<commit_message>
demo-kit: add a Customer Success slide to the Solution Overview deck
New slide 9b "Proven value → a retained, growing relationship" (8-stage
lifecycle, health, renewal/growth, AI EBR, + the CS portfolio lens).
Add CSM to the governance roles slide and a CS line + updated stats to
"what's built". Rebuild .pptx (15 slides) and .pdf.

Co-Authored-By: Claude Opus 4.8 <noreply@anthropic.com>
</commit_message>
<xml_diff>
--- a/demo-kit/ValueLifecycle-Solution-Overview.pptx
+++ b/demo-kit/ValueLifecycle-Solution-Overview.pptx
@@ -19,9 +19,10 @@
     <p:sldId id="267" r:id="rId13"/>
     <p:sldId id="268" r:id="rId14"/>
     <p:sldId id="269" r:id="rId15"/>
+    <p:sldId id="270" r:id="rId16"/>
   </p:sldIdLst>
   <p:notesMasterIdLst>
-    <p:notesMasterId r:id="rId16"/>
+    <p:notesMasterId r:id="rId17"/>
   </p:notesMasterIdLst>
   <p:sldSz cx="12192000" cy="6858000"/>
   <p:notesSz cx="6858000" cy="12192000"/>
@@ -955,7 +956,7 @@
           <a:p>
             <a:r>
               <a:rPr lang="en-US" dirty="0"/>
-              <a:t>Close on the loop: approved value and proven value, joined by a first-class handover. Invite the discussion on where that link is weakest.</a:t>
+              <a:t/>
             </a:r>
             <a:endParaRPr lang="en-US" dirty="0"/>
           </a:p>
@@ -979,6 +980,94 @@
             <a:fld id="{F7021451-1387-4CA6-816F-3879F97B5CBC}" type="slidenum">
               <a:rPr lang="en-US"/>
               <a:t>14</a:t>
+            </a:fld>
+            <a:endParaRPr lang="en-US"/>
+          </a:p>
+        </p:txBody>
+      </p:sp>
+    </p:spTree>
+    <p:extLst>
+      <p:ext uri="{BB962C8B-B14F-4D97-AF65-F5344CB8AC3E}">
+        <p14:creationId xmlns:p14="http://schemas.microsoft.com/office/powerpoint/2010/main" val="1024086991"/>
+      </p:ext>
+    </p:extLst>
+  </p:cSld>
+  <p:clrMapOvr>
+    <a:masterClrMapping/>
+  </p:clrMapOvr>
+</p:notes>
+</file>
+
+<file path=ppt/notesSlides/notesSlide15.xml><?xml version="1.0" encoding="utf-8"?>
+<p:notes xmlns:a="http://schemas.openxmlformats.org/drawingml/2006/main" xmlns:r="http://schemas.openxmlformats.org/officeDocument/2006/relationships" xmlns:p="http://schemas.openxmlformats.org/presentationml/2006/main">
+  <p:cSld>
+    <p:spTree>
+      <p:nvGrpSpPr>
+        <p:cNvPr id="1" name=""/>
+        <p:cNvGrpSpPr/>
+        <p:nvPr/>
+      </p:nvGrpSpPr>
+      <p:grpSpPr>
+        <a:xfrm>
+          <a:off x="0" y="0"/>
+          <a:ext cx="0" cy="0"/>
+          <a:chOff x="0" y="0"/>
+          <a:chExt cx="0" cy="0"/>
+        </a:xfrm>
+      </p:grpSpPr>
+      <p:sp>
+        <p:nvSpPr>
+          <p:cNvPr id="2" name="Slide Image Placeholder 1"/>
+          <p:cNvSpPr>
+            <a:spLocks noGrp="1" noRot="1" noChangeAspect="1"/>
+          </p:cNvSpPr>
+          <p:nvPr>
+            <p:ph type="sldImg"/>
+          </p:nvPr>
+        </p:nvSpPr>
+        <p:spPr/>
+      </p:sp>
+      <p:sp>
+        <p:nvSpPr>
+          <p:cNvPr id="3" name="Notes Placeholder 2"/>
+          <p:cNvSpPr>
+            <a:spLocks noGrp="1"/>
+          </p:cNvSpPr>
+          <p:nvPr>
+            <p:ph type="body" idx="1"/>
+          </p:nvPr>
+        </p:nvSpPr>
+        <p:spPr/>
+        <p:txBody>
+          <a:bodyPr/>
+          <a:lstStyle/>
+          <a:p>
+            <a:r>
+              <a:rPr lang="en-US" dirty="0"/>
+              <a:t>Close on the loop: approved value and proven value, joined by a first-class handover. Invite the discussion on where that link is weakest.</a:t>
+            </a:r>
+            <a:endParaRPr lang="en-US" dirty="0"/>
+          </a:p>
+        </p:txBody>
+      </p:sp>
+      <p:sp>
+        <p:nvSpPr>
+          <p:cNvPr id="4" name="Slide Number Placeholder 3"/>
+          <p:cNvSpPr>
+            <a:spLocks noGrp="1"/>
+          </p:cNvSpPr>
+          <p:nvPr>
+            <p:ph type="sldNum" sz="quarter" idx="10"/>
+          </p:nvPr>
+        </p:nvSpPr>
+        <p:spPr/>
+        <p:txBody>
+          <a:bodyPr/>
+          <a:lstStyle/>
+          <a:p>
+            <a:fld id="{F7021451-1387-4CA6-816F-3879F97B5CBC}" type="slidenum">
+              <a:rPr lang="en-US"/>
+              <a:t>15</a:t>
             </a:fld>
             <a:endParaRPr lang="en-US"/>
           </a:p>
@@ -2300,13 +2389,13 @@
             <a:r>
               <a:rPr lang="en-US" sz="1300" b="1" spc="200" kern="0" dirty="0">
                 <a:solidFill>
-                  <a:srgbClr val="2563EB"/>
+                  <a:srgbClr val="34D399"/>
                 </a:solidFill>
                 <a:latin typeface="Calibri" pitchFamily="34" charset="0"/>
                 <a:ea typeface="Calibri" pitchFamily="34" charset="-122"/>
                 <a:cs typeface="Calibri" pitchFamily="34" charset="-120"/>
               </a:rPr>
-              <a:t>CONFIGURABLE</a:t>
+              <a:t>CUSTOMER SUCCESS</a:t>
             </a:r>
             <a:endParaRPr lang="en-US" sz="1300" dirty="0"/>
           </a:p>
@@ -2345,7 +2434,7 @@
                 <a:ea typeface="Cambria" pitchFamily="34" charset="-122"/>
                 <a:cs typeface="Cambria" pitchFamily="34" charset="-120"/>
               </a:rPr>
-              <a:t>Three industries out of the box — configuration, not code.</a:t>
+              <a:t>Proven value → a retained, growing relationship.</a:t>
             </a:r>
             <a:endParaRPr lang="en-US" sz="3400" dirty="0"/>
           </a:p>
@@ -2353,14 +2442,171 @@
       </p:sp>
       <p:sp>
         <p:nvSpPr>
-          <p:cNvPr id="4" name="Shape 2"/>
-          <p:cNvSpPr/>
-          <p:nvPr/>
-        </p:nvSpPr>
-        <p:spPr>
-          <a:xfrm>
-            <a:off x="640080" y="2377440"/>
-            <a:ext cx="3520440" cy="2651760"/>
+          <p:cNvPr id="4" name="Text 2"/>
+          <p:cNvSpPr/>
+          <p:nvPr/>
+        </p:nvSpPr>
+        <p:spPr>
+          <a:xfrm>
+            <a:off x="640080" y="1965960"/>
+            <a:ext cx="10908792" cy="640080"/>
+          </a:xfrm>
+          <a:prstGeom prst="rect">
+            <a:avLst/>
+          </a:prstGeom>
+          <a:noFill/>
+          <a:ln/>
+        </p:spPr>
+        <p:txBody>
+          <a:bodyPr wrap="square" lIns="0" tIns="0" rIns="0" bIns="0" rtlCol="0" anchor="ctr"/>
+          <a:lstStyle/>
+          <a:p>
+            <a:pPr indent="0" marL="0">
+              <a:lnSpc>
+                <a:spcPct val="115000"/>
+              </a:lnSpc>
+              <a:buNone/>
+            </a:pPr>
+            <a:r>
+              <a:rPr lang="en-US" sz="1500" dirty="0">
+                <a:solidFill>
+                  <a:srgbClr val="64748B"/>
+                </a:solidFill>
+                <a:latin typeface="Calibri" pitchFamily="34" charset="0"/>
+                <a:ea typeface="Calibri" pitchFamily="34" charset="-122"/>
+                <a:cs typeface="Calibri" pitchFamily="34" charset="-120"/>
+              </a:rPr>
+              <a:t>Realization proves one initiative and closes out; Customer Success is the continuous, per-account layer — and it references the account's studies and tracks, it never duplicates their value.</a:t>
+            </a:r>
+            <a:endParaRPr lang="en-US" sz="1500" dirty="0"/>
+          </a:p>
+        </p:txBody>
+      </p:sp>
+      <p:sp>
+        <p:nvSpPr>
+          <p:cNvPr id="5" name="Shape 3"/>
+          <p:cNvSpPr/>
+          <p:nvPr/>
+        </p:nvSpPr>
+        <p:spPr>
+          <a:xfrm>
+            <a:off x="640080" y="2788920"/>
+            <a:ext cx="2651760" cy="2651760"/>
+          </a:xfrm>
+          <a:prstGeom prst="roundRect">
+            <a:avLst>
+              <a:gd name="adj" fmla="val 4138"/>
+            </a:avLst>
+          </a:prstGeom>
+          <a:solidFill>
+            <a:srgbClr val="ECFDF5"/>
+          </a:solidFill>
+          <a:ln w="12700">
+            <a:solidFill>
+              <a:srgbClr val="ECFDF5"/>
+            </a:solidFill>
+            <a:prstDash val="solid"/>
+          </a:ln>
+          <a:effectLst>
+            <a:outerShdw sx="100000" sy="100000" kx="0" ky="0" algn="bl" rotWithShape="0" blurRad="76200" dist="25400" dir="5400000">
+              <a:srgbClr val="0F172A">
+                <a:alpha val="16000"/>
+              </a:srgbClr>
+            </a:outerShdw>
+          </a:effectLst>
+        </p:spPr>
+      </p:sp>
+      <p:sp>
+        <p:nvSpPr>
+          <p:cNvPr id="6" name="Text 4"/>
+          <p:cNvSpPr/>
+          <p:nvPr/>
+        </p:nvSpPr>
+        <p:spPr>
+          <a:xfrm>
+            <a:off x="914400" y="3063240"/>
+            <a:ext cx="2103120" cy="731520"/>
+          </a:xfrm>
+          <a:prstGeom prst="rect">
+            <a:avLst/>
+          </a:prstGeom>
+          <a:noFill/>
+          <a:ln/>
+        </p:spPr>
+        <p:txBody>
+          <a:bodyPr wrap="square" lIns="0" tIns="0" rIns="0" bIns="0" rtlCol="0" anchor="ctr"/>
+          <a:lstStyle/>
+          <a:p>
+            <a:pPr indent="0" marL="0">
+              <a:buNone/>
+            </a:pPr>
+            <a:r>
+              <a:rPr lang="en-US" sz="1600" b="1" dirty="0">
+                <a:solidFill>
+                  <a:srgbClr val="059669"/>
+                </a:solidFill>
+                <a:latin typeface="Cambria" pitchFamily="34" charset="0"/>
+                <a:ea typeface="Cambria" pitchFamily="34" charset="-122"/>
+                <a:cs typeface="Cambria" pitchFamily="34" charset="-120"/>
+              </a:rPr>
+              <a:t>8-stage lifecycle</a:t>
+            </a:r>
+            <a:endParaRPr lang="en-US" sz="1600" dirty="0"/>
+          </a:p>
+        </p:txBody>
+      </p:sp>
+      <p:sp>
+        <p:nvSpPr>
+          <p:cNvPr id="7" name="Text 5"/>
+          <p:cNvSpPr/>
+          <p:nvPr/>
+        </p:nvSpPr>
+        <p:spPr>
+          <a:xfrm>
+            <a:off x="914400" y="3794760"/>
+            <a:ext cx="2103120" cy="1554480"/>
+          </a:xfrm>
+          <a:prstGeom prst="rect">
+            <a:avLst/>
+          </a:prstGeom>
+          <a:noFill/>
+          <a:ln/>
+        </p:spPr>
+        <p:txBody>
+          <a:bodyPr wrap="square" lIns="0" tIns="0" rIns="0" bIns="0" rtlCol="0" anchor="ctr"/>
+          <a:lstStyle/>
+          <a:p>
+            <a:pPr indent="0" marL="0">
+              <a:lnSpc>
+                <a:spcPct val="115000"/>
+              </a:lnSpc>
+              <a:buNone/>
+            </a:pPr>
+            <a:r>
+              <a:rPr lang="en-US" sz="1250" dirty="0">
+                <a:solidFill>
+                  <a:srgbClr val="64748B"/>
+                </a:solidFill>
+                <a:latin typeface="Calibri" pitchFamily="34" charset="0"/>
+                <a:ea typeface="Calibri" pitchFamily="34" charset="-122"/>
+                <a:cs typeface="Calibri" pitchFamily="34" charset="-120"/>
+              </a:rPr>
+              <a:t>Handover → onboarding → adoption → value → health → governance → renewal → expansion.</a:t>
+            </a:r>
+            <a:endParaRPr lang="en-US" sz="1250" dirty="0"/>
+          </a:p>
+        </p:txBody>
+      </p:sp>
+      <p:sp>
+        <p:nvSpPr>
+          <p:cNvPr id="8" name="Shape 6"/>
+          <p:cNvSpPr/>
+          <p:nvPr/>
+        </p:nvSpPr>
+        <p:spPr>
+          <a:xfrm>
+            <a:off x="3392424" y="2788920"/>
+            <a:ext cx="2651760" cy="2651760"/>
           </a:xfrm>
           <a:prstGeom prst="roundRect">
             <a:avLst>
@@ -2387,30 +2633,30 @@
       </p:sp>
       <p:sp>
         <p:nvSpPr>
-          <p:cNvPr id="5" name="Text 3"/>
-          <p:cNvSpPr/>
-          <p:nvPr/>
-        </p:nvSpPr>
-        <p:spPr>
-          <a:xfrm>
-            <a:off x="960120" y="2697480"/>
-            <a:ext cx="2880360" cy="822960"/>
-          </a:xfrm>
-          <a:prstGeom prst="rect">
-            <a:avLst/>
-          </a:prstGeom>
-          <a:noFill/>
-          <a:ln/>
-        </p:spPr>
-        <p:txBody>
-          <a:bodyPr wrap="square" lIns="0" tIns="0" rIns="0" bIns="0" rtlCol="0" anchor="ctr"/>
-          <a:lstStyle/>
-          <a:p>
-            <a:pPr indent="0" marL="0">
-              <a:buNone/>
-            </a:pPr>
-            <a:r>
-              <a:rPr lang="en-US" sz="1700" b="1" dirty="0">
+          <p:cNvPr id="9" name="Text 7"/>
+          <p:cNvSpPr/>
+          <p:nvPr/>
+        </p:nvSpPr>
+        <p:spPr>
+          <a:xfrm>
+            <a:off x="3666744" y="3063240"/>
+            <a:ext cx="2103120" cy="731520"/>
+          </a:xfrm>
+          <a:prstGeom prst="rect">
+            <a:avLst/>
+          </a:prstGeom>
+          <a:noFill/>
+          <a:ln/>
+        </p:spPr>
+        <p:txBody>
+          <a:bodyPr wrap="square" lIns="0" tIns="0" rIns="0" bIns="0" rtlCol="0" anchor="ctr"/>
+          <a:lstStyle/>
+          <a:p>
+            <a:pPr indent="0" marL="0">
+              <a:buNone/>
+            </a:pPr>
+            <a:r>
+              <a:rPr lang="en-US" sz="1600" b="1" dirty="0">
                 <a:solidFill>
                   <a:srgbClr val="2563EB"/>
                 </a:solidFill>
@@ -2418,22 +2664,22 @@
                 <a:ea typeface="Cambria" pitchFamily="34" charset="-122"/>
                 <a:cs typeface="Cambria" pitchFamily="34" charset="-120"/>
               </a:rPr>
-              <a:t>Construction &amp; Infrastructure</a:t>
-            </a:r>
-            <a:endParaRPr lang="en-US" sz="1700" dirty="0"/>
-          </a:p>
-        </p:txBody>
-      </p:sp>
-      <p:sp>
-        <p:nvSpPr>
-          <p:cNvPr id="6" name="Text 4"/>
-          <p:cNvSpPr/>
-          <p:nvPr/>
-        </p:nvSpPr>
-        <p:spPr>
-          <a:xfrm>
-            <a:off x="960120" y="3611880"/>
-            <a:ext cx="2880360" cy="1280160"/>
+              <a:t>Health, proactively</a:t>
+            </a:r>
+            <a:endParaRPr lang="en-US" sz="1600" dirty="0"/>
+          </a:p>
+        </p:txBody>
+      </p:sp>
+      <p:sp>
+        <p:nvSpPr>
+          <p:cNvPr id="10" name="Text 8"/>
+          <p:cNvSpPr/>
+          <p:nvPr/>
+        </p:nvSpPr>
+        <p:spPr>
+          <a:xfrm>
+            <a:off x="3666744" y="3794760"/>
+            <a:ext cx="2103120" cy="1554480"/>
           </a:xfrm>
           <a:prstGeom prst="rect">
             <a:avLst/>
@@ -2447,35 +2693,150 @@
           <a:p>
             <a:pPr indent="0" marL="0">
               <a:lnSpc>
-                <a:spcPct val="120000"/>
+                <a:spcPct val="115000"/>
               </a:lnSpc>
               <a:buNone/>
             </a:pPr>
             <a:r>
-              <a:rPr lang="en-US" sz="1450" dirty="0">
-                <a:solidFill>
-                  <a:srgbClr val="0F172A"/>
+              <a:rPr lang="en-US" sz="1250" dirty="0">
+                <a:solidFill>
+                  <a:srgbClr val="64748B"/>
                 </a:solidFill>
                 <a:latin typeface="Calibri" pitchFamily="34" charset="0"/>
                 <a:ea typeface="Calibri" pitchFamily="34" charset="-122"/>
                 <a:cs typeface="Calibri" pitchFamily="34" charset="-120"/>
               </a:rPr>
-              <a:t>Capital projects, life-cycle cost, buildability — value engineering's home turf.</a:t>
-            </a:r>
-            <a:endParaRPr lang="en-US" sz="1450" dirty="0"/>
-          </a:p>
-        </p:txBody>
-      </p:sp>
-      <p:sp>
-        <p:nvSpPr>
-          <p:cNvPr id="7" name="Shape 5"/>
-          <p:cNvSpPr/>
-          <p:nvPr/>
-        </p:nvSpPr>
-        <p:spPr>
-          <a:xfrm>
-            <a:off x="4334256" y="2377440"/>
-            <a:ext cx="3520440" cy="2651760"/>
+              <a:t>A weighted scorecard rolls up to a RAG band; attention signals flag renewals, risk and detractors.</a:t>
+            </a:r>
+            <a:endParaRPr lang="en-US" sz="1250" dirty="0"/>
+          </a:p>
+        </p:txBody>
+      </p:sp>
+      <p:sp>
+        <p:nvSpPr>
+          <p:cNvPr id="11" name="Shape 9"/>
+          <p:cNvSpPr/>
+          <p:nvPr/>
+        </p:nvSpPr>
+        <p:spPr>
+          <a:xfrm>
+            <a:off x="6144768" y="2788920"/>
+            <a:ext cx="2651760" cy="2651760"/>
+          </a:xfrm>
+          <a:prstGeom prst="roundRect">
+            <a:avLst>
+              <a:gd name="adj" fmla="val 4138"/>
+            </a:avLst>
+          </a:prstGeom>
+          <a:solidFill>
+            <a:srgbClr val="ECFDF5"/>
+          </a:solidFill>
+          <a:ln w="12700">
+            <a:solidFill>
+              <a:srgbClr val="ECFDF5"/>
+            </a:solidFill>
+            <a:prstDash val="solid"/>
+          </a:ln>
+          <a:effectLst>
+            <a:outerShdw sx="100000" sy="100000" kx="0" ky="0" algn="bl" rotWithShape="0" blurRad="76200" dist="25400" dir="5400000">
+              <a:srgbClr val="0F172A">
+                <a:alpha val="16000"/>
+              </a:srgbClr>
+            </a:outerShdw>
+          </a:effectLst>
+        </p:spPr>
+      </p:sp>
+      <p:sp>
+        <p:nvSpPr>
+          <p:cNvPr id="12" name="Text 10"/>
+          <p:cNvSpPr/>
+          <p:nvPr/>
+        </p:nvSpPr>
+        <p:spPr>
+          <a:xfrm>
+            <a:off x="6419088" y="3063240"/>
+            <a:ext cx="2103120" cy="731520"/>
+          </a:xfrm>
+          <a:prstGeom prst="rect">
+            <a:avLst/>
+          </a:prstGeom>
+          <a:noFill/>
+          <a:ln/>
+        </p:spPr>
+        <p:txBody>
+          <a:bodyPr wrap="square" lIns="0" tIns="0" rIns="0" bIns="0" rtlCol="0" anchor="ctr"/>
+          <a:lstStyle/>
+          <a:p>
+            <a:pPr indent="0" marL="0">
+              <a:buNone/>
+            </a:pPr>
+            <a:r>
+              <a:rPr lang="en-US" sz="1600" b="1" dirty="0">
+                <a:solidFill>
+                  <a:srgbClr val="059669"/>
+                </a:solidFill>
+                <a:latin typeface="Cambria" pitchFamily="34" charset="0"/>
+                <a:ea typeface="Cambria" pitchFamily="34" charset="-122"/>
+                <a:cs typeface="Cambria" pitchFamily="34" charset="-120"/>
+              </a:rPr>
+              <a:t>Renewal &amp; growth</a:t>
+            </a:r>
+            <a:endParaRPr lang="en-US" sz="1600" dirty="0"/>
+          </a:p>
+        </p:txBody>
+      </p:sp>
+      <p:sp>
+        <p:nvSpPr>
+          <p:cNvPr id="13" name="Text 11"/>
+          <p:cNvSpPr/>
+          <p:nvPr/>
+        </p:nvSpPr>
+        <p:spPr>
+          <a:xfrm>
+            <a:off x="6419088" y="3794760"/>
+            <a:ext cx="2103120" cy="1554480"/>
+          </a:xfrm>
+          <a:prstGeom prst="rect">
+            <a:avLst/>
+          </a:prstGeom>
+          <a:noFill/>
+          <a:ln/>
+        </p:spPr>
+        <p:txBody>
+          <a:bodyPr wrap="square" lIns="0" tIns="0" rIns="0" bIns="0" rtlCol="0" anchor="ctr"/>
+          <a:lstStyle/>
+          <a:p>
+            <a:pPr indent="0" marL="0">
+              <a:lnSpc>
+                <a:spcPct val="115000"/>
+              </a:lnSpc>
+              <a:buNone/>
+            </a:pPr>
+            <a:r>
+              <a:rPr lang="en-US" sz="1250" dirty="0">
+                <a:solidFill>
+                  <a:srgbClr val="64748B"/>
+                </a:solidFill>
+                <a:latin typeface="Calibri" pitchFamily="34" charset="0"/>
+                <a:ea typeface="Calibri" pitchFamily="34" charset="-122"/>
+                <a:cs typeface="Calibri" pitchFamily="34" charset="-120"/>
+              </a:rPr>
+              <a:t>Stakeholder map, action log, renewal and growth plans — renewal becomes a non-event.</a:t>
+            </a:r>
+            <a:endParaRPr lang="en-US" sz="1250" dirty="0"/>
+          </a:p>
+        </p:txBody>
+      </p:sp>
+      <p:sp>
+        <p:nvSpPr>
+          <p:cNvPr id="14" name="Shape 12"/>
+          <p:cNvSpPr/>
+          <p:nvPr/>
+        </p:nvSpPr>
+        <p:spPr>
+          <a:xfrm>
+            <a:off x="8897112" y="2788920"/>
+            <a:ext cx="2651760" cy="2651760"/>
           </a:xfrm>
           <a:prstGeom prst="roundRect">
             <a:avLst>
@@ -2502,30 +2863,30 @@
       </p:sp>
       <p:sp>
         <p:nvSpPr>
-          <p:cNvPr id="8" name="Text 6"/>
-          <p:cNvSpPr/>
-          <p:nvPr/>
-        </p:nvSpPr>
-        <p:spPr>
-          <a:xfrm>
-            <a:off x="4654296" y="2697480"/>
-            <a:ext cx="2880360" cy="822960"/>
-          </a:xfrm>
-          <a:prstGeom prst="rect">
-            <a:avLst/>
-          </a:prstGeom>
-          <a:noFill/>
-          <a:ln/>
-        </p:spPr>
-        <p:txBody>
-          <a:bodyPr wrap="square" lIns="0" tIns="0" rIns="0" bIns="0" rtlCol="0" anchor="ctr"/>
-          <a:lstStyle/>
-          <a:p>
-            <a:pPr indent="0" marL="0">
-              <a:buNone/>
-            </a:pPr>
-            <a:r>
-              <a:rPr lang="en-US" sz="1700" b="1" dirty="0">
+          <p:cNvPr id="15" name="Text 13"/>
+          <p:cNvSpPr/>
+          <p:nvPr/>
+        </p:nvSpPr>
+        <p:spPr>
+          <a:xfrm>
+            <a:off x="9171432" y="3063240"/>
+            <a:ext cx="2103120" cy="731520"/>
+          </a:xfrm>
+          <a:prstGeom prst="rect">
+            <a:avLst/>
+          </a:prstGeom>
+          <a:noFill/>
+          <a:ln/>
+        </p:spPr>
+        <p:txBody>
+          <a:bodyPr wrap="square" lIns="0" tIns="0" rIns="0" bIns="0" rtlCol="0" anchor="ctr"/>
+          <a:lstStyle/>
+          <a:p>
+            <a:pPr indent="0" marL="0">
+              <a:buNone/>
+            </a:pPr>
+            <a:r>
+              <a:rPr lang="en-US" sz="1600" b="1" dirty="0">
                 <a:solidFill>
                   <a:srgbClr val="2563EB"/>
                 </a:solidFill>
@@ -2533,22 +2894,22 @@
                 <a:ea typeface="Cambria" pitchFamily="34" charset="-122"/>
                 <a:cs typeface="Cambria" pitchFamily="34" charset="-120"/>
               </a:rPr>
-              <a:t>Manufacturing &amp; Product Dev</a:t>
-            </a:r>
-            <a:endParaRPr lang="en-US" sz="1700" dirty="0"/>
-          </a:p>
-        </p:txBody>
-      </p:sp>
-      <p:sp>
-        <p:nvSpPr>
-          <p:cNvPr id="9" name="Text 7"/>
-          <p:cNvSpPr/>
-          <p:nvPr/>
-        </p:nvSpPr>
-        <p:spPr>
-          <a:xfrm>
-            <a:off x="4654296" y="3611880"/>
-            <a:ext cx="2880360" cy="1280160"/>
+              <a:t>AI-assisted EBR</a:t>
+            </a:r>
+            <a:endParaRPr lang="en-US" sz="1600" dirty="0"/>
+          </a:p>
+        </p:txBody>
+      </p:sp>
+      <p:sp>
+        <p:nvSpPr>
+          <p:cNvPr id="16" name="Text 14"/>
+          <p:cNvSpPr/>
+          <p:nvPr/>
+        </p:nvSpPr>
+        <p:spPr>
+          <a:xfrm>
+            <a:off x="9171432" y="3794760"/>
+            <a:ext cx="2103120" cy="1554480"/>
           </a:xfrm>
           <a:prstGeom prst="rect">
             <a:avLst/>
@@ -2562,34 +2923,183 @@
           <a:p>
             <a:pPr indent="0" marL="0">
               <a:lnSpc>
-                <a:spcPct val="120000"/>
+                <a:spcPct val="115000"/>
               </a:lnSpc>
               <a:buNone/>
             </a:pPr>
             <a:r>
-              <a:rPr lang="en-US" sz="1450" dirty="0">
-                <a:solidFill>
-                  <a:srgbClr val="0F172A"/>
+              <a:rPr lang="en-US" sz="1250" dirty="0">
+                <a:solidFill>
+                  <a:srgbClr val="64748B"/>
                 </a:solidFill>
                 <a:latin typeface="Calibri" pitchFamily="34" charset="0"/>
                 <a:ea typeface="Calibri" pitchFamily="34" charset="-122"/>
                 <a:cs typeface="Calibri" pitchFamily="34" charset="-120"/>
               </a:rPr>
-              <a:t>Should-cost, DFMA, tooling and unit-cost levers across a product line.</a:t>
-            </a:r>
-            <a:endParaRPr lang="en-US" sz="1450" dirty="0"/>
-          </a:p>
-        </p:txBody>
-      </p:sp>
-      <p:sp>
-        <p:nvSpPr>
-          <p:cNvPr id="10" name="Shape 8"/>
-          <p:cNvSpPr/>
-          <p:nvPr/>
-        </p:nvSpPr>
-        <p:spPr>
-          <a:xfrm>
-            <a:off x="8028432" y="2377440"/>
+              <a:t>Generate an executive review from the account's own data; export an Account Success Review.</a:t>
+            </a:r>
+            <a:endParaRPr lang="en-US" sz="1250" dirty="0"/>
+          </a:p>
+        </p:txBody>
+      </p:sp>
+      <p:sp>
+        <p:nvSpPr>
+          <p:cNvPr id="17" name="Text 15"/>
+          <p:cNvSpPr/>
+          <p:nvPr/>
+        </p:nvSpPr>
+        <p:spPr>
+          <a:xfrm>
+            <a:off x="640080" y="5669280"/>
+            <a:ext cx="10908792" cy="457200"/>
+          </a:xfrm>
+          <a:prstGeom prst="rect">
+            <a:avLst/>
+          </a:prstGeom>
+          <a:noFill/>
+          <a:ln/>
+        </p:spPr>
+        <p:txBody>
+          <a:bodyPr wrap="square" lIns="0" tIns="0" rIns="0" bIns="0" rtlCol="0" anchor="ctr"/>
+          <a:lstStyle/>
+          <a:p>
+            <a:pPr algn="ctr" indent="0" marL="0">
+              <a:buNone/>
+            </a:pPr>
+            <a:r>
+              <a:rPr lang="en-US" sz="1300" i="1" dirty="0">
+                <a:solidFill>
+                  <a:srgbClr val="64748B"/>
+                </a:solidFill>
+                <a:latin typeface="Calibri" pitchFamily="34" charset="0"/>
+                <a:ea typeface="Calibri" pitchFamily="34" charset="-122"/>
+                <a:cs typeface="Calibri" pitchFamily="34" charset="-120"/>
+              </a:rPr>
+              <a:t>The portfolio gains a Customer Success lens — engagement health, upcoming renewals and accounts needing attention.</a:t>
+            </a:r>
+            <a:endParaRPr lang="en-US" sz="1300" dirty="0"/>
+          </a:p>
+        </p:txBody>
+      </p:sp>
+    </p:spTree>
+  </p:cSld>
+  <p:clrMapOvr>
+    <a:masterClrMapping/>
+  </p:clrMapOvr>
+</p:sld>
+</file>
+
+<file path=ppt/slides/slide11.xml><?xml version="1.0" encoding="utf-8"?>
+<p:sld xmlns:a="http://schemas.openxmlformats.org/drawingml/2006/main" xmlns:r="http://schemas.openxmlformats.org/officeDocument/2006/relationships" xmlns:p="http://schemas.openxmlformats.org/presentationml/2006/main">
+  <p:cSld name="Slide 11">
+    <p:bg>
+      <p:bgPr>
+        <a:solidFill>
+          <a:srgbClr val="FFFFFF"/>
+        </a:solidFill>
+      </p:bgPr>
+    </p:bg>
+    <p:spTree>
+      <p:nvGrpSpPr>
+        <p:cNvPr id="1" name=""/>
+        <p:cNvGrpSpPr/>
+        <p:nvPr/>
+      </p:nvGrpSpPr>
+      <p:grpSpPr>
+        <a:xfrm>
+          <a:off x="0" y="0"/>
+          <a:ext cx="0" cy="0"/>
+          <a:chOff x="0" y="0"/>
+          <a:chExt cx="0" cy="0"/>
+        </a:xfrm>
+      </p:grpSpPr>
+      <p:sp>
+        <p:nvSpPr>
+          <p:cNvPr id="2" name="Text 0"/>
+          <p:cNvSpPr/>
+          <p:nvPr/>
+        </p:nvSpPr>
+        <p:spPr>
+          <a:xfrm>
+            <a:off x="640080" y="502920"/>
+            <a:ext cx="10908792" cy="274320"/>
+          </a:xfrm>
+          <a:prstGeom prst="rect">
+            <a:avLst/>
+          </a:prstGeom>
+          <a:noFill/>
+          <a:ln/>
+        </p:spPr>
+        <p:txBody>
+          <a:bodyPr wrap="square" lIns="0" tIns="0" rIns="0" bIns="0" rtlCol="0" anchor="ctr"/>
+          <a:lstStyle/>
+          <a:p>
+            <a:pPr indent="0" marL="0">
+              <a:buNone/>
+            </a:pPr>
+            <a:r>
+              <a:rPr lang="en-US" sz="1300" b="1" spc="200" kern="0" dirty="0">
+                <a:solidFill>
+                  <a:srgbClr val="2563EB"/>
+                </a:solidFill>
+                <a:latin typeface="Calibri" pitchFamily="34" charset="0"/>
+                <a:ea typeface="Calibri" pitchFamily="34" charset="-122"/>
+                <a:cs typeface="Calibri" pitchFamily="34" charset="-120"/>
+              </a:rPr>
+              <a:t>CONFIGURABLE</a:t>
+            </a:r>
+            <a:endParaRPr lang="en-US" sz="1300" dirty="0"/>
+          </a:p>
+        </p:txBody>
+      </p:sp>
+      <p:sp>
+        <p:nvSpPr>
+          <p:cNvPr id="3" name="Text 1"/>
+          <p:cNvSpPr/>
+          <p:nvPr/>
+        </p:nvSpPr>
+        <p:spPr>
+          <a:xfrm>
+            <a:off x="640080" y="822960"/>
+            <a:ext cx="10908792" cy="1005840"/>
+          </a:xfrm>
+          <a:prstGeom prst="rect">
+            <a:avLst/>
+          </a:prstGeom>
+          <a:noFill/>
+          <a:ln/>
+        </p:spPr>
+        <p:txBody>
+          <a:bodyPr wrap="square" lIns="0" tIns="0" rIns="0" bIns="0" rtlCol="0" anchor="t"/>
+          <a:lstStyle/>
+          <a:p>
+            <a:pPr indent="0" marL="0">
+              <a:buNone/>
+            </a:pPr>
+            <a:r>
+              <a:rPr lang="en-US" sz="3400" b="1" dirty="0">
+                <a:solidFill>
+                  <a:srgbClr val="0F172A"/>
+                </a:solidFill>
+                <a:latin typeface="Cambria" pitchFamily="34" charset="0"/>
+                <a:ea typeface="Cambria" pitchFamily="34" charset="-122"/>
+                <a:cs typeface="Cambria" pitchFamily="34" charset="-120"/>
+              </a:rPr>
+              <a:t>Three industries out of the box — configuration, not code.</a:t>
+            </a:r>
+            <a:endParaRPr lang="en-US" sz="3400" dirty="0"/>
+          </a:p>
+        </p:txBody>
+      </p:sp>
+      <p:sp>
+        <p:nvSpPr>
+          <p:cNvPr id="4" name="Shape 2"/>
+          <p:cNvSpPr/>
+          <p:nvPr/>
+        </p:nvSpPr>
+        <p:spPr>
+          <a:xfrm>
+            <a:off x="640080" y="2377440"/>
             <a:ext cx="3520440" cy="2651760"/>
           </a:xfrm>
           <a:prstGeom prst="roundRect">
@@ -2617,6 +3127,236 @@
       </p:sp>
       <p:sp>
         <p:nvSpPr>
+          <p:cNvPr id="5" name="Text 3"/>
+          <p:cNvSpPr/>
+          <p:nvPr/>
+        </p:nvSpPr>
+        <p:spPr>
+          <a:xfrm>
+            <a:off x="960120" y="2697480"/>
+            <a:ext cx="2880360" cy="822960"/>
+          </a:xfrm>
+          <a:prstGeom prst="rect">
+            <a:avLst/>
+          </a:prstGeom>
+          <a:noFill/>
+          <a:ln/>
+        </p:spPr>
+        <p:txBody>
+          <a:bodyPr wrap="square" lIns="0" tIns="0" rIns="0" bIns="0" rtlCol="0" anchor="ctr"/>
+          <a:lstStyle/>
+          <a:p>
+            <a:pPr indent="0" marL="0">
+              <a:buNone/>
+            </a:pPr>
+            <a:r>
+              <a:rPr lang="en-US" sz="1700" b="1" dirty="0">
+                <a:solidFill>
+                  <a:srgbClr val="2563EB"/>
+                </a:solidFill>
+                <a:latin typeface="Cambria" pitchFamily="34" charset="0"/>
+                <a:ea typeface="Cambria" pitchFamily="34" charset="-122"/>
+                <a:cs typeface="Cambria" pitchFamily="34" charset="-120"/>
+              </a:rPr>
+              <a:t>Construction &amp; Infrastructure</a:t>
+            </a:r>
+            <a:endParaRPr lang="en-US" sz="1700" dirty="0"/>
+          </a:p>
+        </p:txBody>
+      </p:sp>
+      <p:sp>
+        <p:nvSpPr>
+          <p:cNvPr id="6" name="Text 4"/>
+          <p:cNvSpPr/>
+          <p:nvPr/>
+        </p:nvSpPr>
+        <p:spPr>
+          <a:xfrm>
+            <a:off x="960120" y="3611880"/>
+            <a:ext cx="2880360" cy="1280160"/>
+          </a:xfrm>
+          <a:prstGeom prst="rect">
+            <a:avLst/>
+          </a:prstGeom>
+          <a:noFill/>
+          <a:ln/>
+        </p:spPr>
+        <p:txBody>
+          <a:bodyPr wrap="square" lIns="0" tIns="0" rIns="0" bIns="0" rtlCol="0" anchor="ctr"/>
+          <a:lstStyle/>
+          <a:p>
+            <a:pPr indent="0" marL="0">
+              <a:lnSpc>
+                <a:spcPct val="120000"/>
+              </a:lnSpc>
+              <a:buNone/>
+            </a:pPr>
+            <a:r>
+              <a:rPr lang="en-US" sz="1450" dirty="0">
+                <a:solidFill>
+                  <a:srgbClr val="0F172A"/>
+                </a:solidFill>
+                <a:latin typeface="Calibri" pitchFamily="34" charset="0"/>
+                <a:ea typeface="Calibri" pitchFamily="34" charset="-122"/>
+                <a:cs typeface="Calibri" pitchFamily="34" charset="-120"/>
+              </a:rPr>
+              <a:t>Capital projects, life-cycle cost, buildability — value engineering's home turf.</a:t>
+            </a:r>
+            <a:endParaRPr lang="en-US" sz="1450" dirty="0"/>
+          </a:p>
+        </p:txBody>
+      </p:sp>
+      <p:sp>
+        <p:nvSpPr>
+          <p:cNvPr id="7" name="Shape 5"/>
+          <p:cNvSpPr/>
+          <p:nvPr/>
+        </p:nvSpPr>
+        <p:spPr>
+          <a:xfrm>
+            <a:off x="4334256" y="2377440"/>
+            <a:ext cx="3520440" cy="2651760"/>
+          </a:xfrm>
+          <a:prstGeom prst="roundRect">
+            <a:avLst>
+              <a:gd name="adj" fmla="val 4138"/>
+            </a:avLst>
+          </a:prstGeom>
+          <a:solidFill>
+            <a:srgbClr val="EFF6FF"/>
+          </a:solidFill>
+          <a:ln w="12700">
+            <a:solidFill>
+              <a:srgbClr val="EFF6FF"/>
+            </a:solidFill>
+            <a:prstDash val="solid"/>
+          </a:ln>
+          <a:effectLst>
+            <a:outerShdw sx="100000" sy="100000" kx="0" ky="0" algn="bl" rotWithShape="0" blurRad="76200" dist="25400" dir="5400000">
+              <a:srgbClr val="0F172A">
+                <a:alpha val="16000"/>
+              </a:srgbClr>
+            </a:outerShdw>
+          </a:effectLst>
+        </p:spPr>
+      </p:sp>
+      <p:sp>
+        <p:nvSpPr>
+          <p:cNvPr id="8" name="Text 6"/>
+          <p:cNvSpPr/>
+          <p:nvPr/>
+        </p:nvSpPr>
+        <p:spPr>
+          <a:xfrm>
+            <a:off x="4654296" y="2697480"/>
+            <a:ext cx="2880360" cy="822960"/>
+          </a:xfrm>
+          <a:prstGeom prst="rect">
+            <a:avLst/>
+          </a:prstGeom>
+          <a:noFill/>
+          <a:ln/>
+        </p:spPr>
+        <p:txBody>
+          <a:bodyPr wrap="square" lIns="0" tIns="0" rIns="0" bIns="0" rtlCol="0" anchor="ctr"/>
+          <a:lstStyle/>
+          <a:p>
+            <a:pPr indent="0" marL="0">
+              <a:buNone/>
+            </a:pPr>
+            <a:r>
+              <a:rPr lang="en-US" sz="1700" b="1" dirty="0">
+                <a:solidFill>
+                  <a:srgbClr val="2563EB"/>
+                </a:solidFill>
+                <a:latin typeface="Cambria" pitchFamily="34" charset="0"/>
+                <a:ea typeface="Cambria" pitchFamily="34" charset="-122"/>
+                <a:cs typeface="Cambria" pitchFamily="34" charset="-120"/>
+              </a:rPr>
+              <a:t>Manufacturing &amp; Product Dev</a:t>
+            </a:r>
+            <a:endParaRPr lang="en-US" sz="1700" dirty="0"/>
+          </a:p>
+        </p:txBody>
+      </p:sp>
+      <p:sp>
+        <p:nvSpPr>
+          <p:cNvPr id="9" name="Text 7"/>
+          <p:cNvSpPr/>
+          <p:nvPr/>
+        </p:nvSpPr>
+        <p:spPr>
+          <a:xfrm>
+            <a:off x="4654296" y="3611880"/>
+            <a:ext cx="2880360" cy="1280160"/>
+          </a:xfrm>
+          <a:prstGeom prst="rect">
+            <a:avLst/>
+          </a:prstGeom>
+          <a:noFill/>
+          <a:ln/>
+        </p:spPr>
+        <p:txBody>
+          <a:bodyPr wrap="square" lIns="0" tIns="0" rIns="0" bIns="0" rtlCol="0" anchor="ctr"/>
+          <a:lstStyle/>
+          <a:p>
+            <a:pPr indent="0" marL="0">
+              <a:lnSpc>
+                <a:spcPct val="120000"/>
+              </a:lnSpc>
+              <a:buNone/>
+            </a:pPr>
+            <a:r>
+              <a:rPr lang="en-US" sz="1450" dirty="0">
+                <a:solidFill>
+                  <a:srgbClr val="0F172A"/>
+                </a:solidFill>
+                <a:latin typeface="Calibri" pitchFamily="34" charset="0"/>
+                <a:ea typeface="Calibri" pitchFamily="34" charset="-122"/>
+                <a:cs typeface="Calibri" pitchFamily="34" charset="-120"/>
+              </a:rPr>
+              <a:t>Should-cost, DFMA, tooling and unit-cost levers across a product line.</a:t>
+            </a:r>
+            <a:endParaRPr lang="en-US" sz="1450" dirty="0"/>
+          </a:p>
+        </p:txBody>
+      </p:sp>
+      <p:sp>
+        <p:nvSpPr>
+          <p:cNvPr id="10" name="Shape 8"/>
+          <p:cNvSpPr/>
+          <p:nvPr/>
+        </p:nvSpPr>
+        <p:spPr>
+          <a:xfrm>
+            <a:off x="8028432" y="2377440"/>
+            <a:ext cx="3520440" cy="2651760"/>
+          </a:xfrm>
+          <a:prstGeom prst="roundRect">
+            <a:avLst>
+              <a:gd name="adj" fmla="val 4138"/>
+            </a:avLst>
+          </a:prstGeom>
+          <a:solidFill>
+            <a:srgbClr val="EFF6FF"/>
+          </a:solidFill>
+          <a:ln w="12700">
+            <a:solidFill>
+              <a:srgbClr val="EFF6FF"/>
+            </a:solidFill>
+            <a:prstDash val="solid"/>
+          </a:ln>
+          <a:effectLst>
+            <a:outerShdw sx="100000" sy="100000" kx="0" ky="0" algn="bl" rotWithShape="0" blurRad="76200" dist="25400" dir="5400000">
+              <a:srgbClr val="0F172A">
+                <a:alpha val="16000"/>
+              </a:srgbClr>
+            </a:outerShdw>
+          </a:effectLst>
+        </p:spPr>
+      </p:sp>
+      <p:sp>
+        <p:nvSpPr>
           <p:cNvPr id="11" name="Text 9"/>
           <p:cNvSpPr/>
           <p:nvPr/>
@@ -2743,9 +3483,9 @@
 </p:sld>
 </file>
 
-<file path=ppt/slides/slide11.xml><?xml version="1.0" encoding="utf-8"?>
+<file path=ppt/slides/slide12.xml><?xml version="1.0" encoding="utf-8"?>
 <p:sld xmlns:a="http://schemas.openxmlformats.org/drawingml/2006/main" xmlns:r="http://schemas.openxmlformats.org/officeDocument/2006/relationships" xmlns:p="http://schemas.openxmlformats.org/presentationml/2006/main">
-  <p:cSld name="Slide 11">
+  <p:cSld name="Slide 12">
     <p:bg>
       <p:bgPr>
         <a:solidFill>
@@ -2947,7 +3687,7 @@
                 <a:ea typeface="Calibri" pitchFamily="34" charset="-122"/>
                 <a:cs typeface="Calibri" pitchFamily="34" charset="-120"/>
               </a:rPr>
-              <a:t>Value Engineer, Realization Manager, Reviewer, Viewer, Admin — capabilities enforced on the server, not just hidden in the UI.</a:t>
+              <a:t>Value Engineer, Realization Manager, Customer Success Manager, Reviewer, Viewer, Admin — capabilities enforced on the server, not just hidden in the UI.</a:t>
             </a:r>
             <a:endParaRPr lang="en-US" sz="1500" dirty="0"/>
           </a:p>
@@ -3166,730 +3906,6 @@
               <a:t>Self-serve workspaces isolated by organisation; version history and an audit log keep every number defensible.</a:t>
             </a:r>
             <a:endParaRPr lang="en-US" sz="1500" dirty="0"/>
-          </a:p>
-        </p:txBody>
-      </p:sp>
-    </p:spTree>
-  </p:cSld>
-  <p:clrMapOvr>
-    <a:masterClrMapping/>
-  </p:clrMapOvr>
-</p:sld>
-</file>
-
-<file path=ppt/slides/slide12.xml><?xml version="1.0" encoding="utf-8"?>
-<p:sld xmlns:a="http://schemas.openxmlformats.org/drawingml/2006/main" xmlns:r="http://schemas.openxmlformats.org/officeDocument/2006/relationships" xmlns:p="http://schemas.openxmlformats.org/presentationml/2006/main">
-  <p:cSld name="Slide 12">
-    <p:bg>
-      <p:bgPr>
-        <a:solidFill>
-          <a:srgbClr val="FFFFFF"/>
-        </a:solidFill>
-      </p:bgPr>
-    </p:bg>
-    <p:spTree>
-      <p:nvGrpSpPr>
-        <p:cNvPr id="1" name=""/>
-        <p:cNvGrpSpPr/>
-        <p:nvPr/>
-      </p:nvGrpSpPr>
-      <p:grpSpPr>
-        <a:xfrm>
-          <a:off x="0" y="0"/>
-          <a:ext cx="0" cy="0"/>
-          <a:chOff x="0" y="0"/>
-          <a:chExt cx="0" cy="0"/>
-        </a:xfrm>
-      </p:grpSpPr>
-      <p:sp>
-        <p:nvSpPr>
-          <p:cNvPr id="2" name="Text 0"/>
-          <p:cNvSpPr/>
-          <p:nvPr/>
-        </p:nvSpPr>
-        <p:spPr>
-          <a:xfrm>
-            <a:off x="640080" y="502920"/>
-            <a:ext cx="10908792" cy="274320"/>
-          </a:xfrm>
-          <a:prstGeom prst="rect">
-            <a:avLst/>
-          </a:prstGeom>
-          <a:noFill/>
-          <a:ln/>
-        </p:spPr>
-        <p:txBody>
-          <a:bodyPr wrap="square" lIns="0" tIns="0" rIns="0" bIns="0" rtlCol="0" anchor="ctr"/>
-          <a:lstStyle/>
-          <a:p>
-            <a:pPr indent="0" marL="0">
-              <a:buNone/>
-            </a:pPr>
-            <a:r>
-              <a:rPr lang="en-US" sz="1300" b="1" spc="200" kern="0" dirty="0">
-                <a:solidFill>
-                  <a:srgbClr val="2563EB"/>
-                </a:solidFill>
-                <a:latin typeface="Calibri" pitchFamily="34" charset="0"/>
-                <a:ea typeface="Calibri" pitchFamily="34" charset="-122"/>
-                <a:cs typeface="Calibri" pitchFamily="34" charset="-120"/>
-              </a:rPr>
-              <a:t>THE PLATFORM</a:t>
-            </a:r>
-            <a:endParaRPr lang="en-US" sz="1300" dirty="0"/>
-          </a:p>
-        </p:txBody>
-      </p:sp>
-      <p:sp>
-        <p:nvSpPr>
-          <p:cNvPr id="3" name="Text 1"/>
-          <p:cNvSpPr/>
-          <p:nvPr/>
-        </p:nvSpPr>
-        <p:spPr>
-          <a:xfrm>
-            <a:off x="640080" y="822960"/>
-            <a:ext cx="10908792" cy="1005840"/>
-          </a:xfrm>
-          <a:prstGeom prst="rect">
-            <a:avLst/>
-          </a:prstGeom>
-          <a:noFill/>
-          <a:ln/>
-        </p:spPr>
-        <p:txBody>
-          <a:bodyPr wrap="square" lIns="0" tIns="0" rIns="0" bIns="0" rtlCol="0" anchor="t"/>
-          <a:lstStyle/>
-          <a:p>
-            <a:pPr indent="0" marL="0">
-              <a:buNone/>
-            </a:pPr>
-            <a:r>
-              <a:rPr lang="en-US" sz="3400" b="1" dirty="0">
-                <a:solidFill>
-                  <a:srgbClr val="0F172A"/>
-                </a:solidFill>
-                <a:latin typeface="Cambria" pitchFamily="34" charset="0"/>
-                <a:ea typeface="Cambria" pitchFamily="34" charset="-122"/>
-                <a:cs typeface="Cambria" pitchFamily="34" charset="-120"/>
-              </a:rPr>
-              <a:t>A complete platform, already built.</a:t>
-            </a:r>
-            <a:endParaRPr lang="en-US" sz="3400" dirty="0"/>
-          </a:p>
-        </p:txBody>
-      </p:sp>
-      <p:sp>
-        <p:nvSpPr>
-          <p:cNvPr id="4" name="Shape 2"/>
-          <p:cNvSpPr/>
-          <p:nvPr/>
-        </p:nvSpPr>
-        <p:spPr>
-          <a:xfrm>
-            <a:off x="640080" y="2331720"/>
-            <a:ext cx="2514600" cy="1554480"/>
-          </a:xfrm>
-          <a:prstGeom prst="roundRect">
-            <a:avLst>
-              <a:gd name="adj" fmla="val 7059"/>
-            </a:avLst>
-          </a:prstGeom>
-          <a:solidFill>
-            <a:srgbClr val="EFF6FF"/>
-          </a:solidFill>
-          <a:ln w="12700">
-            <a:solidFill>
-              <a:srgbClr val="EFF6FF"/>
-            </a:solidFill>
-            <a:prstDash val="solid"/>
-          </a:ln>
-          <a:effectLst>
-            <a:outerShdw sx="100000" sy="100000" kx="0" ky="0" algn="bl" rotWithShape="0" blurRad="76200" dist="25400" dir="5400000">
-              <a:srgbClr val="0F172A">
-                <a:alpha val="16000"/>
-              </a:srgbClr>
-            </a:outerShdw>
-          </a:effectLst>
-        </p:spPr>
-      </p:sp>
-      <p:sp>
-        <p:nvSpPr>
-          <p:cNvPr id="5" name="Text 3"/>
-          <p:cNvSpPr/>
-          <p:nvPr/>
-        </p:nvSpPr>
-        <p:spPr>
-          <a:xfrm>
-            <a:off x="640080" y="2468880"/>
-            <a:ext cx="2514600" cy="777240"/>
-          </a:xfrm>
-          <a:prstGeom prst="rect">
-            <a:avLst/>
-          </a:prstGeom>
-          <a:noFill/>
-          <a:ln/>
-        </p:spPr>
-        <p:txBody>
-          <a:bodyPr wrap="square" lIns="0" tIns="0" rIns="0" bIns="0" rtlCol="0" anchor="ctr"/>
-          <a:lstStyle/>
-          <a:p>
-            <a:pPr algn="ctr" indent="0" marL="0">
-              <a:buNone/>
-            </a:pPr>
-            <a:r>
-              <a:rPr lang="en-US" sz="3600" b="1" dirty="0">
-                <a:solidFill>
-                  <a:srgbClr val="2563EB"/>
-                </a:solidFill>
-                <a:latin typeface="Cambria" pitchFamily="34" charset="0"/>
-                <a:ea typeface="Cambria" pitchFamily="34" charset="-122"/>
-                <a:cs typeface="Cambria" pitchFamily="34" charset="-120"/>
-              </a:rPr>
-              <a:t>8 + 7</a:t>
-            </a:r>
-            <a:endParaRPr lang="en-US" sz="3600" dirty="0"/>
-          </a:p>
-        </p:txBody>
-      </p:sp>
-      <p:sp>
-        <p:nvSpPr>
-          <p:cNvPr id="6" name="Text 4"/>
-          <p:cNvSpPr/>
-          <p:nvPr/>
-        </p:nvSpPr>
-        <p:spPr>
-          <a:xfrm>
-            <a:off x="640080" y="3246120"/>
-            <a:ext cx="2514600" cy="457200"/>
-          </a:xfrm>
-          <a:prstGeom prst="rect">
-            <a:avLst/>
-          </a:prstGeom>
-          <a:noFill/>
-          <a:ln/>
-        </p:spPr>
-        <p:txBody>
-          <a:bodyPr wrap="square" lIns="0" tIns="0" rIns="0" bIns="0" rtlCol="0" anchor="ctr"/>
-          <a:lstStyle/>
-          <a:p>
-            <a:pPr algn="ctr" indent="0" marL="0">
-              <a:buNone/>
-            </a:pPr>
-            <a:r>
-              <a:rPr lang="en-US" sz="1300" dirty="0">
-                <a:solidFill>
-                  <a:srgbClr val="64748B"/>
-                </a:solidFill>
-                <a:latin typeface="Calibri" pitchFamily="34" charset="0"/>
-                <a:ea typeface="Calibri" pitchFamily="34" charset="-122"/>
-                <a:cs typeface="Calibri" pitchFamily="34" charset="-120"/>
-              </a:rPr>
-              <a:t>VE + VR phases</a:t>
-            </a:r>
-            <a:endParaRPr lang="en-US" sz="1300" dirty="0"/>
-          </a:p>
-        </p:txBody>
-      </p:sp>
-      <p:sp>
-        <p:nvSpPr>
-          <p:cNvPr id="7" name="Shape 5"/>
-          <p:cNvSpPr/>
-          <p:nvPr/>
-        </p:nvSpPr>
-        <p:spPr>
-          <a:xfrm>
-            <a:off x="3438144" y="2331720"/>
-            <a:ext cx="2514600" cy="1554480"/>
-          </a:xfrm>
-          <a:prstGeom prst="roundRect">
-            <a:avLst>
-              <a:gd name="adj" fmla="val 7059"/>
-            </a:avLst>
-          </a:prstGeom>
-          <a:solidFill>
-            <a:srgbClr val="ECFDF5"/>
-          </a:solidFill>
-          <a:ln w="12700">
-            <a:solidFill>
-              <a:srgbClr val="ECFDF5"/>
-            </a:solidFill>
-            <a:prstDash val="solid"/>
-          </a:ln>
-          <a:effectLst>
-            <a:outerShdw sx="100000" sy="100000" kx="0" ky="0" algn="bl" rotWithShape="0" blurRad="76200" dist="25400" dir="5400000">
-              <a:srgbClr val="0F172A">
-                <a:alpha val="16000"/>
-              </a:srgbClr>
-            </a:outerShdw>
-          </a:effectLst>
-        </p:spPr>
-      </p:sp>
-      <p:sp>
-        <p:nvSpPr>
-          <p:cNvPr id="8" name="Text 6"/>
-          <p:cNvSpPr/>
-          <p:nvPr/>
-        </p:nvSpPr>
-        <p:spPr>
-          <a:xfrm>
-            <a:off x="3438144" y="2468880"/>
-            <a:ext cx="2514600" cy="777240"/>
-          </a:xfrm>
-          <a:prstGeom prst="rect">
-            <a:avLst/>
-          </a:prstGeom>
-          <a:noFill/>
-          <a:ln/>
-        </p:spPr>
-        <p:txBody>
-          <a:bodyPr wrap="square" lIns="0" tIns="0" rIns="0" bIns="0" rtlCol="0" anchor="ctr"/>
-          <a:lstStyle/>
-          <a:p>
-            <a:pPr algn="ctr" indent="0" marL="0">
-              <a:buNone/>
-            </a:pPr>
-            <a:r>
-              <a:rPr lang="en-US" sz="3600" b="1" dirty="0">
-                <a:solidFill>
-                  <a:srgbClr val="059669"/>
-                </a:solidFill>
-                <a:latin typeface="Cambria" pitchFamily="34" charset="0"/>
-                <a:ea typeface="Cambria" pitchFamily="34" charset="-122"/>
-                <a:cs typeface="Cambria" pitchFamily="34" charset="-120"/>
-              </a:rPr>
-              <a:t>3</a:t>
-            </a:r>
-            <a:endParaRPr lang="en-US" sz="3600" dirty="0"/>
-          </a:p>
-        </p:txBody>
-      </p:sp>
-      <p:sp>
-        <p:nvSpPr>
-          <p:cNvPr id="9" name="Text 7"/>
-          <p:cNvSpPr/>
-          <p:nvPr/>
-        </p:nvSpPr>
-        <p:spPr>
-          <a:xfrm>
-            <a:off x="3438144" y="3246120"/>
-            <a:ext cx="2514600" cy="457200"/>
-          </a:xfrm>
-          <a:prstGeom prst="rect">
-            <a:avLst/>
-          </a:prstGeom>
-          <a:noFill/>
-          <a:ln/>
-        </p:spPr>
-        <p:txBody>
-          <a:bodyPr wrap="square" lIns="0" tIns="0" rIns="0" bIns="0" rtlCol="0" anchor="ctr"/>
-          <a:lstStyle/>
-          <a:p>
-            <a:pPr algn="ctr" indent="0" marL="0">
-              <a:buNone/>
-            </a:pPr>
-            <a:r>
-              <a:rPr lang="en-US" sz="1300" dirty="0">
-                <a:solidFill>
-                  <a:srgbClr val="64748B"/>
-                </a:solidFill>
-                <a:latin typeface="Calibri" pitchFamily="34" charset="0"/>
-                <a:ea typeface="Calibri" pitchFamily="34" charset="-122"/>
-                <a:cs typeface="Calibri" pitchFamily="34" charset="-120"/>
-              </a:rPr>
-              <a:t>industry profiles</a:t>
-            </a:r>
-            <a:endParaRPr lang="en-US" sz="1300" dirty="0"/>
-          </a:p>
-        </p:txBody>
-      </p:sp>
-      <p:sp>
-        <p:nvSpPr>
-          <p:cNvPr id="10" name="Shape 8"/>
-          <p:cNvSpPr/>
-          <p:nvPr/>
-        </p:nvSpPr>
-        <p:spPr>
-          <a:xfrm>
-            <a:off x="6236208" y="2331720"/>
-            <a:ext cx="2514600" cy="1554480"/>
-          </a:xfrm>
-          <a:prstGeom prst="roundRect">
-            <a:avLst>
-              <a:gd name="adj" fmla="val 7059"/>
-            </a:avLst>
-          </a:prstGeom>
-          <a:solidFill>
-            <a:srgbClr val="EFF6FF"/>
-          </a:solidFill>
-          <a:ln w="12700">
-            <a:solidFill>
-              <a:srgbClr val="EFF6FF"/>
-            </a:solidFill>
-            <a:prstDash val="solid"/>
-          </a:ln>
-          <a:effectLst>
-            <a:outerShdw sx="100000" sy="100000" kx="0" ky="0" algn="bl" rotWithShape="0" blurRad="76200" dist="25400" dir="5400000">
-              <a:srgbClr val="0F172A">
-                <a:alpha val="16000"/>
-              </a:srgbClr>
-            </a:outerShdw>
-          </a:effectLst>
-        </p:spPr>
-      </p:sp>
-      <p:sp>
-        <p:nvSpPr>
-          <p:cNvPr id="11" name="Text 9"/>
-          <p:cNvSpPr/>
-          <p:nvPr/>
-        </p:nvSpPr>
-        <p:spPr>
-          <a:xfrm>
-            <a:off x="6236208" y="2468880"/>
-            <a:ext cx="2514600" cy="777240"/>
-          </a:xfrm>
-          <a:prstGeom prst="rect">
-            <a:avLst/>
-          </a:prstGeom>
-          <a:noFill/>
-          <a:ln/>
-        </p:spPr>
-        <p:txBody>
-          <a:bodyPr wrap="square" lIns="0" tIns="0" rIns="0" bIns="0" rtlCol="0" anchor="ctr"/>
-          <a:lstStyle/>
-          <a:p>
-            <a:pPr algn="ctr" indent="0" marL="0">
-              <a:buNone/>
-            </a:pPr>
-            <a:r>
-              <a:rPr lang="en-US" sz="3600" b="1" dirty="0">
-                <a:solidFill>
-                  <a:srgbClr val="2563EB"/>
-                </a:solidFill>
-                <a:latin typeface="Cambria" pitchFamily="34" charset="0"/>
-                <a:ea typeface="Cambria" pitchFamily="34" charset="-122"/>
-                <a:cs typeface="Cambria" pitchFamily="34" charset="-120"/>
-              </a:rPr>
-              <a:t>5</a:t>
-            </a:r>
-            <a:endParaRPr lang="en-US" sz="3600" dirty="0"/>
-          </a:p>
-        </p:txBody>
-      </p:sp>
-      <p:sp>
-        <p:nvSpPr>
-          <p:cNvPr id="12" name="Text 10"/>
-          <p:cNvSpPr/>
-          <p:nvPr/>
-        </p:nvSpPr>
-        <p:spPr>
-          <a:xfrm>
-            <a:off x="6236208" y="3246120"/>
-            <a:ext cx="2514600" cy="457200"/>
-          </a:xfrm>
-          <a:prstGeom prst="rect">
-            <a:avLst/>
-          </a:prstGeom>
-          <a:noFill/>
-          <a:ln/>
-        </p:spPr>
-        <p:txBody>
-          <a:bodyPr wrap="square" lIns="0" tIns="0" rIns="0" bIns="0" rtlCol="0" anchor="ctr"/>
-          <a:lstStyle/>
-          <a:p>
-            <a:pPr algn="ctr" indent="0" marL="0">
-              <a:buNone/>
-            </a:pPr>
-            <a:r>
-              <a:rPr lang="en-US" sz="1300" dirty="0">
-                <a:solidFill>
-                  <a:srgbClr val="64748B"/>
-                </a:solidFill>
-                <a:latin typeface="Calibri" pitchFamily="34" charset="0"/>
-                <a:ea typeface="Calibri" pitchFamily="34" charset="-122"/>
-                <a:cs typeface="Calibri" pitchFamily="34" charset="-120"/>
-              </a:rPr>
-              <a:t>finance metrics</a:t>
-            </a:r>
-            <a:endParaRPr lang="en-US" sz="1300" dirty="0"/>
-          </a:p>
-        </p:txBody>
-      </p:sp>
-      <p:sp>
-        <p:nvSpPr>
-          <p:cNvPr id="13" name="Shape 11"/>
-          <p:cNvSpPr/>
-          <p:nvPr/>
-        </p:nvSpPr>
-        <p:spPr>
-          <a:xfrm>
-            <a:off x="9034272" y="2331720"/>
-            <a:ext cx="2514600" cy="1554480"/>
-          </a:xfrm>
-          <a:prstGeom prst="roundRect">
-            <a:avLst>
-              <a:gd name="adj" fmla="val 7059"/>
-            </a:avLst>
-          </a:prstGeom>
-          <a:solidFill>
-            <a:srgbClr val="ECFDF5"/>
-          </a:solidFill>
-          <a:ln w="12700">
-            <a:solidFill>
-              <a:srgbClr val="ECFDF5"/>
-            </a:solidFill>
-            <a:prstDash val="solid"/>
-          </a:ln>
-          <a:effectLst>
-            <a:outerShdw sx="100000" sy="100000" kx="0" ky="0" algn="bl" rotWithShape="0" blurRad="76200" dist="25400" dir="5400000">
-              <a:srgbClr val="0F172A">
-                <a:alpha val="16000"/>
-              </a:srgbClr>
-            </a:outerShdw>
-          </a:effectLst>
-        </p:spPr>
-      </p:sp>
-      <p:sp>
-        <p:nvSpPr>
-          <p:cNvPr id="14" name="Text 12"/>
-          <p:cNvSpPr/>
-          <p:nvPr/>
-        </p:nvSpPr>
-        <p:spPr>
-          <a:xfrm>
-            <a:off x="9034272" y="2468880"/>
-            <a:ext cx="2514600" cy="777240"/>
-          </a:xfrm>
-          <a:prstGeom prst="rect">
-            <a:avLst/>
-          </a:prstGeom>
-          <a:noFill/>
-          <a:ln/>
-        </p:spPr>
-        <p:txBody>
-          <a:bodyPr wrap="square" lIns="0" tIns="0" rIns="0" bIns="0" rtlCol="0" anchor="ctr"/>
-          <a:lstStyle/>
-          <a:p>
-            <a:pPr algn="ctr" indent="0" marL="0">
-              <a:buNone/>
-            </a:pPr>
-            <a:r>
-              <a:rPr lang="en-US" sz="3600" b="1" dirty="0">
-                <a:solidFill>
-                  <a:srgbClr val="059669"/>
-                </a:solidFill>
-                <a:latin typeface="Cambria" pitchFamily="34" charset="0"/>
-                <a:ea typeface="Cambria" pitchFamily="34" charset="-122"/>
-                <a:cs typeface="Cambria" pitchFamily="34" charset="-120"/>
-              </a:rPr>
-              <a:t>100%</a:t>
-            </a:r>
-            <a:endParaRPr lang="en-US" sz="3600" dirty="0"/>
-          </a:p>
-        </p:txBody>
-      </p:sp>
-      <p:sp>
-        <p:nvSpPr>
-          <p:cNvPr id="15" name="Text 13"/>
-          <p:cNvSpPr/>
-          <p:nvPr/>
-        </p:nvSpPr>
-        <p:spPr>
-          <a:xfrm>
-            <a:off x="9034272" y="3246120"/>
-            <a:ext cx="2514600" cy="457200"/>
-          </a:xfrm>
-          <a:prstGeom prst="rect">
-            <a:avLst/>
-          </a:prstGeom>
-          <a:noFill/>
-          <a:ln/>
-        </p:spPr>
-        <p:txBody>
-          <a:bodyPr wrap="square" lIns="0" tIns="0" rIns="0" bIns="0" rtlCol="0" anchor="ctr"/>
-          <a:lstStyle/>
-          <a:p>
-            <a:pPr algn="ctr" indent="0" marL="0">
-              <a:buNone/>
-            </a:pPr>
-            <a:r>
-              <a:rPr lang="en-US" sz="1300" dirty="0">
-                <a:solidFill>
-                  <a:srgbClr val="64748B"/>
-                </a:solidFill>
-                <a:latin typeface="Calibri" pitchFamily="34" charset="0"/>
-                <a:ea typeface="Calibri" pitchFamily="34" charset="-122"/>
-                <a:cs typeface="Calibri" pitchFamily="34" charset="-120"/>
-              </a:rPr>
-              <a:t>tenant-isolated</a:t>
-            </a:r>
-            <a:endParaRPr lang="en-US" sz="1300" dirty="0"/>
-          </a:p>
-        </p:txBody>
-      </p:sp>
-      <p:sp>
-        <p:nvSpPr>
-          <p:cNvPr id="16" name="Text 14"/>
-          <p:cNvSpPr/>
-          <p:nvPr/>
-        </p:nvSpPr>
-        <p:spPr>
-          <a:xfrm>
-            <a:off x="640080" y="4206240"/>
-            <a:ext cx="10908792" cy="365760"/>
-          </a:xfrm>
-          <a:prstGeom prst="rect">
-            <a:avLst/>
-          </a:prstGeom>
-          <a:noFill/>
-          <a:ln/>
-        </p:spPr>
-        <p:txBody>
-          <a:bodyPr wrap="square" lIns="0" tIns="0" rIns="0" bIns="0" rtlCol="0" anchor="ctr"/>
-          <a:lstStyle/>
-          <a:p>
-            <a:pPr indent="0" marL="0">
-              <a:buNone/>
-            </a:pPr>
-            <a:r>
-              <a:rPr lang="en-US" sz="1600" b="1" dirty="0">
-                <a:solidFill>
-                  <a:srgbClr val="0F172A"/>
-                </a:solidFill>
-                <a:latin typeface="Cambria" pitchFamily="34" charset="0"/>
-                <a:ea typeface="Cambria" pitchFamily="34" charset="-122"/>
-                <a:cs typeface="Cambria" pitchFamily="34" charset="-120"/>
-              </a:rPr>
-              <a:t>What ships today:</a:t>
-            </a:r>
-            <a:endParaRPr lang="en-US" sz="1600" dirty="0"/>
-          </a:p>
-        </p:txBody>
-      </p:sp>
-      <p:sp>
-        <p:nvSpPr>
-          <p:cNvPr id="17" name="Text 15"/>
-          <p:cNvSpPr/>
-          <p:nvPr/>
-        </p:nvSpPr>
-        <p:spPr>
-          <a:xfrm>
-            <a:off x="640080" y="4617720"/>
-            <a:ext cx="10908792" cy="1828800"/>
-          </a:xfrm>
-          <a:prstGeom prst="rect">
-            <a:avLst/>
-          </a:prstGeom>
-          <a:noFill/>
-          <a:ln/>
-        </p:spPr>
-        <p:txBody>
-          <a:bodyPr wrap="square" lIns="0" tIns="0" rIns="0" bIns="0" rtlCol="0" anchor="ctr"/>
-          <a:lstStyle/>
-          <a:p>
-            <a:pPr marL="203200" indent="-203200">
-              <a:spcAft>
-                <a:spcPts val="600"/>
-              </a:spcAft>
-              <a:buSzPct val="100000"/>
-              <a:buChar char="•"/>
-            </a:pPr>
-            <a:r>
-              <a:rPr lang="en-US" sz="1350" dirty="0">
-                <a:solidFill>
-                  <a:srgbClr val="64748B"/>
-                </a:solidFill>
-                <a:latin typeface="Calibri" pitchFamily="34" charset="0"/>
-                <a:ea typeface="Calibri" pitchFamily="34" charset="-122"/>
-                <a:cs typeface="Calibri" pitchFamily="34" charset="-120"/>
-              </a:rPr>
-              <a:t>VE Job Plan — function analysis, FAST diagram, weighted evaluation matrix, inline editing throughout</a:t>
-            </a:r>
-            <a:endParaRPr lang="en-US" sz="1350" dirty="0"/>
-          </a:p>
-          <a:p>
-            <a:pPr marL="203200" indent="-203200">
-              <a:spcAft>
-                <a:spcPts val="600"/>
-              </a:spcAft>
-              <a:buSzPct val="100000"/>
-              <a:buChar char="•"/>
-            </a:pPr>
-            <a:r>
-              <a:rPr lang="en-US" sz="1350" dirty="0">
-                <a:solidFill>
-                  <a:srgbClr val="64748B"/>
-                </a:solidFill>
-                <a:latin typeface="Calibri" pitchFamily="34" charset="0"/>
-                <a:ea typeface="Calibri" pitchFamily="34" charset="-122"/>
-                <a:cs typeface="Calibri" pitchFamily="34" charset="-120"/>
-              </a:rPr>
-              <a:t>Business case — live finance engine (ROI/payback/NPV/IRR/LCC), multi-currency, version history, Word export</a:t>
-            </a:r>
-            <a:endParaRPr lang="en-US" sz="1350" dirty="0"/>
-          </a:p>
-          <a:p>
-            <a:pPr marL="203200" indent="-203200">
-              <a:spcAft>
-                <a:spcPts val="600"/>
-              </a:spcAft>
-              <a:buSzPct val="100000"/>
-              <a:buChar char="•"/>
-            </a:pPr>
-            <a:r>
-              <a:rPr lang="en-US" sz="1350" dirty="0">
-                <a:solidFill>
-                  <a:srgbClr val="64748B"/>
-                </a:solidFill>
-                <a:latin typeface="Calibri" pitchFamily="34" charset="0"/>
-                <a:ea typeface="Calibri" pitchFamily="34" charset="-122"/>
-                <a:cs typeface="Calibri" pitchFamily="34" charset="-120"/>
-              </a:rPr>
-              <a:t>The first-class VE→VR handover — accepted recommendations become a seeded realization track</a:t>
-            </a:r>
-            <a:endParaRPr lang="en-US" sz="1350" dirty="0"/>
-          </a:p>
-          <a:p>
-            <a:pPr marL="203200" indent="-203200">
-              <a:spcAft>
-                <a:spcPts val="600"/>
-              </a:spcAft>
-              <a:buSzPct val="100000"/>
-              <a:buChar char="•"/>
-            </a:pPr>
-            <a:r>
-              <a:rPr lang="en-US" sz="1350" dirty="0">
-                <a:solidFill>
-                  <a:srgbClr val="64748B"/>
-                </a:solidFill>
-                <a:latin typeface="Calibri" pitchFamily="34" charset="0"/>
-                <a:ea typeface="Calibri" pitchFamily="34" charset="-122"/>
-                <a:cs typeface="Calibri" pitchFamily="34" charset="-120"/>
-              </a:rPr>
-              <a:t>Realization lifecycle — work packages, adoption plan, KPI tracker, benefits realization, VRP/QBR export</a:t>
-            </a:r>
-            <a:endParaRPr lang="en-US" sz="1350" dirty="0"/>
-          </a:p>
-          <a:p>
-            <a:pPr marL="203200" indent="-203200">
-              <a:spcAft>
-                <a:spcPts val="600"/>
-              </a:spcAft>
-              <a:buSzPct val="100000"/>
-              <a:buChar char="•"/>
-            </a:pPr>
-            <a:r>
-              <a:rPr lang="en-US" sz="1350" dirty="0">
-                <a:solidFill>
-                  <a:srgbClr val="64748B"/>
-                </a:solidFill>
-                <a:latin typeface="Calibri" pitchFamily="34" charset="0"/>
-                <a:ea typeface="Calibri" pitchFamily="34" charset="-122"/>
-                <a:cs typeface="Calibri" pitchFamily="34" charset="-120"/>
-              </a:rPr>
-              <a:t>Platform — portfolio &amp; KPI dashboards, real Auth.js RBAC, self-service workspaces + admin team management</a:t>
-            </a:r>
-            <a:endParaRPr lang="en-US" sz="1350" dirty="0"/>
           </a:p>
         </p:txBody>
       </p:sp>
@@ -3958,6 +3974,751 @@
                 <a:ea typeface="Calibri" pitchFamily="34" charset="-122"/>
                 <a:cs typeface="Calibri" pitchFamily="34" charset="-120"/>
               </a:rPr>
+              <a:t>THE PLATFORM</a:t>
+            </a:r>
+            <a:endParaRPr lang="en-US" sz="1300" dirty="0"/>
+          </a:p>
+        </p:txBody>
+      </p:sp>
+      <p:sp>
+        <p:nvSpPr>
+          <p:cNvPr id="3" name="Text 1"/>
+          <p:cNvSpPr/>
+          <p:nvPr/>
+        </p:nvSpPr>
+        <p:spPr>
+          <a:xfrm>
+            <a:off x="640080" y="822960"/>
+            <a:ext cx="10908792" cy="1005840"/>
+          </a:xfrm>
+          <a:prstGeom prst="rect">
+            <a:avLst/>
+          </a:prstGeom>
+          <a:noFill/>
+          <a:ln/>
+        </p:spPr>
+        <p:txBody>
+          <a:bodyPr wrap="square" lIns="0" tIns="0" rIns="0" bIns="0" rtlCol="0" anchor="t"/>
+          <a:lstStyle/>
+          <a:p>
+            <a:pPr indent="0" marL="0">
+              <a:buNone/>
+            </a:pPr>
+            <a:r>
+              <a:rPr lang="en-US" sz="3400" b="1" dirty="0">
+                <a:solidFill>
+                  <a:srgbClr val="0F172A"/>
+                </a:solidFill>
+                <a:latin typeface="Cambria" pitchFamily="34" charset="0"/>
+                <a:ea typeface="Cambria" pitchFamily="34" charset="-122"/>
+                <a:cs typeface="Cambria" pitchFamily="34" charset="-120"/>
+              </a:rPr>
+              <a:t>A complete platform, already built.</a:t>
+            </a:r>
+            <a:endParaRPr lang="en-US" sz="3400" dirty="0"/>
+          </a:p>
+        </p:txBody>
+      </p:sp>
+      <p:sp>
+        <p:nvSpPr>
+          <p:cNvPr id="4" name="Shape 2"/>
+          <p:cNvSpPr/>
+          <p:nvPr/>
+        </p:nvSpPr>
+        <p:spPr>
+          <a:xfrm>
+            <a:off x="640080" y="2331720"/>
+            <a:ext cx="2514600" cy="1554480"/>
+          </a:xfrm>
+          <a:prstGeom prst="roundRect">
+            <a:avLst>
+              <a:gd name="adj" fmla="val 7059"/>
+            </a:avLst>
+          </a:prstGeom>
+          <a:solidFill>
+            <a:srgbClr val="EFF6FF"/>
+          </a:solidFill>
+          <a:ln w="12700">
+            <a:solidFill>
+              <a:srgbClr val="EFF6FF"/>
+            </a:solidFill>
+            <a:prstDash val="solid"/>
+          </a:ln>
+          <a:effectLst>
+            <a:outerShdw sx="100000" sy="100000" kx="0" ky="0" algn="bl" rotWithShape="0" blurRad="76200" dist="25400" dir="5400000">
+              <a:srgbClr val="0F172A">
+                <a:alpha val="16000"/>
+              </a:srgbClr>
+            </a:outerShdw>
+          </a:effectLst>
+        </p:spPr>
+      </p:sp>
+      <p:sp>
+        <p:nvSpPr>
+          <p:cNvPr id="5" name="Text 3"/>
+          <p:cNvSpPr/>
+          <p:nvPr/>
+        </p:nvSpPr>
+        <p:spPr>
+          <a:xfrm>
+            <a:off x="640080" y="2468880"/>
+            <a:ext cx="2514600" cy="777240"/>
+          </a:xfrm>
+          <a:prstGeom prst="rect">
+            <a:avLst/>
+          </a:prstGeom>
+          <a:noFill/>
+          <a:ln/>
+        </p:spPr>
+        <p:txBody>
+          <a:bodyPr wrap="square" lIns="0" tIns="0" rIns="0" bIns="0" rtlCol="0" anchor="ctr"/>
+          <a:lstStyle/>
+          <a:p>
+            <a:pPr algn="ctr" indent="0" marL="0">
+              <a:buNone/>
+            </a:pPr>
+            <a:r>
+              <a:rPr lang="en-US" sz="3600" b="1" dirty="0">
+                <a:solidFill>
+                  <a:srgbClr val="2563EB"/>
+                </a:solidFill>
+                <a:latin typeface="Cambria" pitchFamily="34" charset="0"/>
+                <a:ea typeface="Cambria" pitchFamily="34" charset="-122"/>
+                <a:cs typeface="Cambria" pitchFamily="34" charset="-120"/>
+              </a:rPr>
+              <a:t>8·7·8</a:t>
+            </a:r>
+            <a:endParaRPr lang="en-US" sz="3600" dirty="0"/>
+          </a:p>
+        </p:txBody>
+      </p:sp>
+      <p:sp>
+        <p:nvSpPr>
+          <p:cNvPr id="6" name="Text 4"/>
+          <p:cNvSpPr/>
+          <p:nvPr/>
+        </p:nvSpPr>
+        <p:spPr>
+          <a:xfrm>
+            <a:off x="640080" y="3246120"/>
+            <a:ext cx="2514600" cy="457200"/>
+          </a:xfrm>
+          <a:prstGeom prst="rect">
+            <a:avLst/>
+          </a:prstGeom>
+          <a:noFill/>
+          <a:ln/>
+        </p:spPr>
+        <p:txBody>
+          <a:bodyPr wrap="square" lIns="0" tIns="0" rIns="0" bIns="0" rtlCol="0" anchor="ctr"/>
+          <a:lstStyle/>
+          <a:p>
+            <a:pPr algn="ctr" indent="0" marL="0">
+              <a:buNone/>
+            </a:pPr>
+            <a:r>
+              <a:rPr lang="en-US" sz="1300" dirty="0">
+                <a:solidFill>
+                  <a:srgbClr val="64748B"/>
+                </a:solidFill>
+                <a:latin typeface="Calibri" pitchFamily="34" charset="0"/>
+                <a:ea typeface="Calibri" pitchFamily="34" charset="-122"/>
+                <a:cs typeface="Calibri" pitchFamily="34" charset="-120"/>
+              </a:rPr>
+              <a:t>VE · VR · CS phases</a:t>
+            </a:r>
+            <a:endParaRPr lang="en-US" sz="1300" dirty="0"/>
+          </a:p>
+        </p:txBody>
+      </p:sp>
+      <p:sp>
+        <p:nvSpPr>
+          <p:cNvPr id="7" name="Shape 5"/>
+          <p:cNvSpPr/>
+          <p:nvPr/>
+        </p:nvSpPr>
+        <p:spPr>
+          <a:xfrm>
+            <a:off x="3438144" y="2331720"/>
+            <a:ext cx="2514600" cy="1554480"/>
+          </a:xfrm>
+          <a:prstGeom prst="roundRect">
+            <a:avLst>
+              <a:gd name="adj" fmla="val 7059"/>
+            </a:avLst>
+          </a:prstGeom>
+          <a:solidFill>
+            <a:srgbClr val="ECFDF5"/>
+          </a:solidFill>
+          <a:ln w="12700">
+            <a:solidFill>
+              <a:srgbClr val="ECFDF5"/>
+            </a:solidFill>
+            <a:prstDash val="solid"/>
+          </a:ln>
+          <a:effectLst>
+            <a:outerShdw sx="100000" sy="100000" kx="0" ky="0" algn="bl" rotWithShape="0" blurRad="76200" dist="25400" dir="5400000">
+              <a:srgbClr val="0F172A">
+                <a:alpha val="16000"/>
+              </a:srgbClr>
+            </a:outerShdw>
+          </a:effectLst>
+        </p:spPr>
+      </p:sp>
+      <p:sp>
+        <p:nvSpPr>
+          <p:cNvPr id="8" name="Text 6"/>
+          <p:cNvSpPr/>
+          <p:nvPr/>
+        </p:nvSpPr>
+        <p:spPr>
+          <a:xfrm>
+            <a:off x="3438144" y="2468880"/>
+            <a:ext cx="2514600" cy="777240"/>
+          </a:xfrm>
+          <a:prstGeom prst="rect">
+            <a:avLst/>
+          </a:prstGeom>
+          <a:noFill/>
+          <a:ln/>
+        </p:spPr>
+        <p:txBody>
+          <a:bodyPr wrap="square" lIns="0" tIns="0" rIns="0" bIns="0" rtlCol="0" anchor="ctr"/>
+          <a:lstStyle/>
+          <a:p>
+            <a:pPr algn="ctr" indent="0" marL="0">
+              <a:buNone/>
+            </a:pPr>
+            <a:r>
+              <a:rPr lang="en-US" sz="3600" b="1" dirty="0">
+                <a:solidFill>
+                  <a:srgbClr val="059669"/>
+                </a:solidFill>
+                <a:latin typeface="Cambria" pitchFamily="34" charset="0"/>
+                <a:ea typeface="Cambria" pitchFamily="34" charset="-122"/>
+                <a:cs typeface="Cambria" pitchFamily="34" charset="-120"/>
+              </a:rPr>
+              <a:t>3</a:t>
+            </a:r>
+            <a:endParaRPr lang="en-US" sz="3600" dirty="0"/>
+          </a:p>
+        </p:txBody>
+      </p:sp>
+      <p:sp>
+        <p:nvSpPr>
+          <p:cNvPr id="9" name="Text 7"/>
+          <p:cNvSpPr/>
+          <p:nvPr/>
+        </p:nvSpPr>
+        <p:spPr>
+          <a:xfrm>
+            <a:off x="3438144" y="3246120"/>
+            <a:ext cx="2514600" cy="457200"/>
+          </a:xfrm>
+          <a:prstGeom prst="rect">
+            <a:avLst/>
+          </a:prstGeom>
+          <a:noFill/>
+          <a:ln/>
+        </p:spPr>
+        <p:txBody>
+          <a:bodyPr wrap="square" lIns="0" tIns="0" rIns="0" bIns="0" rtlCol="0" anchor="ctr"/>
+          <a:lstStyle/>
+          <a:p>
+            <a:pPr algn="ctr" indent="0" marL="0">
+              <a:buNone/>
+            </a:pPr>
+            <a:r>
+              <a:rPr lang="en-US" sz="1300" dirty="0">
+                <a:solidFill>
+                  <a:srgbClr val="64748B"/>
+                </a:solidFill>
+                <a:latin typeface="Calibri" pitchFamily="34" charset="0"/>
+                <a:ea typeface="Calibri" pitchFamily="34" charset="-122"/>
+                <a:cs typeface="Calibri" pitchFamily="34" charset="-120"/>
+              </a:rPr>
+              <a:t>linked pillars</a:t>
+            </a:r>
+            <a:endParaRPr lang="en-US" sz="1300" dirty="0"/>
+          </a:p>
+        </p:txBody>
+      </p:sp>
+      <p:sp>
+        <p:nvSpPr>
+          <p:cNvPr id="10" name="Shape 8"/>
+          <p:cNvSpPr/>
+          <p:nvPr/>
+        </p:nvSpPr>
+        <p:spPr>
+          <a:xfrm>
+            <a:off x="6236208" y="2331720"/>
+            <a:ext cx="2514600" cy="1554480"/>
+          </a:xfrm>
+          <a:prstGeom prst="roundRect">
+            <a:avLst>
+              <a:gd name="adj" fmla="val 7059"/>
+            </a:avLst>
+          </a:prstGeom>
+          <a:solidFill>
+            <a:srgbClr val="EFF6FF"/>
+          </a:solidFill>
+          <a:ln w="12700">
+            <a:solidFill>
+              <a:srgbClr val="EFF6FF"/>
+            </a:solidFill>
+            <a:prstDash val="solid"/>
+          </a:ln>
+          <a:effectLst>
+            <a:outerShdw sx="100000" sy="100000" kx="0" ky="0" algn="bl" rotWithShape="0" blurRad="76200" dist="25400" dir="5400000">
+              <a:srgbClr val="0F172A">
+                <a:alpha val="16000"/>
+              </a:srgbClr>
+            </a:outerShdw>
+          </a:effectLst>
+        </p:spPr>
+      </p:sp>
+      <p:sp>
+        <p:nvSpPr>
+          <p:cNvPr id="11" name="Text 9"/>
+          <p:cNvSpPr/>
+          <p:nvPr/>
+        </p:nvSpPr>
+        <p:spPr>
+          <a:xfrm>
+            <a:off x="6236208" y="2468880"/>
+            <a:ext cx="2514600" cy="777240"/>
+          </a:xfrm>
+          <a:prstGeom prst="rect">
+            <a:avLst/>
+          </a:prstGeom>
+          <a:noFill/>
+          <a:ln/>
+        </p:spPr>
+        <p:txBody>
+          <a:bodyPr wrap="square" lIns="0" tIns="0" rIns="0" bIns="0" rtlCol="0" anchor="ctr"/>
+          <a:lstStyle/>
+          <a:p>
+            <a:pPr algn="ctr" indent="0" marL="0">
+              <a:buNone/>
+            </a:pPr>
+            <a:r>
+              <a:rPr lang="en-US" sz="3600" b="1" dirty="0">
+                <a:solidFill>
+                  <a:srgbClr val="2563EB"/>
+                </a:solidFill>
+                <a:latin typeface="Cambria" pitchFamily="34" charset="0"/>
+                <a:ea typeface="Cambria" pitchFamily="34" charset="-122"/>
+                <a:cs typeface="Cambria" pitchFamily="34" charset="-120"/>
+              </a:rPr>
+              <a:t>5</a:t>
+            </a:r>
+            <a:endParaRPr lang="en-US" sz="3600" dirty="0"/>
+          </a:p>
+        </p:txBody>
+      </p:sp>
+      <p:sp>
+        <p:nvSpPr>
+          <p:cNvPr id="12" name="Text 10"/>
+          <p:cNvSpPr/>
+          <p:nvPr/>
+        </p:nvSpPr>
+        <p:spPr>
+          <a:xfrm>
+            <a:off x="6236208" y="3246120"/>
+            <a:ext cx="2514600" cy="457200"/>
+          </a:xfrm>
+          <a:prstGeom prst="rect">
+            <a:avLst/>
+          </a:prstGeom>
+          <a:noFill/>
+          <a:ln/>
+        </p:spPr>
+        <p:txBody>
+          <a:bodyPr wrap="square" lIns="0" tIns="0" rIns="0" bIns="0" rtlCol="0" anchor="ctr"/>
+          <a:lstStyle/>
+          <a:p>
+            <a:pPr algn="ctr" indent="0" marL="0">
+              <a:buNone/>
+            </a:pPr>
+            <a:r>
+              <a:rPr lang="en-US" sz="1300" dirty="0">
+                <a:solidFill>
+                  <a:srgbClr val="64748B"/>
+                </a:solidFill>
+                <a:latin typeface="Calibri" pitchFamily="34" charset="0"/>
+                <a:ea typeface="Calibri" pitchFamily="34" charset="-122"/>
+                <a:cs typeface="Calibri" pitchFamily="34" charset="-120"/>
+              </a:rPr>
+              <a:t>finance metrics</a:t>
+            </a:r>
+            <a:endParaRPr lang="en-US" sz="1300" dirty="0"/>
+          </a:p>
+        </p:txBody>
+      </p:sp>
+      <p:sp>
+        <p:nvSpPr>
+          <p:cNvPr id="13" name="Shape 11"/>
+          <p:cNvSpPr/>
+          <p:nvPr/>
+        </p:nvSpPr>
+        <p:spPr>
+          <a:xfrm>
+            <a:off x="9034272" y="2331720"/>
+            <a:ext cx="2514600" cy="1554480"/>
+          </a:xfrm>
+          <a:prstGeom prst="roundRect">
+            <a:avLst>
+              <a:gd name="adj" fmla="val 7059"/>
+            </a:avLst>
+          </a:prstGeom>
+          <a:solidFill>
+            <a:srgbClr val="ECFDF5"/>
+          </a:solidFill>
+          <a:ln w="12700">
+            <a:solidFill>
+              <a:srgbClr val="ECFDF5"/>
+            </a:solidFill>
+            <a:prstDash val="solid"/>
+          </a:ln>
+          <a:effectLst>
+            <a:outerShdw sx="100000" sy="100000" kx="0" ky="0" algn="bl" rotWithShape="0" blurRad="76200" dist="25400" dir="5400000">
+              <a:srgbClr val="0F172A">
+                <a:alpha val="16000"/>
+              </a:srgbClr>
+            </a:outerShdw>
+          </a:effectLst>
+        </p:spPr>
+      </p:sp>
+      <p:sp>
+        <p:nvSpPr>
+          <p:cNvPr id="14" name="Text 12"/>
+          <p:cNvSpPr/>
+          <p:nvPr/>
+        </p:nvSpPr>
+        <p:spPr>
+          <a:xfrm>
+            <a:off x="9034272" y="2468880"/>
+            <a:ext cx="2514600" cy="777240"/>
+          </a:xfrm>
+          <a:prstGeom prst="rect">
+            <a:avLst/>
+          </a:prstGeom>
+          <a:noFill/>
+          <a:ln/>
+        </p:spPr>
+        <p:txBody>
+          <a:bodyPr wrap="square" lIns="0" tIns="0" rIns="0" bIns="0" rtlCol="0" anchor="ctr"/>
+          <a:lstStyle/>
+          <a:p>
+            <a:pPr algn="ctr" indent="0" marL="0">
+              <a:buNone/>
+            </a:pPr>
+            <a:r>
+              <a:rPr lang="en-US" sz="3600" b="1" dirty="0">
+                <a:solidFill>
+                  <a:srgbClr val="059669"/>
+                </a:solidFill>
+                <a:latin typeface="Cambria" pitchFamily="34" charset="0"/>
+                <a:ea typeface="Cambria" pitchFamily="34" charset="-122"/>
+                <a:cs typeface="Cambria" pitchFamily="34" charset="-120"/>
+              </a:rPr>
+              <a:t>100%</a:t>
+            </a:r>
+            <a:endParaRPr lang="en-US" sz="3600" dirty="0"/>
+          </a:p>
+        </p:txBody>
+      </p:sp>
+      <p:sp>
+        <p:nvSpPr>
+          <p:cNvPr id="15" name="Text 13"/>
+          <p:cNvSpPr/>
+          <p:nvPr/>
+        </p:nvSpPr>
+        <p:spPr>
+          <a:xfrm>
+            <a:off x="9034272" y="3246120"/>
+            <a:ext cx="2514600" cy="457200"/>
+          </a:xfrm>
+          <a:prstGeom prst="rect">
+            <a:avLst/>
+          </a:prstGeom>
+          <a:noFill/>
+          <a:ln/>
+        </p:spPr>
+        <p:txBody>
+          <a:bodyPr wrap="square" lIns="0" tIns="0" rIns="0" bIns="0" rtlCol="0" anchor="ctr"/>
+          <a:lstStyle/>
+          <a:p>
+            <a:pPr algn="ctr" indent="0" marL="0">
+              <a:buNone/>
+            </a:pPr>
+            <a:r>
+              <a:rPr lang="en-US" sz="1300" dirty="0">
+                <a:solidFill>
+                  <a:srgbClr val="64748B"/>
+                </a:solidFill>
+                <a:latin typeface="Calibri" pitchFamily="34" charset="0"/>
+                <a:ea typeface="Calibri" pitchFamily="34" charset="-122"/>
+                <a:cs typeface="Calibri" pitchFamily="34" charset="-120"/>
+              </a:rPr>
+              <a:t>tenant-isolated</a:t>
+            </a:r>
+            <a:endParaRPr lang="en-US" sz="1300" dirty="0"/>
+          </a:p>
+        </p:txBody>
+      </p:sp>
+      <p:sp>
+        <p:nvSpPr>
+          <p:cNvPr id="16" name="Text 14"/>
+          <p:cNvSpPr/>
+          <p:nvPr/>
+        </p:nvSpPr>
+        <p:spPr>
+          <a:xfrm>
+            <a:off x="640080" y="4206240"/>
+            <a:ext cx="10908792" cy="365760"/>
+          </a:xfrm>
+          <a:prstGeom prst="rect">
+            <a:avLst/>
+          </a:prstGeom>
+          <a:noFill/>
+          <a:ln/>
+        </p:spPr>
+        <p:txBody>
+          <a:bodyPr wrap="square" lIns="0" tIns="0" rIns="0" bIns="0" rtlCol="0" anchor="ctr"/>
+          <a:lstStyle/>
+          <a:p>
+            <a:pPr indent="0" marL="0">
+              <a:buNone/>
+            </a:pPr>
+            <a:r>
+              <a:rPr lang="en-US" sz="1600" b="1" dirty="0">
+                <a:solidFill>
+                  <a:srgbClr val="0F172A"/>
+                </a:solidFill>
+                <a:latin typeface="Cambria" pitchFamily="34" charset="0"/>
+                <a:ea typeface="Cambria" pitchFamily="34" charset="-122"/>
+                <a:cs typeface="Cambria" pitchFamily="34" charset="-120"/>
+              </a:rPr>
+              <a:t>What ships today:</a:t>
+            </a:r>
+            <a:endParaRPr lang="en-US" sz="1600" dirty="0"/>
+          </a:p>
+        </p:txBody>
+      </p:sp>
+      <p:sp>
+        <p:nvSpPr>
+          <p:cNvPr id="17" name="Text 15"/>
+          <p:cNvSpPr/>
+          <p:nvPr/>
+        </p:nvSpPr>
+        <p:spPr>
+          <a:xfrm>
+            <a:off x="640080" y="4617720"/>
+            <a:ext cx="10908792" cy="1828800"/>
+          </a:xfrm>
+          <a:prstGeom prst="rect">
+            <a:avLst/>
+          </a:prstGeom>
+          <a:noFill/>
+          <a:ln/>
+        </p:spPr>
+        <p:txBody>
+          <a:bodyPr wrap="square" lIns="0" tIns="0" rIns="0" bIns="0" rtlCol="0" anchor="ctr"/>
+          <a:lstStyle/>
+          <a:p>
+            <a:pPr marL="203200" indent="-203200">
+              <a:spcAft>
+                <a:spcPts val="600"/>
+              </a:spcAft>
+              <a:buSzPct val="100000"/>
+              <a:buChar char="•"/>
+            </a:pPr>
+            <a:r>
+              <a:rPr lang="en-US" sz="1350" dirty="0">
+                <a:solidFill>
+                  <a:srgbClr val="64748B"/>
+                </a:solidFill>
+                <a:latin typeface="Calibri" pitchFamily="34" charset="0"/>
+                <a:ea typeface="Calibri" pitchFamily="34" charset="-122"/>
+                <a:cs typeface="Calibri" pitchFamily="34" charset="-120"/>
+              </a:rPr>
+              <a:t>VE Job Plan — function analysis, FAST diagram, weighted evaluation matrix, inline editing throughout</a:t>
+            </a:r>
+            <a:endParaRPr lang="en-US" sz="1350" dirty="0"/>
+          </a:p>
+          <a:p>
+            <a:pPr marL="203200" indent="-203200">
+              <a:spcAft>
+                <a:spcPts val="600"/>
+              </a:spcAft>
+              <a:buSzPct val="100000"/>
+              <a:buChar char="•"/>
+            </a:pPr>
+            <a:r>
+              <a:rPr lang="en-US" sz="1350" dirty="0">
+                <a:solidFill>
+                  <a:srgbClr val="64748B"/>
+                </a:solidFill>
+                <a:latin typeface="Calibri" pitchFamily="34" charset="0"/>
+                <a:ea typeface="Calibri" pitchFamily="34" charset="-122"/>
+                <a:cs typeface="Calibri" pitchFamily="34" charset="-120"/>
+              </a:rPr>
+              <a:t>Business case — live finance engine (ROI/payback/NPV/IRR/LCC), multi-currency, version history, Word export</a:t>
+            </a:r>
+            <a:endParaRPr lang="en-US" sz="1350" dirty="0"/>
+          </a:p>
+          <a:p>
+            <a:pPr marL="203200" indent="-203200">
+              <a:spcAft>
+                <a:spcPts val="600"/>
+              </a:spcAft>
+              <a:buSzPct val="100000"/>
+              <a:buChar char="•"/>
+            </a:pPr>
+            <a:r>
+              <a:rPr lang="en-US" sz="1350" dirty="0">
+                <a:solidFill>
+                  <a:srgbClr val="64748B"/>
+                </a:solidFill>
+                <a:latin typeface="Calibri" pitchFamily="34" charset="0"/>
+                <a:ea typeface="Calibri" pitchFamily="34" charset="-122"/>
+                <a:cs typeface="Calibri" pitchFamily="34" charset="-120"/>
+              </a:rPr>
+              <a:t>The first-class VE→VR handover — accepted recommendations become a seeded realization track</a:t>
+            </a:r>
+            <a:endParaRPr lang="en-US" sz="1350" dirty="0"/>
+          </a:p>
+          <a:p>
+            <a:pPr marL="203200" indent="-203200">
+              <a:spcAft>
+                <a:spcPts val="600"/>
+              </a:spcAft>
+              <a:buSzPct val="100000"/>
+              <a:buChar char="•"/>
+            </a:pPr>
+            <a:r>
+              <a:rPr lang="en-US" sz="1350" dirty="0">
+                <a:solidFill>
+                  <a:srgbClr val="64748B"/>
+                </a:solidFill>
+                <a:latin typeface="Calibri" pitchFamily="34" charset="0"/>
+                <a:ea typeface="Calibri" pitchFamily="34" charset="-122"/>
+                <a:cs typeface="Calibri" pitchFamily="34" charset="-120"/>
+              </a:rPr>
+              <a:t>Realization lifecycle — work packages, adoption plan, KPI tracker, benefits realization, VRP/QBR export</a:t>
+            </a:r>
+            <a:endParaRPr lang="en-US" sz="1350" dirty="0"/>
+          </a:p>
+          <a:p>
+            <a:pPr marL="203200" indent="-203200">
+              <a:spcAft>
+                <a:spcPts val="600"/>
+              </a:spcAft>
+              <a:buSzPct val="100000"/>
+              <a:buChar char="•"/>
+            </a:pPr>
+            <a:r>
+              <a:rPr lang="en-US" sz="1350" dirty="0">
+                <a:solidFill>
+                  <a:srgbClr val="64748B"/>
+                </a:solidFill>
+                <a:latin typeface="Calibri" pitchFamily="34" charset="0"/>
+                <a:ea typeface="Calibri" pitchFamily="34" charset="-122"/>
+                <a:cs typeface="Calibri" pitchFamily="34" charset="-120"/>
+              </a:rPr>
+              <a:t>Customer Success — per-account engagements, 8-stage lifecycle, health scorecard, renewal/growth plans, AI-assisted EBRs</a:t>
+            </a:r>
+            <a:endParaRPr lang="en-US" sz="1350" dirty="0"/>
+          </a:p>
+          <a:p>
+            <a:pPr marL="203200" indent="-203200">
+              <a:spcAft>
+                <a:spcPts val="600"/>
+              </a:spcAft>
+              <a:buSzPct val="100000"/>
+              <a:buChar char="•"/>
+            </a:pPr>
+            <a:r>
+              <a:rPr lang="en-US" sz="1350" dirty="0">
+                <a:solidFill>
+                  <a:srgbClr val="64748B"/>
+                </a:solidFill>
+                <a:latin typeface="Calibri" pitchFamily="34" charset="0"/>
+                <a:ea typeface="Calibri" pitchFamily="34" charset="-122"/>
+                <a:cs typeface="Calibri" pitchFamily="34" charset="-120"/>
+              </a:rPr>
+              <a:t>Platform — portfolio &amp; KPI dashboards (with a CS lens), real Auth.js RBAC, self-service workspaces + admin team management</a:t>
+            </a:r>
+            <a:endParaRPr lang="en-US" sz="1350" dirty="0"/>
+          </a:p>
+        </p:txBody>
+      </p:sp>
+    </p:spTree>
+  </p:cSld>
+  <p:clrMapOvr>
+    <a:masterClrMapping/>
+  </p:clrMapOvr>
+</p:sld>
+</file>
+
+<file path=ppt/slides/slide14.xml><?xml version="1.0" encoding="utf-8"?>
+<p:sld xmlns:a="http://schemas.openxmlformats.org/drawingml/2006/main" xmlns:r="http://schemas.openxmlformats.org/officeDocument/2006/relationships" xmlns:p="http://schemas.openxmlformats.org/presentationml/2006/main">
+  <p:cSld name="Slide 14">
+    <p:bg>
+      <p:bgPr>
+        <a:solidFill>
+          <a:srgbClr val="FFFFFF"/>
+        </a:solidFill>
+      </p:bgPr>
+    </p:bg>
+    <p:spTree>
+      <p:nvGrpSpPr>
+        <p:cNvPr id="1" name=""/>
+        <p:cNvGrpSpPr/>
+        <p:nvPr/>
+      </p:nvGrpSpPr>
+      <p:grpSpPr>
+        <a:xfrm>
+          <a:off x="0" y="0"/>
+          <a:ext cx="0" cy="0"/>
+          <a:chOff x="0" y="0"/>
+          <a:chExt cx="0" cy="0"/>
+        </a:xfrm>
+      </p:grpSpPr>
+      <p:sp>
+        <p:nvSpPr>
+          <p:cNvPr id="2" name="Text 0"/>
+          <p:cNvSpPr/>
+          <p:nvPr/>
+        </p:nvSpPr>
+        <p:spPr>
+          <a:xfrm>
+            <a:off x="640080" y="502920"/>
+            <a:ext cx="10908792" cy="274320"/>
+          </a:xfrm>
+          <a:prstGeom prst="rect">
+            <a:avLst/>
+          </a:prstGeom>
+          <a:noFill/>
+          <a:ln/>
+        </p:spPr>
+        <p:txBody>
+          <a:bodyPr wrap="square" lIns="0" tIns="0" rIns="0" bIns="0" rtlCol="0" anchor="ctr"/>
+          <a:lstStyle/>
+          <a:p>
+            <a:pPr indent="0" marL="0">
+              <a:buNone/>
+            </a:pPr>
+            <a:r>
+              <a:rPr lang="en-US" sz="1300" b="1" spc="200" kern="0" dirty="0">
+                <a:solidFill>
+                  <a:srgbClr val="2563EB"/>
+                </a:solidFill>
+                <a:latin typeface="Calibri" pitchFamily="34" charset="0"/>
+                <a:ea typeface="Calibri" pitchFamily="34" charset="-122"/>
+                <a:cs typeface="Calibri" pitchFamily="34" charset="-120"/>
+              </a:rPr>
               <a:t>WHO IT'S FOR</a:t>
             </a:r>
             <a:endParaRPr lang="en-US" sz="1300" dirty="0"/>
@@ -4356,9 +5117,9 @@
 </p:sld>
 </file>
 
-<file path=ppt/slides/slide14.xml><?xml version="1.0" encoding="utf-8"?>
+<file path=ppt/slides/slide15.xml><?xml version="1.0" encoding="utf-8"?>
 <p:sld xmlns:a="http://schemas.openxmlformats.org/drawingml/2006/main" xmlns:r="http://schemas.openxmlformats.org/officeDocument/2006/relationships" xmlns:p="http://schemas.openxmlformats.org/presentationml/2006/main">
-  <p:cSld name="Slide 14">
+  <p:cSld name="Slide 15">
     <p:bg>
       <p:bgPr>
         <a:solidFill>

</xml_diff>

<commit_message>
demo-kit: re-skin diagrams + Solution-Overview deck to the MP072 palette
- make-diagrams.js: palette -> VE Blue Fantastic #2C3B4D, VR Truffle Trouble
  #A35139, CS Burning Flame (legible #E07E2A/#B45E1C), warm greige canvas;
  regenerated all 6 diagram PNG+SVG (Design-Document .md picks these up).
- build-deck.js: palette consts remapped to MP072 (VE/VR/accent/neutrals);
  regenerated ValueLifecycle-Solution-Overview.pptx + .pdf (via PowerPoint).
- Rebuilt ValueLifecycle-Design-Document.docx to embed the new-colour diagrams.

Co-Authored-By: Claude Opus 4.8 <noreply@anthropic.com>
</commit_message>
<xml_diff>
--- a/demo-kit/ValueLifecycle-Solution-Overview.pptx
+++ b/demo-kit/ValueLifecycle-Solution-Overview.pptx
@@ -2103,7 +2103,7 @@
     <p:bg>
       <p:bgPr>
         <a:solidFill>
-          <a:srgbClr val="0B1220"/>
+          <a:srgbClr val="1B2632"/>
         </a:solidFill>
       </p:bgPr>
     </p:bg>
@@ -2136,11 +2136,11 @@
             <a:avLst/>
           </a:prstGeom>
           <a:solidFill>
-            <a:srgbClr val="0B1220"/>
+            <a:srgbClr val="1B2632"/>
           </a:solidFill>
           <a:ln w="38100">
             <a:solidFill>
-              <a:srgbClr val="60A5FA"/>
+              <a:srgbClr val="B7C2CD"/>
             </a:solidFill>
             <a:prstDash val="solid"/>
           </a:ln>
@@ -2161,11 +2161,11 @@
             <a:avLst/>
           </a:prstGeom>
           <a:solidFill>
-            <a:srgbClr val="0B1220"/>
+            <a:srgbClr val="1B2632"/>
           </a:solidFill>
           <a:ln w="38100">
             <a:solidFill>
-              <a:srgbClr val="34D399"/>
+              <a:srgbClr val="D98E74"/>
             </a:solidFill>
             <a:prstDash val="solid"/>
           </a:ln>
@@ -2237,7 +2237,7 @@
             <a:r>
               <a:rPr lang="en-US" sz="2400" dirty="0">
                 <a:solidFill>
-                  <a:srgbClr val="60A5FA"/>
+                  <a:srgbClr val="B7C2CD"/>
                 </a:solidFill>
                 <a:latin typeface="Calibri" pitchFamily="34" charset="0"/>
                 <a:ea typeface="Calibri" pitchFamily="34" charset="-122"/>
@@ -2279,7 +2279,7 @@
             <a:r>
               <a:rPr lang="en-US" sz="1600" dirty="0">
                 <a:solidFill>
-                  <a:srgbClr val="CBD5E1"/>
+                  <a:srgbClr val="AEB7BF"/>
                 </a:solidFill>
                 <a:latin typeface="Calibri" pitchFamily="34" charset="0"/>
                 <a:ea typeface="Calibri" pitchFamily="34" charset="-122"/>
@@ -2318,7 +2318,7 @@
             <a:r>
               <a:rPr lang="en-US" sz="1200" b="1" spc="300" kern="0" dirty="0">
                 <a:solidFill>
-                  <a:srgbClr val="34D399"/>
+                  <a:srgbClr val="D98E74"/>
                 </a:solidFill>
                 <a:latin typeface="Calibri" pitchFamily="34" charset="0"/>
                 <a:ea typeface="Calibri" pitchFamily="34" charset="-122"/>
@@ -2389,7 +2389,7 @@
             <a:r>
               <a:rPr lang="en-US" sz="1300" b="1" spc="200" kern="0" dirty="0">
                 <a:solidFill>
-                  <a:srgbClr val="34D399"/>
+                  <a:srgbClr val="D98E74"/>
                 </a:solidFill>
                 <a:latin typeface="Calibri" pitchFamily="34" charset="0"/>
                 <a:ea typeface="Calibri" pitchFamily="34" charset="-122"/>
@@ -2428,7 +2428,7 @@
             <a:r>
               <a:rPr lang="en-US" sz="3400" b="1" dirty="0">
                 <a:solidFill>
-                  <a:srgbClr val="0F172A"/>
+                  <a:srgbClr val="26303B"/>
                 </a:solidFill>
                 <a:latin typeface="Cambria" pitchFamily="34" charset="0"/>
                 <a:ea typeface="Cambria" pitchFamily="34" charset="-122"/>
@@ -2470,7 +2470,7 @@
             <a:r>
               <a:rPr lang="en-US" sz="1500" dirty="0">
                 <a:solidFill>
-                  <a:srgbClr val="64748B"/>
+                  <a:srgbClr val="6E685C"/>
                 </a:solidFill>
                 <a:latin typeface="Calibri" pitchFamily="34" charset="0"/>
                 <a:ea typeface="Calibri" pitchFamily="34" charset="-122"/>
@@ -2499,17 +2499,17 @@
             </a:avLst>
           </a:prstGeom>
           <a:solidFill>
-            <a:srgbClr val="ECFDF5"/>
+            <a:srgbClr val="FBF0EC"/>
           </a:solidFill>
           <a:ln w="12700">
             <a:solidFill>
-              <a:srgbClr val="ECFDF5"/>
+              <a:srgbClr val="FBF0EC"/>
             </a:solidFill>
             <a:prstDash val="solid"/>
           </a:ln>
           <a:effectLst>
             <a:outerShdw sx="100000" sy="100000" kx="0" ky="0" algn="bl" rotWithShape="0" blurRad="76200" dist="25400" dir="5400000">
-              <a:srgbClr val="0F172A">
+              <a:srgbClr val="26303B">
                 <a:alpha val="16000"/>
               </a:srgbClr>
             </a:outerShdw>
@@ -2543,7 +2543,7 @@
             <a:r>
               <a:rPr lang="en-US" sz="1600" b="1" dirty="0">
                 <a:solidFill>
-                  <a:srgbClr val="059669"/>
+                  <a:srgbClr val="A35139"/>
                 </a:solidFill>
                 <a:latin typeface="Cambria" pitchFamily="34" charset="0"/>
                 <a:ea typeface="Cambria" pitchFamily="34" charset="-122"/>
@@ -2585,7 +2585,7 @@
             <a:r>
               <a:rPr lang="en-US" sz="1250" dirty="0">
                 <a:solidFill>
-                  <a:srgbClr val="64748B"/>
+                  <a:srgbClr val="6E685C"/>
                 </a:solidFill>
                 <a:latin typeface="Calibri" pitchFamily="34" charset="0"/>
                 <a:ea typeface="Calibri" pitchFamily="34" charset="-122"/>
@@ -2614,17 +2614,17 @@
             </a:avLst>
           </a:prstGeom>
           <a:solidFill>
-            <a:srgbClr val="EFF6FF"/>
+            <a:srgbClr val="EEF1F4"/>
           </a:solidFill>
           <a:ln w="12700">
             <a:solidFill>
-              <a:srgbClr val="EFF6FF"/>
+              <a:srgbClr val="EEF1F4"/>
             </a:solidFill>
             <a:prstDash val="solid"/>
           </a:ln>
           <a:effectLst>
             <a:outerShdw sx="100000" sy="100000" kx="0" ky="0" algn="bl" rotWithShape="0" blurRad="76200" dist="25400" dir="5400000">
-              <a:srgbClr val="0F172A">
+              <a:srgbClr val="26303B">
                 <a:alpha val="16000"/>
               </a:srgbClr>
             </a:outerShdw>
@@ -2658,7 +2658,7 @@
             <a:r>
               <a:rPr lang="en-US" sz="1600" b="1" dirty="0">
                 <a:solidFill>
-                  <a:srgbClr val="2563EB"/>
+                  <a:srgbClr val="2C3B4D"/>
                 </a:solidFill>
                 <a:latin typeface="Cambria" pitchFamily="34" charset="0"/>
                 <a:ea typeface="Cambria" pitchFamily="34" charset="-122"/>
@@ -2700,7 +2700,7 @@
             <a:r>
               <a:rPr lang="en-US" sz="1250" dirty="0">
                 <a:solidFill>
-                  <a:srgbClr val="64748B"/>
+                  <a:srgbClr val="6E685C"/>
                 </a:solidFill>
                 <a:latin typeface="Calibri" pitchFamily="34" charset="0"/>
                 <a:ea typeface="Calibri" pitchFamily="34" charset="-122"/>
@@ -2729,17 +2729,17 @@
             </a:avLst>
           </a:prstGeom>
           <a:solidFill>
-            <a:srgbClr val="ECFDF5"/>
+            <a:srgbClr val="FBF0EC"/>
           </a:solidFill>
           <a:ln w="12700">
             <a:solidFill>
-              <a:srgbClr val="ECFDF5"/>
+              <a:srgbClr val="FBF0EC"/>
             </a:solidFill>
             <a:prstDash val="solid"/>
           </a:ln>
           <a:effectLst>
             <a:outerShdw sx="100000" sy="100000" kx="0" ky="0" algn="bl" rotWithShape="0" blurRad="76200" dist="25400" dir="5400000">
-              <a:srgbClr val="0F172A">
+              <a:srgbClr val="26303B">
                 <a:alpha val="16000"/>
               </a:srgbClr>
             </a:outerShdw>
@@ -2773,7 +2773,7 @@
             <a:r>
               <a:rPr lang="en-US" sz="1600" b="1" dirty="0">
                 <a:solidFill>
-                  <a:srgbClr val="059669"/>
+                  <a:srgbClr val="A35139"/>
                 </a:solidFill>
                 <a:latin typeface="Cambria" pitchFamily="34" charset="0"/>
                 <a:ea typeface="Cambria" pitchFamily="34" charset="-122"/>
@@ -2815,7 +2815,7 @@
             <a:r>
               <a:rPr lang="en-US" sz="1250" dirty="0">
                 <a:solidFill>
-                  <a:srgbClr val="64748B"/>
+                  <a:srgbClr val="6E685C"/>
                 </a:solidFill>
                 <a:latin typeface="Calibri" pitchFamily="34" charset="0"/>
                 <a:ea typeface="Calibri" pitchFamily="34" charset="-122"/>
@@ -2844,17 +2844,17 @@
             </a:avLst>
           </a:prstGeom>
           <a:solidFill>
-            <a:srgbClr val="EFF6FF"/>
+            <a:srgbClr val="EEF1F4"/>
           </a:solidFill>
           <a:ln w="12700">
             <a:solidFill>
-              <a:srgbClr val="EFF6FF"/>
+              <a:srgbClr val="EEF1F4"/>
             </a:solidFill>
             <a:prstDash val="solid"/>
           </a:ln>
           <a:effectLst>
             <a:outerShdw sx="100000" sy="100000" kx="0" ky="0" algn="bl" rotWithShape="0" blurRad="76200" dist="25400" dir="5400000">
-              <a:srgbClr val="0F172A">
+              <a:srgbClr val="26303B">
                 <a:alpha val="16000"/>
               </a:srgbClr>
             </a:outerShdw>
@@ -2888,7 +2888,7 @@
             <a:r>
               <a:rPr lang="en-US" sz="1600" b="1" dirty="0">
                 <a:solidFill>
-                  <a:srgbClr val="2563EB"/>
+                  <a:srgbClr val="2C3B4D"/>
                 </a:solidFill>
                 <a:latin typeface="Cambria" pitchFamily="34" charset="0"/>
                 <a:ea typeface="Cambria" pitchFamily="34" charset="-122"/>
@@ -2930,7 +2930,7 @@
             <a:r>
               <a:rPr lang="en-US" sz="1250" dirty="0">
                 <a:solidFill>
-                  <a:srgbClr val="64748B"/>
+                  <a:srgbClr val="6E685C"/>
                 </a:solidFill>
                 <a:latin typeface="Calibri" pitchFamily="34" charset="0"/>
                 <a:ea typeface="Calibri" pitchFamily="34" charset="-122"/>
@@ -2969,7 +2969,7 @@
             <a:r>
               <a:rPr lang="en-US" sz="1300" i="1" dirty="0">
                 <a:solidFill>
-                  <a:srgbClr val="64748B"/>
+                  <a:srgbClr val="6E685C"/>
                 </a:solidFill>
                 <a:latin typeface="Calibri" pitchFamily="34" charset="0"/>
                 <a:ea typeface="Calibri" pitchFamily="34" charset="-122"/>
@@ -3040,7 +3040,7 @@
             <a:r>
               <a:rPr lang="en-US" sz="1300" b="1" spc="200" kern="0" dirty="0">
                 <a:solidFill>
-                  <a:srgbClr val="2563EB"/>
+                  <a:srgbClr val="2C3B4D"/>
                 </a:solidFill>
                 <a:latin typeface="Calibri" pitchFamily="34" charset="0"/>
                 <a:ea typeface="Calibri" pitchFamily="34" charset="-122"/>
@@ -3079,7 +3079,7 @@
             <a:r>
               <a:rPr lang="en-US" sz="3400" b="1" dirty="0">
                 <a:solidFill>
-                  <a:srgbClr val="0F172A"/>
+                  <a:srgbClr val="26303B"/>
                 </a:solidFill>
                 <a:latin typeface="Cambria" pitchFamily="34" charset="0"/>
                 <a:ea typeface="Cambria" pitchFamily="34" charset="-122"/>
@@ -3108,17 +3108,17 @@
             </a:avLst>
           </a:prstGeom>
           <a:solidFill>
-            <a:srgbClr val="EFF6FF"/>
+            <a:srgbClr val="EEF1F4"/>
           </a:solidFill>
           <a:ln w="12700">
             <a:solidFill>
-              <a:srgbClr val="EFF6FF"/>
+              <a:srgbClr val="EEF1F4"/>
             </a:solidFill>
             <a:prstDash val="solid"/>
           </a:ln>
           <a:effectLst>
             <a:outerShdw sx="100000" sy="100000" kx="0" ky="0" algn="bl" rotWithShape="0" blurRad="76200" dist="25400" dir="5400000">
-              <a:srgbClr val="0F172A">
+              <a:srgbClr val="26303B">
                 <a:alpha val="16000"/>
               </a:srgbClr>
             </a:outerShdw>
@@ -3152,7 +3152,7 @@
             <a:r>
               <a:rPr lang="en-US" sz="1700" b="1" dirty="0">
                 <a:solidFill>
-                  <a:srgbClr val="2563EB"/>
+                  <a:srgbClr val="2C3B4D"/>
                 </a:solidFill>
                 <a:latin typeface="Cambria" pitchFamily="34" charset="0"/>
                 <a:ea typeface="Cambria" pitchFamily="34" charset="-122"/>
@@ -3194,7 +3194,7 @@
             <a:r>
               <a:rPr lang="en-US" sz="1450" dirty="0">
                 <a:solidFill>
-                  <a:srgbClr val="0F172A"/>
+                  <a:srgbClr val="26303B"/>
                 </a:solidFill>
                 <a:latin typeface="Calibri" pitchFamily="34" charset="0"/>
                 <a:ea typeface="Calibri" pitchFamily="34" charset="-122"/>
@@ -3223,17 +3223,17 @@
             </a:avLst>
           </a:prstGeom>
           <a:solidFill>
-            <a:srgbClr val="EFF6FF"/>
+            <a:srgbClr val="EEF1F4"/>
           </a:solidFill>
           <a:ln w="12700">
             <a:solidFill>
-              <a:srgbClr val="EFF6FF"/>
+              <a:srgbClr val="EEF1F4"/>
             </a:solidFill>
             <a:prstDash val="solid"/>
           </a:ln>
           <a:effectLst>
             <a:outerShdw sx="100000" sy="100000" kx="0" ky="0" algn="bl" rotWithShape="0" blurRad="76200" dist="25400" dir="5400000">
-              <a:srgbClr val="0F172A">
+              <a:srgbClr val="26303B">
                 <a:alpha val="16000"/>
               </a:srgbClr>
             </a:outerShdw>
@@ -3267,7 +3267,7 @@
             <a:r>
               <a:rPr lang="en-US" sz="1700" b="1" dirty="0">
                 <a:solidFill>
-                  <a:srgbClr val="2563EB"/>
+                  <a:srgbClr val="2C3B4D"/>
                 </a:solidFill>
                 <a:latin typeface="Cambria" pitchFamily="34" charset="0"/>
                 <a:ea typeface="Cambria" pitchFamily="34" charset="-122"/>
@@ -3309,7 +3309,7 @@
             <a:r>
               <a:rPr lang="en-US" sz="1450" dirty="0">
                 <a:solidFill>
-                  <a:srgbClr val="0F172A"/>
+                  <a:srgbClr val="26303B"/>
                 </a:solidFill>
                 <a:latin typeface="Calibri" pitchFamily="34" charset="0"/>
                 <a:ea typeface="Calibri" pitchFamily="34" charset="-122"/>
@@ -3338,17 +3338,17 @@
             </a:avLst>
           </a:prstGeom>
           <a:solidFill>
-            <a:srgbClr val="EFF6FF"/>
+            <a:srgbClr val="EEF1F4"/>
           </a:solidFill>
           <a:ln w="12700">
             <a:solidFill>
-              <a:srgbClr val="EFF6FF"/>
+              <a:srgbClr val="EEF1F4"/>
             </a:solidFill>
             <a:prstDash val="solid"/>
           </a:ln>
           <a:effectLst>
             <a:outerShdw sx="100000" sy="100000" kx="0" ky="0" algn="bl" rotWithShape="0" blurRad="76200" dist="25400" dir="5400000">
-              <a:srgbClr val="0F172A">
+              <a:srgbClr val="26303B">
                 <a:alpha val="16000"/>
               </a:srgbClr>
             </a:outerShdw>
@@ -3382,7 +3382,7 @@
             <a:r>
               <a:rPr lang="en-US" sz="1700" b="1" dirty="0">
                 <a:solidFill>
-                  <a:srgbClr val="2563EB"/>
+                  <a:srgbClr val="2C3B4D"/>
                 </a:solidFill>
                 <a:latin typeface="Cambria" pitchFamily="34" charset="0"/>
                 <a:ea typeface="Cambria" pitchFamily="34" charset="-122"/>
@@ -3424,7 +3424,7 @@
             <a:r>
               <a:rPr lang="en-US" sz="1450" dirty="0">
                 <a:solidFill>
-                  <a:srgbClr val="0F172A"/>
+                  <a:srgbClr val="26303B"/>
                 </a:solidFill>
                 <a:latin typeface="Calibri" pitchFamily="34" charset="0"/>
                 <a:ea typeface="Calibri" pitchFamily="34" charset="-122"/>
@@ -3463,7 +3463,7 @@
             <a:r>
               <a:rPr lang="en-US" sz="1400" i="1" dirty="0">
                 <a:solidFill>
-                  <a:srgbClr val="64748B"/>
+                  <a:srgbClr val="6E685C"/>
                 </a:solidFill>
                 <a:latin typeface="Calibri" pitchFamily="34" charset="0"/>
                 <a:ea typeface="Calibri" pitchFamily="34" charset="-122"/>
@@ -3489,7 +3489,7 @@
     <p:bg>
       <p:bgPr>
         <a:solidFill>
-          <a:srgbClr val="0B1220"/>
+          <a:srgbClr val="1B2632"/>
         </a:solidFill>
       </p:bgPr>
     </p:bg>
@@ -3534,7 +3534,7 @@
             <a:r>
               <a:rPr lang="en-US" sz="1300" b="1" spc="200" kern="0" dirty="0">
                 <a:solidFill>
-                  <a:srgbClr val="34D399"/>
+                  <a:srgbClr val="D98E74"/>
                 </a:solidFill>
                 <a:latin typeface="Calibri" pitchFamily="34" charset="0"/>
                 <a:ea typeface="Calibri" pitchFamily="34" charset="-122"/>
@@ -3602,11 +3602,11 @@
             </a:avLst>
           </a:prstGeom>
           <a:solidFill>
-            <a:srgbClr val="16233B"/>
+            <a:srgbClr val="26303B"/>
           </a:solidFill>
           <a:ln w="12700">
             <a:solidFill>
-              <a:srgbClr val="2563EB"/>
+              <a:srgbClr val="2C3B4D"/>
             </a:solidFill>
             <a:prstDash val="solid"/>
           </a:ln>
@@ -3639,7 +3639,7 @@
             <a:r>
               <a:rPr lang="en-US" sz="1900" b="1" dirty="0">
                 <a:solidFill>
-                  <a:srgbClr val="60A5FA"/>
+                  <a:srgbClr val="B7C2CD"/>
                 </a:solidFill>
                 <a:latin typeface="Cambria" pitchFamily="34" charset="0"/>
                 <a:ea typeface="Cambria" pitchFamily="34" charset="-122"/>
@@ -3681,7 +3681,7 @@
             <a:r>
               <a:rPr lang="en-US" sz="1500" dirty="0">
                 <a:solidFill>
-                  <a:srgbClr val="CBD5E1"/>
+                  <a:srgbClr val="AEB7BF"/>
                 </a:solidFill>
                 <a:latin typeface="Calibri" pitchFamily="34" charset="0"/>
                 <a:ea typeface="Calibri" pitchFamily="34" charset="-122"/>
@@ -3710,11 +3710,11 @@
             </a:avLst>
           </a:prstGeom>
           <a:solidFill>
-            <a:srgbClr val="16233B"/>
+            <a:srgbClr val="26303B"/>
           </a:solidFill>
           <a:ln w="12700">
             <a:solidFill>
-              <a:srgbClr val="2563EB"/>
+              <a:srgbClr val="2C3B4D"/>
             </a:solidFill>
             <a:prstDash val="solid"/>
           </a:ln>
@@ -3747,7 +3747,7 @@
             <a:r>
               <a:rPr lang="en-US" sz="1900" b="1" dirty="0">
                 <a:solidFill>
-                  <a:srgbClr val="60A5FA"/>
+                  <a:srgbClr val="B7C2CD"/>
                 </a:solidFill>
                 <a:latin typeface="Cambria" pitchFamily="34" charset="0"/>
                 <a:ea typeface="Cambria" pitchFamily="34" charset="-122"/>
@@ -3789,7 +3789,7 @@
             <a:r>
               <a:rPr lang="en-US" sz="1500" dirty="0">
                 <a:solidFill>
-                  <a:srgbClr val="CBD5E1"/>
+                  <a:srgbClr val="AEB7BF"/>
                 </a:solidFill>
                 <a:latin typeface="Calibri" pitchFamily="34" charset="0"/>
                 <a:ea typeface="Calibri" pitchFamily="34" charset="-122"/>
@@ -3818,11 +3818,11 @@
             </a:avLst>
           </a:prstGeom>
           <a:solidFill>
-            <a:srgbClr val="16233B"/>
+            <a:srgbClr val="26303B"/>
           </a:solidFill>
           <a:ln w="12700">
             <a:solidFill>
-              <a:srgbClr val="059669"/>
+              <a:srgbClr val="A35139"/>
             </a:solidFill>
             <a:prstDash val="solid"/>
           </a:ln>
@@ -3855,7 +3855,7 @@
             <a:r>
               <a:rPr lang="en-US" sz="1900" b="1" dirty="0">
                 <a:solidFill>
-                  <a:srgbClr val="34D399"/>
+                  <a:srgbClr val="D98E74"/>
                 </a:solidFill>
                 <a:latin typeface="Cambria" pitchFamily="34" charset="0"/>
                 <a:ea typeface="Cambria" pitchFamily="34" charset="-122"/>
@@ -3897,7 +3897,7 @@
             <a:r>
               <a:rPr lang="en-US" sz="1500" dirty="0">
                 <a:solidFill>
-                  <a:srgbClr val="CBD5E1"/>
+                  <a:srgbClr val="AEB7BF"/>
                 </a:solidFill>
                 <a:latin typeface="Calibri" pitchFamily="34" charset="0"/>
                 <a:ea typeface="Calibri" pitchFamily="34" charset="-122"/>
@@ -3968,7 +3968,7 @@
             <a:r>
               <a:rPr lang="en-US" sz="1300" b="1" spc="200" kern="0" dirty="0">
                 <a:solidFill>
-                  <a:srgbClr val="2563EB"/>
+                  <a:srgbClr val="2C3B4D"/>
                 </a:solidFill>
                 <a:latin typeface="Calibri" pitchFamily="34" charset="0"/>
                 <a:ea typeface="Calibri" pitchFamily="34" charset="-122"/>
@@ -4007,7 +4007,7 @@
             <a:r>
               <a:rPr lang="en-US" sz="3400" b="1" dirty="0">
                 <a:solidFill>
-                  <a:srgbClr val="0F172A"/>
+                  <a:srgbClr val="26303B"/>
                 </a:solidFill>
                 <a:latin typeface="Cambria" pitchFamily="34" charset="0"/>
                 <a:ea typeface="Cambria" pitchFamily="34" charset="-122"/>
@@ -4036,17 +4036,17 @@
             </a:avLst>
           </a:prstGeom>
           <a:solidFill>
-            <a:srgbClr val="EFF6FF"/>
+            <a:srgbClr val="EEF1F4"/>
           </a:solidFill>
           <a:ln w="12700">
             <a:solidFill>
-              <a:srgbClr val="EFF6FF"/>
+              <a:srgbClr val="EEF1F4"/>
             </a:solidFill>
             <a:prstDash val="solid"/>
           </a:ln>
           <a:effectLst>
             <a:outerShdw sx="100000" sy="100000" kx="0" ky="0" algn="bl" rotWithShape="0" blurRad="76200" dist="25400" dir="5400000">
-              <a:srgbClr val="0F172A">
+              <a:srgbClr val="26303B">
                 <a:alpha val="16000"/>
               </a:srgbClr>
             </a:outerShdw>
@@ -4080,7 +4080,7 @@
             <a:r>
               <a:rPr lang="en-US" sz="3600" b="1" dirty="0">
                 <a:solidFill>
-                  <a:srgbClr val="2563EB"/>
+                  <a:srgbClr val="2C3B4D"/>
                 </a:solidFill>
                 <a:latin typeface="Cambria" pitchFamily="34" charset="0"/>
                 <a:ea typeface="Cambria" pitchFamily="34" charset="-122"/>
@@ -4119,7 +4119,7 @@
             <a:r>
               <a:rPr lang="en-US" sz="1300" dirty="0">
                 <a:solidFill>
-                  <a:srgbClr val="64748B"/>
+                  <a:srgbClr val="6E685C"/>
                 </a:solidFill>
                 <a:latin typeface="Calibri" pitchFamily="34" charset="0"/>
                 <a:ea typeface="Calibri" pitchFamily="34" charset="-122"/>
@@ -4148,17 +4148,17 @@
             </a:avLst>
           </a:prstGeom>
           <a:solidFill>
-            <a:srgbClr val="ECFDF5"/>
+            <a:srgbClr val="FBF0EC"/>
           </a:solidFill>
           <a:ln w="12700">
             <a:solidFill>
-              <a:srgbClr val="ECFDF5"/>
+              <a:srgbClr val="FBF0EC"/>
             </a:solidFill>
             <a:prstDash val="solid"/>
           </a:ln>
           <a:effectLst>
             <a:outerShdw sx="100000" sy="100000" kx="0" ky="0" algn="bl" rotWithShape="0" blurRad="76200" dist="25400" dir="5400000">
-              <a:srgbClr val="0F172A">
+              <a:srgbClr val="26303B">
                 <a:alpha val="16000"/>
               </a:srgbClr>
             </a:outerShdw>
@@ -4192,7 +4192,7 @@
             <a:r>
               <a:rPr lang="en-US" sz="3600" b="1" dirty="0">
                 <a:solidFill>
-                  <a:srgbClr val="059669"/>
+                  <a:srgbClr val="A35139"/>
                 </a:solidFill>
                 <a:latin typeface="Cambria" pitchFamily="34" charset="0"/>
                 <a:ea typeface="Cambria" pitchFamily="34" charset="-122"/>
@@ -4231,7 +4231,7 @@
             <a:r>
               <a:rPr lang="en-US" sz="1300" dirty="0">
                 <a:solidFill>
-                  <a:srgbClr val="64748B"/>
+                  <a:srgbClr val="6E685C"/>
                 </a:solidFill>
                 <a:latin typeface="Calibri" pitchFamily="34" charset="0"/>
                 <a:ea typeface="Calibri" pitchFamily="34" charset="-122"/>
@@ -4260,17 +4260,17 @@
             </a:avLst>
           </a:prstGeom>
           <a:solidFill>
-            <a:srgbClr val="EFF6FF"/>
+            <a:srgbClr val="EEF1F4"/>
           </a:solidFill>
           <a:ln w="12700">
             <a:solidFill>
-              <a:srgbClr val="EFF6FF"/>
+              <a:srgbClr val="EEF1F4"/>
             </a:solidFill>
             <a:prstDash val="solid"/>
           </a:ln>
           <a:effectLst>
             <a:outerShdw sx="100000" sy="100000" kx="0" ky="0" algn="bl" rotWithShape="0" blurRad="76200" dist="25400" dir="5400000">
-              <a:srgbClr val="0F172A">
+              <a:srgbClr val="26303B">
                 <a:alpha val="16000"/>
               </a:srgbClr>
             </a:outerShdw>
@@ -4304,7 +4304,7 @@
             <a:r>
               <a:rPr lang="en-US" sz="3600" b="1" dirty="0">
                 <a:solidFill>
-                  <a:srgbClr val="2563EB"/>
+                  <a:srgbClr val="2C3B4D"/>
                 </a:solidFill>
                 <a:latin typeface="Cambria" pitchFamily="34" charset="0"/>
                 <a:ea typeface="Cambria" pitchFamily="34" charset="-122"/>
@@ -4343,7 +4343,7 @@
             <a:r>
               <a:rPr lang="en-US" sz="1300" dirty="0">
                 <a:solidFill>
-                  <a:srgbClr val="64748B"/>
+                  <a:srgbClr val="6E685C"/>
                 </a:solidFill>
                 <a:latin typeface="Calibri" pitchFamily="34" charset="0"/>
                 <a:ea typeface="Calibri" pitchFamily="34" charset="-122"/>
@@ -4372,17 +4372,17 @@
             </a:avLst>
           </a:prstGeom>
           <a:solidFill>
-            <a:srgbClr val="ECFDF5"/>
+            <a:srgbClr val="FBF0EC"/>
           </a:solidFill>
           <a:ln w="12700">
             <a:solidFill>
-              <a:srgbClr val="ECFDF5"/>
+              <a:srgbClr val="FBF0EC"/>
             </a:solidFill>
             <a:prstDash val="solid"/>
           </a:ln>
           <a:effectLst>
             <a:outerShdw sx="100000" sy="100000" kx="0" ky="0" algn="bl" rotWithShape="0" blurRad="76200" dist="25400" dir="5400000">
-              <a:srgbClr val="0F172A">
+              <a:srgbClr val="26303B">
                 <a:alpha val="16000"/>
               </a:srgbClr>
             </a:outerShdw>
@@ -4416,7 +4416,7 @@
             <a:r>
               <a:rPr lang="en-US" sz="3600" b="1" dirty="0">
                 <a:solidFill>
-                  <a:srgbClr val="059669"/>
+                  <a:srgbClr val="A35139"/>
                 </a:solidFill>
                 <a:latin typeface="Cambria" pitchFamily="34" charset="0"/>
                 <a:ea typeface="Cambria" pitchFamily="34" charset="-122"/>
@@ -4455,7 +4455,7 @@
             <a:r>
               <a:rPr lang="en-US" sz="1300" dirty="0">
                 <a:solidFill>
-                  <a:srgbClr val="64748B"/>
+                  <a:srgbClr val="6E685C"/>
                 </a:solidFill>
                 <a:latin typeface="Calibri" pitchFamily="34" charset="0"/>
                 <a:ea typeface="Calibri" pitchFamily="34" charset="-122"/>
@@ -4494,7 +4494,7 @@
             <a:r>
               <a:rPr lang="en-US" sz="1600" b="1" dirty="0">
                 <a:solidFill>
-                  <a:srgbClr val="0F172A"/>
+                  <a:srgbClr val="26303B"/>
                 </a:solidFill>
                 <a:latin typeface="Cambria" pitchFamily="34" charset="0"/>
                 <a:ea typeface="Cambria" pitchFamily="34" charset="-122"/>
@@ -4537,7 +4537,7 @@
             <a:r>
               <a:rPr lang="en-US" sz="1350" dirty="0">
                 <a:solidFill>
-                  <a:srgbClr val="64748B"/>
+                  <a:srgbClr val="6E685C"/>
                 </a:solidFill>
                 <a:latin typeface="Calibri" pitchFamily="34" charset="0"/>
                 <a:ea typeface="Calibri" pitchFamily="34" charset="-122"/>
@@ -4558,7 +4558,7 @@
             <a:r>
               <a:rPr lang="en-US" sz="1350" dirty="0">
                 <a:solidFill>
-                  <a:srgbClr val="64748B"/>
+                  <a:srgbClr val="6E685C"/>
                 </a:solidFill>
                 <a:latin typeface="Calibri" pitchFamily="34" charset="0"/>
                 <a:ea typeface="Calibri" pitchFamily="34" charset="-122"/>
@@ -4579,7 +4579,7 @@
             <a:r>
               <a:rPr lang="en-US" sz="1350" dirty="0">
                 <a:solidFill>
-                  <a:srgbClr val="64748B"/>
+                  <a:srgbClr val="6E685C"/>
                 </a:solidFill>
                 <a:latin typeface="Calibri" pitchFamily="34" charset="0"/>
                 <a:ea typeface="Calibri" pitchFamily="34" charset="-122"/>
@@ -4600,7 +4600,7 @@
             <a:r>
               <a:rPr lang="en-US" sz="1350" dirty="0">
                 <a:solidFill>
-                  <a:srgbClr val="64748B"/>
+                  <a:srgbClr val="6E685C"/>
                 </a:solidFill>
                 <a:latin typeface="Calibri" pitchFamily="34" charset="0"/>
                 <a:ea typeface="Calibri" pitchFamily="34" charset="-122"/>
@@ -4621,7 +4621,7 @@
             <a:r>
               <a:rPr lang="en-US" sz="1350" dirty="0">
                 <a:solidFill>
-                  <a:srgbClr val="64748B"/>
+                  <a:srgbClr val="6E685C"/>
                 </a:solidFill>
                 <a:latin typeface="Calibri" pitchFamily="34" charset="0"/>
                 <a:ea typeface="Calibri" pitchFamily="34" charset="-122"/>
@@ -4642,7 +4642,7 @@
             <a:r>
               <a:rPr lang="en-US" sz="1350" dirty="0">
                 <a:solidFill>
-                  <a:srgbClr val="64748B"/>
+                  <a:srgbClr val="6E685C"/>
                 </a:solidFill>
                 <a:latin typeface="Calibri" pitchFamily="34" charset="0"/>
                 <a:ea typeface="Calibri" pitchFamily="34" charset="-122"/>
@@ -4713,7 +4713,7 @@
             <a:r>
               <a:rPr lang="en-US" sz="1300" b="1" spc="200" kern="0" dirty="0">
                 <a:solidFill>
-                  <a:srgbClr val="2563EB"/>
+                  <a:srgbClr val="2C3B4D"/>
                 </a:solidFill>
                 <a:latin typeface="Calibri" pitchFamily="34" charset="0"/>
                 <a:ea typeface="Calibri" pitchFamily="34" charset="-122"/>
@@ -4752,7 +4752,7 @@
             <a:r>
               <a:rPr lang="en-US" sz="3400" b="1" dirty="0">
                 <a:solidFill>
-                  <a:srgbClr val="0F172A"/>
+                  <a:srgbClr val="26303B"/>
                 </a:solidFill>
                 <a:latin typeface="Cambria" pitchFamily="34" charset="0"/>
                 <a:ea typeface="Cambria" pitchFamily="34" charset="-122"/>
@@ -4785,13 +4785,13 @@
           </a:solidFill>
           <a:ln w="12700">
             <a:solidFill>
-              <a:srgbClr val="E5E7EB"/>
+              <a:srgbClr val="DAD3C6"/>
             </a:solidFill>
             <a:prstDash val="solid"/>
           </a:ln>
           <a:effectLst>
             <a:outerShdw sx="100000" sy="100000" kx="0" ky="0" algn="bl" rotWithShape="0" blurRad="76200" dist="25400" dir="5400000">
-              <a:srgbClr val="0F172A">
+              <a:srgbClr val="26303B">
                 <a:alpha val="16000"/>
               </a:srgbClr>
             </a:outerShdw>
@@ -4825,7 +4825,7 @@
             <a:r>
               <a:rPr lang="en-US" sz="2000" b="1" dirty="0">
                 <a:solidFill>
-                  <a:srgbClr val="2563EB"/>
+                  <a:srgbClr val="2C3B4D"/>
                 </a:solidFill>
                 <a:latin typeface="Cambria" pitchFamily="34" charset="0"/>
                 <a:ea typeface="Cambria" pitchFamily="34" charset="-122"/>
@@ -4867,7 +4867,7 @@
             <a:r>
               <a:rPr lang="en-US" sz="1500" dirty="0">
                 <a:solidFill>
-                  <a:srgbClr val="64748B"/>
+                  <a:srgbClr val="6E685C"/>
                 </a:solidFill>
                 <a:latin typeface="Calibri" pitchFamily="34" charset="0"/>
                 <a:ea typeface="Calibri" pitchFamily="34" charset="-122"/>
@@ -4896,17 +4896,17 @@
             </a:avLst>
           </a:prstGeom>
           <a:solidFill>
-            <a:srgbClr val="2563EB"/>
+            <a:srgbClr val="2C3B4D"/>
           </a:solidFill>
           <a:ln w="12700">
             <a:solidFill>
-              <a:srgbClr val="2563EB"/>
+              <a:srgbClr val="2C3B4D"/>
             </a:solidFill>
             <a:prstDash val="solid"/>
           </a:ln>
           <a:effectLst>
             <a:outerShdw sx="100000" sy="100000" kx="0" ky="0" algn="bl" rotWithShape="0" blurRad="76200" dist="25400" dir="5400000">
-              <a:srgbClr val="0F172A">
+              <a:srgbClr val="26303B">
                 <a:alpha val="16000"/>
               </a:srgbClr>
             </a:outerShdw>
@@ -4982,7 +4982,7 @@
             <a:r>
               <a:rPr lang="en-US" sz="1500" dirty="0">
                 <a:solidFill>
-                  <a:srgbClr val="CBD5E1"/>
+                  <a:srgbClr val="AEB7BF"/>
                 </a:solidFill>
                 <a:latin typeface="Calibri" pitchFamily="34" charset="0"/>
                 <a:ea typeface="Calibri" pitchFamily="34" charset="-122"/>
@@ -5015,13 +5015,13 @@
           </a:solidFill>
           <a:ln w="12700">
             <a:solidFill>
-              <a:srgbClr val="E5E7EB"/>
+              <a:srgbClr val="DAD3C6"/>
             </a:solidFill>
             <a:prstDash val="solid"/>
           </a:ln>
           <a:effectLst>
             <a:outerShdw sx="100000" sy="100000" kx="0" ky="0" algn="bl" rotWithShape="0" blurRad="76200" dist="25400" dir="5400000">
-              <a:srgbClr val="0F172A">
+              <a:srgbClr val="26303B">
                 <a:alpha val="16000"/>
               </a:srgbClr>
             </a:outerShdw>
@@ -5055,7 +5055,7 @@
             <a:r>
               <a:rPr lang="en-US" sz="2000" b="1" dirty="0">
                 <a:solidFill>
-                  <a:srgbClr val="2563EB"/>
+                  <a:srgbClr val="2C3B4D"/>
                 </a:solidFill>
                 <a:latin typeface="Cambria" pitchFamily="34" charset="0"/>
                 <a:ea typeface="Cambria" pitchFamily="34" charset="-122"/>
@@ -5097,7 +5097,7 @@
             <a:r>
               <a:rPr lang="en-US" sz="1500" dirty="0">
                 <a:solidFill>
-                  <a:srgbClr val="64748B"/>
+                  <a:srgbClr val="6E685C"/>
                 </a:solidFill>
                 <a:latin typeface="Calibri" pitchFamily="34" charset="0"/>
                 <a:ea typeface="Calibri" pitchFamily="34" charset="-122"/>
@@ -5123,7 +5123,7 @@
     <p:bg>
       <p:bgPr>
         <a:solidFill>
-          <a:srgbClr val="0B1220"/>
+          <a:srgbClr val="1B2632"/>
         </a:solidFill>
       </p:bgPr>
     </p:bg>
@@ -5156,11 +5156,11 @@
             <a:avLst/>
           </a:prstGeom>
           <a:solidFill>
-            <a:srgbClr val="0B1220"/>
+            <a:srgbClr val="1B2632"/>
           </a:solidFill>
           <a:ln w="38100">
             <a:solidFill>
-              <a:srgbClr val="60A5FA"/>
+              <a:srgbClr val="B7C2CD"/>
             </a:solidFill>
             <a:prstDash val="solid"/>
           </a:ln>
@@ -5181,11 +5181,11 @@
             <a:avLst/>
           </a:prstGeom>
           <a:solidFill>
-            <a:srgbClr val="0B1220"/>
+            <a:srgbClr val="1B2632"/>
           </a:solidFill>
           <a:ln w="38100">
             <a:solidFill>
-              <a:srgbClr val="34D399"/>
+              <a:srgbClr val="D98E74"/>
             </a:solidFill>
             <a:prstDash val="solid"/>
           </a:ln>
@@ -5280,7 +5280,7 @@
             <a:r>
               <a:rPr lang="en-US" sz="2000" dirty="0">
                 <a:solidFill>
-                  <a:srgbClr val="60A5FA"/>
+                  <a:srgbClr val="B7C2CD"/>
                 </a:solidFill>
                 <a:latin typeface="Calibri" pitchFamily="34" charset="0"/>
                 <a:ea typeface="Calibri" pitchFamily="34" charset="-122"/>
@@ -5390,7 +5390,7 @@
             <a:r>
               <a:rPr lang="en-US" sz="1300" b="1" spc="200" kern="0" dirty="0">
                 <a:solidFill>
-                  <a:srgbClr val="2563EB"/>
+                  <a:srgbClr val="2C3B4D"/>
                 </a:solidFill>
                 <a:latin typeface="Calibri" pitchFamily="34" charset="0"/>
                 <a:ea typeface="Calibri" pitchFamily="34" charset="-122"/>
@@ -5429,7 +5429,7 @@
             <a:r>
               <a:rPr lang="en-US" sz="3300" b="1" dirty="0">
                 <a:solidFill>
-                  <a:srgbClr val="0F172A"/>
+                  <a:srgbClr val="26303B"/>
                 </a:solidFill>
                 <a:latin typeface="Cambria" pitchFamily="34" charset="0"/>
                 <a:ea typeface="Cambria" pitchFamily="34" charset="-122"/>
@@ -5446,7 +5446,7 @@
             <a:r>
               <a:rPr lang="en-US" sz="3300" b="1" dirty="0">
                 <a:solidFill>
-                  <a:srgbClr val="0F172A"/>
+                  <a:srgbClr val="26303B"/>
                 </a:solidFill>
                 <a:latin typeface="Cambria" pitchFamily="34" charset="0"/>
                 <a:ea typeface="Cambria" pitchFamily="34" charset="-122"/>
@@ -5488,7 +5488,7 @@
             <a:r>
               <a:rPr lang="en-US" sz="1700" dirty="0">
                 <a:solidFill>
-                  <a:srgbClr val="64748B"/>
+                  <a:srgbClr val="6E685C"/>
                 </a:solidFill>
                 <a:latin typeface="Calibri" pitchFamily="34" charset="0"/>
                 <a:ea typeface="Calibri" pitchFamily="34" charset="-122"/>
@@ -5517,17 +5517,17 @@
             </a:avLst>
           </a:prstGeom>
           <a:solidFill>
-            <a:srgbClr val="EFF6FF"/>
+            <a:srgbClr val="EEF1F4"/>
           </a:solidFill>
           <a:ln w="12700">
             <a:solidFill>
-              <a:srgbClr val="EFF6FF"/>
+              <a:srgbClr val="EEF1F4"/>
             </a:solidFill>
             <a:prstDash val="solid"/>
           </a:ln>
           <a:effectLst>
             <a:outerShdw sx="100000" sy="100000" kx="0" ky="0" algn="bl" rotWithShape="0" blurRad="76200" dist="25400" dir="5400000">
-              <a:srgbClr val="0F172A">
+              <a:srgbClr val="26303B">
                 <a:alpha val="16000"/>
               </a:srgbClr>
             </a:outerShdw>
@@ -5561,7 +5561,7 @@
             <a:r>
               <a:rPr lang="en-US" sz="1800" b="1" dirty="0">
                 <a:solidFill>
-                  <a:srgbClr val="2563EB"/>
+                  <a:srgbClr val="2C3B4D"/>
                 </a:solidFill>
                 <a:latin typeface="Cambria" pitchFamily="34" charset="0"/>
                 <a:ea typeface="Cambria" pitchFamily="34" charset="-122"/>
@@ -5604,7 +5604,7 @@
             <a:r>
               <a:rPr lang="en-US" sz="1500" dirty="0">
                 <a:solidFill>
-                  <a:srgbClr val="0F172A"/>
+                  <a:srgbClr val="26303B"/>
                 </a:solidFill>
                 <a:latin typeface="Calibri" pitchFamily="34" charset="0"/>
                 <a:ea typeface="Calibri" pitchFamily="34" charset="-122"/>
@@ -5625,7 +5625,7 @@
             <a:r>
               <a:rPr lang="en-US" sz="1500" dirty="0">
                 <a:solidFill>
-                  <a:srgbClr val="0F172A"/>
+                  <a:srgbClr val="26303B"/>
                 </a:solidFill>
                 <a:latin typeface="Calibri" pitchFamily="34" charset="0"/>
                 <a:ea typeface="Calibri" pitchFamily="34" charset="-122"/>
@@ -5646,7 +5646,7 @@
             <a:r>
               <a:rPr lang="en-US" sz="1500" dirty="0">
                 <a:solidFill>
-                  <a:srgbClr val="0F172A"/>
+                  <a:srgbClr val="26303B"/>
                 </a:solidFill>
                 <a:latin typeface="Calibri" pitchFamily="34" charset="0"/>
                 <a:ea typeface="Calibri" pitchFamily="34" charset="-122"/>
@@ -5667,7 +5667,7 @@
             <a:r>
               <a:rPr lang="en-US" sz="1500" dirty="0">
                 <a:solidFill>
-                  <a:srgbClr val="0F172A"/>
+                  <a:srgbClr val="26303B"/>
                 </a:solidFill>
                 <a:latin typeface="Calibri" pitchFamily="34" charset="0"/>
                 <a:ea typeface="Calibri" pitchFamily="34" charset="-122"/>
@@ -5738,7 +5738,7 @@
             <a:r>
               <a:rPr lang="en-US" sz="1300" b="1" spc="200" kern="0" dirty="0">
                 <a:solidFill>
-                  <a:srgbClr val="2563EB"/>
+                  <a:srgbClr val="2C3B4D"/>
                 </a:solidFill>
                 <a:latin typeface="Calibri" pitchFamily="34" charset="0"/>
                 <a:ea typeface="Calibri" pitchFamily="34" charset="-122"/>
@@ -5777,7 +5777,7 @@
             <a:r>
               <a:rPr lang="en-US" sz="3400" b="1" dirty="0">
                 <a:solidFill>
-                  <a:srgbClr val="0F172A"/>
+                  <a:srgbClr val="26303B"/>
                 </a:solidFill>
                 <a:latin typeface="Cambria" pitchFamily="34" charset="0"/>
                 <a:ea typeface="Cambria" pitchFamily="34" charset="-122"/>
@@ -5810,13 +5810,13 @@
           </a:solidFill>
           <a:ln w="12700">
             <a:solidFill>
-              <a:srgbClr val="E5E7EB"/>
+              <a:srgbClr val="DAD3C6"/>
             </a:solidFill>
             <a:prstDash val="solid"/>
           </a:ln>
           <a:effectLst>
             <a:outerShdw sx="100000" sy="100000" kx="0" ky="0" algn="bl" rotWithShape="0" blurRad="76200" dist="25400" dir="5400000">
-              <a:srgbClr val="0F172A">
+              <a:srgbClr val="26303B">
                 <a:alpha val="16000"/>
               </a:srgbClr>
             </a:outerShdw>
@@ -5838,7 +5838,7 @@
             <a:avLst/>
           </a:prstGeom>
           <a:solidFill>
-            <a:srgbClr val="2563EB"/>
+            <a:srgbClr val="2C3B4D"/>
           </a:solidFill>
           <a:ln/>
         </p:spPr>
@@ -5909,7 +5909,7 @@
             <a:r>
               <a:rPr lang="en-US" sz="2000" b="1" dirty="0">
                 <a:solidFill>
-                  <a:srgbClr val="0F172A"/>
+                  <a:srgbClr val="26303B"/>
                 </a:solidFill>
                 <a:latin typeface="Cambria" pitchFamily="34" charset="0"/>
                 <a:ea typeface="Cambria" pitchFamily="34" charset="-122"/>
@@ -5951,7 +5951,7 @@
             <a:r>
               <a:rPr lang="en-US" sz="1500" dirty="0">
                 <a:solidFill>
-                  <a:srgbClr val="64748B"/>
+                  <a:srgbClr val="6E685C"/>
                 </a:solidFill>
                 <a:latin typeface="Calibri" pitchFamily="34" charset="0"/>
                 <a:ea typeface="Calibri" pitchFamily="34" charset="-122"/>
@@ -5984,13 +5984,13 @@
           </a:solidFill>
           <a:ln w="12700">
             <a:solidFill>
-              <a:srgbClr val="E5E7EB"/>
+              <a:srgbClr val="DAD3C6"/>
             </a:solidFill>
             <a:prstDash val="solid"/>
           </a:ln>
           <a:effectLst>
             <a:outerShdw sx="100000" sy="100000" kx="0" ky="0" algn="bl" rotWithShape="0" blurRad="76200" dist="25400" dir="5400000">
-              <a:srgbClr val="0F172A">
+              <a:srgbClr val="26303B">
                 <a:alpha val="16000"/>
               </a:srgbClr>
             </a:outerShdw>
@@ -6012,7 +6012,7 @@
             <a:avLst/>
           </a:prstGeom>
           <a:solidFill>
-            <a:srgbClr val="0F172A"/>
+            <a:srgbClr val="26303B"/>
           </a:solidFill>
           <a:ln/>
         </p:spPr>
@@ -6083,7 +6083,7 @@
             <a:r>
               <a:rPr lang="en-US" sz="2000" b="1" dirty="0">
                 <a:solidFill>
-                  <a:srgbClr val="0F172A"/>
+                  <a:srgbClr val="26303B"/>
                 </a:solidFill>
                 <a:latin typeface="Cambria" pitchFamily="34" charset="0"/>
                 <a:ea typeface="Cambria" pitchFamily="34" charset="-122"/>
@@ -6125,7 +6125,7 @@
             <a:r>
               <a:rPr lang="en-US" sz="1500" dirty="0">
                 <a:solidFill>
-                  <a:srgbClr val="64748B"/>
+                  <a:srgbClr val="6E685C"/>
                 </a:solidFill>
                 <a:latin typeface="Calibri" pitchFamily="34" charset="0"/>
                 <a:ea typeface="Calibri" pitchFamily="34" charset="-122"/>
@@ -6158,13 +6158,13 @@
           </a:solidFill>
           <a:ln w="12700">
             <a:solidFill>
-              <a:srgbClr val="E5E7EB"/>
+              <a:srgbClr val="DAD3C6"/>
             </a:solidFill>
             <a:prstDash val="solid"/>
           </a:ln>
           <a:effectLst>
             <a:outerShdw sx="100000" sy="100000" kx="0" ky="0" algn="bl" rotWithShape="0" blurRad="76200" dist="25400" dir="5400000">
-              <a:srgbClr val="0F172A">
+              <a:srgbClr val="26303B">
                 <a:alpha val="16000"/>
               </a:srgbClr>
             </a:outerShdw>
@@ -6186,7 +6186,7 @@
             <a:avLst/>
           </a:prstGeom>
           <a:solidFill>
-            <a:srgbClr val="059669"/>
+            <a:srgbClr val="A35139"/>
           </a:solidFill>
           <a:ln/>
         </p:spPr>
@@ -6257,7 +6257,7 @@
             <a:r>
               <a:rPr lang="en-US" sz="2000" b="1" dirty="0">
                 <a:solidFill>
-                  <a:srgbClr val="0F172A"/>
+                  <a:srgbClr val="26303B"/>
                 </a:solidFill>
                 <a:latin typeface="Cambria" pitchFamily="34" charset="0"/>
                 <a:ea typeface="Cambria" pitchFamily="34" charset="-122"/>
@@ -6299,7 +6299,7 @@
             <a:r>
               <a:rPr lang="en-US" sz="1500" dirty="0">
                 <a:solidFill>
-                  <a:srgbClr val="64748B"/>
+                  <a:srgbClr val="6E685C"/>
                 </a:solidFill>
                 <a:latin typeface="Calibri" pitchFamily="34" charset="0"/>
                 <a:ea typeface="Calibri" pitchFamily="34" charset="-122"/>
@@ -6370,7 +6370,7 @@
             <a:r>
               <a:rPr lang="en-US" sz="1300" b="1" spc="200" kern="0" dirty="0">
                 <a:solidFill>
-                  <a:srgbClr val="2563EB"/>
+                  <a:srgbClr val="2C3B4D"/>
                 </a:solidFill>
                 <a:latin typeface="Calibri" pitchFamily="34" charset="0"/>
                 <a:ea typeface="Calibri" pitchFamily="34" charset="-122"/>
@@ -6409,7 +6409,7 @@
             <a:r>
               <a:rPr lang="en-US" sz="3400" b="1" dirty="0">
                 <a:solidFill>
-                  <a:srgbClr val="0F172A"/>
+                  <a:srgbClr val="26303B"/>
                 </a:solidFill>
                 <a:latin typeface="Cambria" pitchFamily="34" charset="0"/>
                 <a:ea typeface="Cambria" pitchFamily="34" charset="-122"/>
@@ -6438,17 +6438,17 @@
             </a:avLst>
           </a:prstGeom>
           <a:solidFill>
-            <a:srgbClr val="EFF6FF"/>
+            <a:srgbClr val="EEF1F4"/>
           </a:solidFill>
           <a:ln w="12700">
             <a:solidFill>
-              <a:srgbClr val="EFF6FF"/>
+              <a:srgbClr val="EEF1F4"/>
             </a:solidFill>
             <a:prstDash val="solid"/>
           </a:ln>
           <a:effectLst>
             <a:outerShdw sx="100000" sy="100000" kx="0" ky="0" algn="bl" rotWithShape="0" blurRad="76200" dist="25400" dir="5400000">
-              <a:srgbClr val="0F172A">
+              <a:srgbClr val="26303B">
                 <a:alpha val="16000"/>
               </a:srgbClr>
             </a:outerShdw>
@@ -6472,7 +6472,7 @@
             </a:avLst>
           </a:prstGeom>
           <a:solidFill>
-            <a:srgbClr val="2563EB"/>
+            <a:srgbClr val="2C3B4D"/>
           </a:solidFill>
           <a:ln/>
         </p:spPr>
@@ -6547,7 +6547,7 @@
             <a:r>
               <a:rPr lang="en-US" sz="1350" dirty="0">
                 <a:solidFill>
-                  <a:srgbClr val="0F172A"/>
+                  <a:srgbClr val="26303B"/>
                 </a:solidFill>
                 <a:latin typeface="Calibri" pitchFamily="34" charset="0"/>
                 <a:ea typeface="Calibri" pitchFamily="34" charset="-122"/>
@@ -6568,7 +6568,7 @@
             <a:r>
               <a:rPr lang="en-US" sz="1350" dirty="0">
                 <a:solidFill>
-                  <a:srgbClr val="0F172A"/>
+                  <a:srgbClr val="26303B"/>
                 </a:solidFill>
                 <a:latin typeface="Calibri" pitchFamily="34" charset="0"/>
                 <a:ea typeface="Calibri" pitchFamily="34" charset="-122"/>
@@ -6589,7 +6589,7 @@
             <a:r>
               <a:rPr lang="en-US" sz="1350" dirty="0">
                 <a:solidFill>
-                  <a:srgbClr val="0F172A"/>
+                  <a:srgbClr val="26303B"/>
                 </a:solidFill>
                 <a:latin typeface="Calibri" pitchFamily="34" charset="0"/>
                 <a:ea typeface="Calibri" pitchFamily="34" charset="-122"/>
@@ -6610,7 +6610,7 @@
             <a:r>
               <a:rPr lang="en-US" sz="1350" dirty="0">
                 <a:solidFill>
-                  <a:srgbClr val="0F172A"/>
+                  <a:srgbClr val="26303B"/>
                 </a:solidFill>
                 <a:latin typeface="Calibri" pitchFamily="34" charset="0"/>
                 <a:ea typeface="Calibri" pitchFamily="34" charset="-122"/>
@@ -6631,7 +6631,7 @@
             <a:r>
               <a:rPr lang="en-US" sz="1350" dirty="0">
                 <a:solidFill>
-                  <a:srgbClr val="0F172A"/>
+                  <a:srgbClr val="26303B"/>
                 </a:solidFill>
                 <a:latin typeface="Calibri" pitchFamily="34" charset="0"/>
                 <a:ea typeface="Calibri" pitchFamily="34" charset="-122"/>
@@ -6652,7 +6652,7 @@
             <a:r>
               <a:rPr lang="en-US" sz="1350" dirty="0">
                 <a:solidFill>
-                  <a:srgbClr val="0F172A"/>
+                  <a:srgbClr val="26303B"/>
                 </a:solidFill>
                 <a:latin typeface="Calibri" pitchFamily="34" charset="0"/>
                 <a:ea typeface="Calibri" pitchFamily="34" charset="-122"/>
@@ -6673,7 +6673,7 @@
             <a:r>
               <a:rPr lang="en-US" sz="1350" dirty="0">
                 <a:solidFill>
-                  <a:srgbClr val="0F172A"/>
+                  <a:srgbClr val="26303B"/>
                 </a:solidFill>
                 <a:latin typeface="Calibri" pitchFamily="34" charset="0"/>
                 <a:ea typeface="Calibri" pitchFamily="34" charset="-122"/>
@@ -6706,7 +6706,7 @@
           </a:solidFill>
           <a:ln w="19050">
             <a:solidFill>
-              <a:srgbClr val="D97706"/>
+              <a:srgbClr val="E07E2A"/>
             </a:solidFill>
             <a:prstDash val="solid"/>
           </a:ln>
@@ -6739,7 +6739,7 @@
             <a:r>
               <a:rPr lang="en-US" sz="2200" b="1" dirty="0">
                 <a:solidFill>
-                  <a:srgbClr val="D97706"/>
+                  <a:srgbClr val="E07E2A"/>
                 </a:solidFill>
                 <a:latin typeface="Calibri" pitchFamily="34" charset="0"/>
                 <a:ea typeface="Calibri" pitchFamily="34" charset="-122"/>
@@ -6768,17 +6768,17 @@
             </a:avLst>
           </a:prstGeom>
           <a:solidFill>
-            <a:srgbClr val="ECFDF5"/>
+            <a:srgbClr val="FBF0EC"/>
           </a:solidFill>
           <a:ln w="12700">
             <a:solidFill>
-              <a:srgbClr val="ECFDF5"/>
+              <a:srgbClr val="FBF0EC"/>
             </a:solidFill>
             <a:prstDash val="solid"/>
           </a:ln>
           <a:effectLst>
             <a:outerShdw sx="100000" sy="100000" kx="0" ky="0" algn="bl" rotWithShape="0" blurRad="76200" dist="25400" dir="5400000">
-              <a:srgbClr val="0F172A">
+              <a:srgbClr val="26303B">
                 <a:alpha val="16000"/>
               </a:srgbClr>
             </a:outerShdw>
@@ -6802,7 +6802,7 @@
             </a:avLst>
           </a:prstGeom>
           <a:solidFill>
-            <a:srgbClr val="059669"/>
+            <a:srgbClr val="A35139"/>
           </a:solidFill>
           <a:ln/>
         </p:spPr>
@@ -6877,7 +6877,7 @@
             <a:r>
               <a:rPr lang="en-US" sz="1350" dirty="0">
                 <a:solidFill>
-                  <a:srgbClr val="0F172A"/>
+                  <a:srgbClr val="26303B"/>
                 </a:solidFill>
                 <a:latin typeface="Calibri" pitchFamily="34" charset="0"/>
                 <a:ea typeface="Calibri" pitchFamily="34" charset="-122"/>
@@ -6898,7 +6898,7 @@
             <a:r>
               <a:rPr lang="en-US" sz="1350" dirty="0">
                 <a:solidFill>
-                  <a:srgbClr val="0F172A"/>
+                  <a:srgbClr val="26303B"/>
                 </a:solidFill>
                 <a:latin typeface="Calibri" pitchFamily="34" charset="0"/>
                 <a:ea typeface="Calibri" pitchFamily="34" charset="-122"/>
@@ -6919,7 +6919,7 @@
             <a:r>
               <a:rPr lang="en-US" sz="1350" dirty="0">
                 <a:solidFill>
-                  <a:srgbClr val="0F172A"/>
+                  <a:srgbClr val="26303B"/>
                 </a:solidFill>
                 <a:latin typeface="Calibri" pitchFamily="34" charset="0"/>
                 <a:ea typeface="Calibri" pitchFamily="34" charset="-122"/>
@@ -6940,7 +6940,7 @@
             <a:r>
               <a:rPr lang="en-US" sz="1350" dirty="0">
                 <a:solidFill>
-                  <a:srgbClr val="0F172A"/>
+                  <a:srgbClr val="26303B"/>
                 </a:solidFill>
                 <a:latin typeface="Calibri" pitchFamily="34" charset="0"/>
                 <a:ea typeface="Calibri" pitchFamily="34" charset="-122"/>
@@ -6961,7 +6961,7 @@
             <a:r>
               <a:rPr lang="en-US" sz="1350" dirty="0">
                 <a:solidFill>
-                  <a:srgbClr val="0F172A"/>
+                  <a:srgbClr val="26303B"/>
                 </a:solidFill>
                 <a:latin typeface="Calibri" pitchFamily="34" charset="0"/>
                 <a:ea typeface="Calibri" pitchFamily="34" charset="-122"/>
@@ -6982,7 +6982,7 @@
             <a:r>
               <a:rPr lang="en-US" sz="1350" dirty="0">
                 <a:solidFill>
-                  <a:srgbClr val="0F172A"/>
+                  <a:srgbClr val="26303B"/>
                 </a:solidFill>
                 <a:latin typeface="Calibri" pitchFamily="34" charset="0"/>
                 <a:ea typeface="Calibri" pitchFamily="34" charset="-122"/>
@@ -7003,7 +7003,7 @@
             <a:r>
               <a:rPr lang="en-US" sz="1350" dirty="0">
                 <a:solidFill>
-                  <a:srgbClr val="0F172A"/>
+                  <a:srgbClr val="26303B"/>
                 </a:solidFill>
                 <a:latin typeface="Calibri" pitchFamily="34" charset="0"/>
                 <a:ea typeface="Calibri" pitchFamily="34" charset="-122"/>
@@ -7042,7 +7042,7 @@
             <a:r>
               <a:rPr lang="en-US" sz="1300" i="1" dirty="0">
                 <a:solidFill>
-                  <a:srgbClr val="64748B"/>
+                  <a:srgbClr val="6E685C"/>
                 </a:solidFill>
                 <a:latin typeface="Calibri" pitchFamily="34" charset="0"/>
                 <a:ea typeface="Calibri" pitchFamily="34" charset="-122"/>
@@ -7113,7 +7113,7 @@
             <a:r>
               <a:rPr lang="en-US" sz="1300" b="1" spc="200" kern="0" dirty="0">
                 <a:solidFill>
-                  <a:srgbClr val="2563EB"/>
+                  <a:srgbClr val="2C3B4D"/>
                 </a:solidFill>
                 <a:latin typeface="Calibri" pitchFamily="34" charset="0"/>
                 <a:ea typeface="Calibri" pitchFamily="34" charset="-122"/>
@@ -7152,7 +7152,7 @@
             <a:r>
               <a:rPr lang="en-US" sz="3400" b="1" dirty="0">
                 <a:solidFill>
-                  <a:srgbClr val="0F172A"/>
+                  <a:srgbClr val="26303B"/>
                 </a:solidFill>
                 <a:latin typeface="Cambria" pitchFamily="34" charset="0"/>
                 <a:ea typeface="Cambria" pitchFamily="34" charset="-122"/>
@@ -7185,13 +7185,13 @@
           </a:solidFill>
           <a:ln w="12700">
             <a:solidFill>
-              <a:srgbClr val="E5E7EB"/>
+              <a:srgbClr val="DAD3C6"/>
             </a:solidFill>
             <a:prstDash val="solid"/>
           </a:ln>
           <a:effectLst>
             <a:outerShdw sx="100000" sy="100000" kx="0" ky="0" algn="bl" rotWithShape="0" blurRad="76200" dist="25400" dir="5400000">
-              <a:srgbClr val="0F172A">
+              <a:srgbClr val="26303B">
                 <a:alpha val="16000"/>
               </a:srgbClr>
             </a:outerShdw>
@@ -7225,7 +7225,7 @@
             <a:r>
               <a:rPr lang="en-US" sz="1550" b="1" dirty="0">
                 <a:solidFill>
-                  <a:srgbClr val="2563EB"/>
+                  <a:srgbClr val="2C3B4D"/>
                 </a:solidFill>
                 <a:latin typeface="Cambria" pitchFamily="34" charset="0"/>
                 <a:ea typeface="Cambria" pitchFamily="34" charset="-122"/>
@@ -7267,7 +7267,7 @@
             <a:r>
               <a:rPr lang="en-US" sz="1250" dirty="0">
                 <a:solidFill>
-                  <a:srgbClr val="64748B"/>
+                  <a:srgbClr val="6E685C"/>
                 </a:solidFill>
                 <a:latin typeface="Calibri" pitchFamily="34" charset="0"/>
                 <a:ea typeface="Calibri" pitchFamily="34" charset="-122"/>
@@ -7296,17 +7296,17 @@
             </a:avLst>
           </a:prstGeom>
           <a:solidFill>
-            <a:srgbClr val="EFF6FF"/>
+            <a:srgbClr val="EEF1F4"/>
           </a:solidFill>
           <a:ln w="12700">
             <a:solidFill>
-              <a:srgbClr val="EFF6FF"/>
+              <a:srgbClr val="EEF1F4"/>
             </a:solidFill>
             <a:prstDash val="solid"/>
           </a:ln>
           <a:effectLst>
             <a:outerShdw sx="100000" sy="100000" kx="0" ky="0" algn="bl" rotWithShape="0" blurRad="76200" dist="25400" dir="5400000">
-              <a:srgbClr val="0F172A">
+              <a:srgbClr val="26303B">
                 <a:alpha val="16000"/>
               </a:srgbClr>
             </a:outerShdw>
@@ -7340,7 +7340,7 @@
             <a:r>
               <a:rPr lang="en-US" sz="1550" b="1" dirty="0">
                 <a:solidFill>
-                  <a:srgbClr val="2563EB"/>
+                  <a:srgbClr val="2C3B4D"/>
                 </a:solidFill>
                 <a:latin typeface="Cambria" pitchFamily="34" charset="0"/>
                 <a:ea typeface="Cambria" pitchFamily="34" charset="-122"/>
@@ -7382,7 +7382,7 @@
             <a:r>
               <a:rPr lang="en-US" sz="1250" dirty="0">
                 <a:solidFill>
-                  <a:srgbClr val="64748B"/>
+                  <a:srgbClr val="6E685C"/>
                 </a:solidFill>
                 <a:latin typeface="Calibri" pitchFamily="34" charset="0"/>
                 <a:ea typeface="Calibri" pitchFamily="34" charset="-122"/>
@@ -7415,13 +7415,13 @@
           </a:solidFill>
           <a:ln w="12700">
             <a:solidFill>
-              <a:srgbClr val="E5E7EB"/>
+              <a:srgbClr val="DAD3C6"/>
             </a:solidFill>
             <a:prstDash val="solid"/>
           </a:ln>
           <a:effectLst>
             <a:outerShdw sx="100000" sy="100000" kx="0" ky="0" algn="bl" rotWithShape="0" blurRad="76200" dist="25400" dir="5400000">
-              <a:srgbClr val="0F172A">
+              <a:srgbClr val="26303B">
                 <a:alpha val="16000"/>
               </a:srgbClr>
             </a:outerShdw>
@@ -7455,7 +7455,7 @@
             <a:r>
               <a:rPr lang="en-US" sz="1550" b="1" dirty="0">
                 <a:solidFill>
-                  <a:srgbClr val="2563EB"/>
+                  <a:srgbClr val="2C3B4D"/>
                 </a:solidFill>
                 <a:latin typeface="Cambria" pitchFamily="34" charset="0"/>
                 <a:ea typeface="Cambria" pitchFamily="34" charset="-122"/>
@@ -7497,7 +7497,7 @@
             <a:r>
               <a:rPr lang="en-US" sz="1250" dirty="0">
                 <a:solidFill>
-                  <a:srgbClr val="64748B"/>
+                  <a:srgbClr val="6E685C"/>
                 </a:solidFill>
                 <a:latin typeface="Calibri" pitchFamily="34" charset="0"/>
                 <a:ea typeface="Calibri" pitchFamily="34" charset="-122"/>
@@ -7526,17 +7526,17 @@
             </a:avLst>
           </a:prstGeom>
           <a:solidFill>
-            <a:srgbClr val="EFF6FF"/>
+            <a:srgbClr val="EEF1F4"/>
           </a:solidFill>
           <a:ln w="12700">
             <a:solidFill>
-              <a:srgbClr val="EFF6FF"/>
+              <a:srgbClr val="EEF1F4"/>
             </a:solidFill>
             <a:prstDash val="solid"/>
           </a:ln>
           <a:effectLst>
             <a:outerShdw sx="100000" sy="100000" kx="0" ky="0" algn="bl" rotWithShape="0" blurRad="76200" dist="25400" dir="5400000">
-              <a:srgbClr val="0F172A">
+              <a:srgbClr val="26303B">
                 <a:alpha val="16000"/>
               </a:srgbClr>
             </a:outerShdw>
@@ -7570,7 +7570,7 @@
             <a:r>
               <a:rPr lang="en-US" sz="1550" b="1" dirty="0">
                 <a:solidFill>
-                  <a:srgbClr val="2563EB"/>
+                  <a:srgbClr val="2C3B4D"/>
                 </a:solidFill>
                 <a:latin typeface="Cambria" pitchFamily="34" charset="0"/>
                 <a:ea typeface="Cambria" pitchFamily="34" charset="-122"/>
@@ -7612,7 +7612,7 @@
             <a:r>
               <a:rPr lang="en-US" sz="1250" dirty="0">
                 <a:solidFill>
-                  <a:srgbClr val="64748B"/>
+                  <a:srgbClr val="6E685C"/>
                 </a:solidFill>
                 <a:latin typeface="Calibri" pitchFamily="34" charset="0"/>
                 <a:ea typeface="Calibri" pitchFamily="34" charset="-122"/>
@@ -7645,13 +7645,13 @@
           </a:solidFill>
           <a:ln w="12700">
             <a:solidFill>
-              <a:srgbClr val="E5E7EB"/>
+              <a:srgbClr val="DAD3C6"/>
             </a:solidFill>
             <a:prstDash val="solid"/>
           </a:ln>
           <a:effectLst>
             <a:outerShdw sx="100000" sy="100000" kx="0" ky="0" algn="bl" rotWithShape="0" blurRad="76200" dist="25400" dir="5400000">
-              <a:srgbClr val="0F172A">
+              <a:srgbClr val="26303B">
                 <a:alpha val="16000"/>
               </a:srgbClr>
             </a:outerShdw>
@@ -7685,7 +7685,7 @@
             <a:r>
               <a:rPr lang="en-US" sz="1550" b="1" dirty="0">
                 <a:solidFill>
-                  <a:srgbClr val="2563EB"/>
+                  <a:srgbClr val="2C3B4D"/>
                 </a:solidFill>
                 <a:latin typeface="Cambria" pitchFamily="34" charset="0"/>
                 <a:ea typeface="Cambria" pitchFamily="34" charset="-122"/>
@@ -7727,7 +7727,7 @@
             <a:r>
               <a:rPr lang="en-US" sz="1250" dirty="0">
                 <a:solidFill>
-                  <a:srgbClr val="64748B"/>
+                  <a:srgbClr val="6E685C"/>
                 </a:solidFill>
                 <a:latin typeface="Calibri" pitchFamily="34" charset="0"/>
                 <a:ea typeface="Calibri" pitchFamily="34" charset="-122"/>
@@ -7756,17 +7756,17 @@
             </a:avLst>
           </a:prstGeom>
           <a:solidFill>
-            <a:srgbClr val="EFF6FF"/>
+            <a:srgbClr val="EEF1F4"/>
           </a:solidFill>
           <a:ln w="12700">
             <a:solidFill>
-              <a:srgbClr val="EFF6FF"/>
+              <a:srgbClr val="EEF1F4"/>
             </a:solidFill>
             <a:prstDash val="solid"/>
           </a:ln>
           <a:effectLst>
             <a:outerShdw sx="100000" sy="100000" kx="0" ky="0" algn="bl" rotWithShape="0" blurRad="76200" dist="25400" dir="5400000">
-              <a:srgbClr val="0F172A">
+              <a:srgbClr val="26303B">
                 <a:alpha val="16000"/>
               </a:srgbClr>
             </a:outerShdw>
@@ -7800,7 +7800,7 @@
             <a:r>
               <a:rPr lang="en-US" sz="1550" b="1" dirty="0">
                 <a:solidFill>
-                  <a:srgbClr val="2563EB"/>
+                  <a:srgbClr val="2C3B4D"/>
                 </a:solidFill>
                 <a:latin typeface="Cambria" pitchFamily="34" charset="0"/>
                 <a:ea typeface="Cambria" pitchFamily="34" charset="-122"/>
@@ -7842,7 +7842,7 @@
             <a:r>
               <a:rPr lang="en-US" sz="1250" dirty="0">
                 <a:solidFill>
-                  <a:srgbClr val="64748B"/>
+                  <a:srgbClr val="6E685C"/>
                 </a:solidFill>
                 <a:latin typeface="Calibri" pitchFamily="34" charset="0"/>
                 <a:ea typeface="Calibri" pitchFamily="34" charset="-122"/>
@@ -7913,7 +7913,7 @@
             <a:r>
               <a:rPr lang="en-US" sz="1300" b="1" spc="200" kern="0" dirty="0">
                 <a:solidFill>
-                  <a:srgbClr val="2563EB"/>
+                  <a:srgbClr val="2C3B4D"/>
                 </a:solidFill>
                 <a:latin typeface="Calibri" pitchFamily="34" charset="0"/>
                 <a:ea typeface="Calibri" pitchFamily="34" charset="-122"/>
@@ -7952,7 +7952,7 @@
             <a:r>
               <a:rPr lang="en-US" sz="3400" b="1" dirty="0">
                 <a:solidFill>
-                  <a:srgbClr val="0F172A"/>
+                  <a:srgbClr val="26303B"/>
                 </a:solidFill>
                 <a:latin typeface="Cambria" pitchFamily="34" charset="0"/>
                 <a:ea typeface="Cambria" pitchFamily="34" charset="-122"/>
@@ -7994,7 +7994,7 @@
             <a:r>
               <a:rPr lang="en-US" sz="1700" dirty="0">
                 <a:solidFill>
-                  <a:srgbClr val="64748B"/>
+                  <a:srgbClr val="6E685C"/>
                 </a:solidFill>
                 <a:latin typeface="Calibri" pitchFamily="34" charset="0"/>
                 <a:ea typeface="Calibri" pitchFamily="34" charset="-122"/>
@@ -8037,7 +8037,7 @@
             <a:r>
               <a:rPr lang="en-US" sz="1500" b="1" dirty="0">
                 <a:solidFill>
-                  <a:srgbClr val="0F172A"/>
+                  <a:srgbClr val="26303B"/>
                 </a:solidFill>
                 <a:latin typeface="Calibri" pitchFamily="34" charset="0"/>
                 <a:ea typeface="Calibri" pitchFamily="34" charset="-122"/>
@@ -8058,7 +8058,7 @@
             <a:r>
               <a:rPr lang="en-US" sz="1500" b="1" dirty="0">
                 <a:solidFill>
-                  <a:srgbClr val="0F172A"/>
+                  <a:srgbClr val="26303B"/>
                 </a:solidFill>
                 <a:latin typeface="Calibri" pitchFamily="34" charset="0"/>
                 <a:ea typeface="Calibri" pitchFamily="34" charset="-122"/>
@@ -8079,7 +8079,7 @@
             <a:r>
               <a:rPr lang="en-US" sz="1500" b="1" dirty="0">
                 <a:solidFill>
-                  <a:srgbClr val="0F172A"/>
+                  <a:srgbClr val="26303B"/>
                 </a:solidFill>
                 <a:latin typeface="Calibri" pitchFamily="34" charset="0"/>
                 <a:ea typeface="Calibri" pitchFamily="34" charset="-122"/>
@@ -8100,7 +8100,7 @@
             <a:r>
               <a:rPr lang="en-US" sz="1500" b="1" dirty="0">
                 <a:solidFill>
-                  <a:srgbClr val="0F172A"/>
+                  <a:srgbClr val="26303B"/>
                 </a:solidFill>
                 <a:latin typeface="Calibri" pitchFamily="34" charset="0"/>
                 <a:ea typeface="Calibri" pitchFamily="34" charset="-122"/>
@@ -8121,7 +8121,7 @@
             <a:r>
               <a:rPr lang="en-US" sz="1500" b="1" dirty="0">
                 <a:solidFill>
-                  <a:srgbClr val="0F172A"/>
+                  <a:srgbClr val="26303B"/>
                 </a:solidFill>
                 <a:latin typeface="Calibri" pitchFamily="34" charset="0"/>
                 <a:ea typeface="Calibri" pitchFamily="34" charset="-122"/>
@@ -8150,17 +8150,17 @@
             </a:avLst>
           </a:prstGeom>
           <a:solidFill>
-            <a:srgbClr val="EFF6FF"/>
+            <a:srgbClr val="EEF1F4"/>
           </a:solidFill>
           <a:ln w="12700">
             <a:solidFill>
-              <a:srgbClr val="EFF6FF"/>
+              <a:srgbClr val="EEF1F4"/>
             </a:solidFill>
             <a:prstDash val="solid"/>
           </a:ln>
           <a:effectLst>
             <a:outerShdw sx="100000" sy="100000" kx="0" ky="0" algn="bl" rotWithShape="0" blurRad="76200" dist="25400" dir="5400000">
-              <a:srgbClr val="0F172A">
+              <a:srgbClr val="26303B">
                 <a:alpha val="16000"/>
               </a:srgbClr>
             </a:outerShdw>
@@ -8194,7 +8194,7 @@
             <a:r>
               <a:rPr lang="en-US" sz="1700" b="1" dirty="0">
                 <a:solidFill>
-                  <a:srgbClr val="2563EB"/>
+                  <a:srgbClr val="2C3B4D"/>
                 </a:solidFill>
                 <a:latin typeface="Cambria" pitchFamily="34" charset="0"/>
                 <a:ea typeface="Cambria" pitchFamily="34" charset="-122"/>
@@ -8236,7 +8236,7 @@
             <a:r>
               <a:rPr lang="en-US" sz="1400" dirty="0">
                 <a:solidFill>
-                  <a:srgbClr val="0F172A"/>
+                  <a:srgbClr val="26303B"/>
                 </a:solidFill>
                 <a:latin typeface="Calibri" pitchFamily="34" charset="0"/>
                 <a:ea typeface="Calibri" pitchFamily="34" charset="-122"/>
@@ -8265,17 +8265,17 @@
             </a:avLst>
           </a:prstGeom>
           <a:solidFill>
-            <a:srgbClr val="0B1220"/>
+            <a:srgbClr val="1B2632"/>
           </a:solidFill>
           <a:ln w="12700">
             <a:solidFill>
-              <a:srgbClr val="0B1220"/>
+              <a:srgbClr val="1B2632"/>
             </a:solidFill>
             <a:prstDash val="solid"/>
           </a:ln>
           <a:effectLst>
             <a:outerShdw sx="100000" sy="100000" kx="0" ky="0" algn="bl" rotWithShape="0" blurRad="76200" dist="25400" dir="5400000">
-              <a:srgbClr val="0F172A">
+              <a:srgbClr val="26303B">
                 <a:alpha val="16000"/>
               </a:srgbClr>
             </a:outerShdw>
@@ -8309,7 +8309,7 @@
             <a:r>
               <a:rPr lang="en-US" sz="4000" b="1" dirty="0">
                 <a:solidFill>
-                  <a:srgbClr val="34D399"/>
+                  <a:srgbClr val="D98E74"/>
                 </a:solidFill>
                 <a:latin typeface="Cambria" pitchFamily="34" charset="0"/>
                 <a:ea typeface="Cambria" pitchFamily="34" charset="-122"/>
@@ -8391,7 +8391,7 @@
     <p:bg>
       <p:bgPr>
         <a:solidFill>
-          <a:srgbClr val="0B1220"/>
+          <a:srgbClr val="1B2632"/>
         </a:solidFill>
       </p:bgPr>
     </p:bg>
@@ -8436,7 +8436,7 @@
             <a:r>
               <a:rPr lang="en-US" sz="1300" b="1" spc="200" kern="0" dirty="0">
                 <a:solidFill>
-                  <a:srgbClr val="60A5FA"/>
+                  <a:srgbClr val="B7C2CD"/>
                 </a:solidFill>
                 <a:latin typeface="Calibri" pitchFamily="34" charset="0"/>
                 <a:ea typeface="Calibri" pitchFamily="34" charset="-122"/>
@@ -8517,7 +8517,7 @@
             <a:r>
               <a:rPr lang="en-US" sz="1700" dirty="0">
                 <a:solidFill>
-                  <a:srgbClr val="CBD5E1"/>
+                  <a:srgbClr val="AEB7BF"/>
                 </a:solidFill>
                 <a:latin typeface="Calibri" pitchFamily="34" charset="0"/>
                 <a:ea typeface="Calibri" pitchFamily="34" charset="-122"/>
@@ -8546,11 +8546,11 @@
             </a:avLst>
           </a:prstGeom>
           <a:solidFill>
-            <a:srgbClr val="16233B"/>
+            <a:srgbClr val="26303B"/>
           </a:solidFill>
           <a:ln w="12700">
             <a:solidFill>
-              <a:srgbClr val="2563EB"/>
+              <a:srgbClr val="2C3B4D"/>
             </a:solidFill>
             <a:prstDash val="solid"/>
           </a:ln>
@@ -8583,7 +8583,7 @@
             <a:r>
               <a:rPr lang="en-US" sz="1700" b="1" dirty="0">
                 <a:solidFill>
-                  <a:srgbClr val="60A5FA"/>
+                  <a:srgbClr val="B7C2CD"/>
                 </a:solidFill>
                 <a:latin typeface="Cambria" pitchFamily="34" charset="0"/>
                 <a:ea typeface="Cambria" pitchFamily="34" charset="-122"/>
@@ -8625,7 +8625,7 @@
             <a:r>
               <a:rPr lang="en-US" sz="1350" dirty="0">
                 <a:solidFill>
-                  <a:srgbClr val="CBD5E1"/>
+                  <a:srgbClr val="AEB7BF"/>
                 </a:solidFill>
                 <a:latin typeface="Calibri" pitchFamily="34" charset="0"/>
                 <a:ea typeface="Calibri" pitchFamily="34" charset="-122"/>
@@ -8654,11 +8654,11 @@
             </a:avLst>
           </a:prstGeom>
           <a:solidFill>
-            <a:srgbClr val="16233B"/>
+            <a:srgbClr val="26303B"/>
           </a:solidFill>
           <a:ln w="12700">
             <a:solidFill>
-              <a:srgbClr val="2563EB"/>
+              <a:srgbClr val="2C3B4D"/>
             </a:solidFill>
             <a:prstDash val="solid"/>
           </a:ln>
@@ -8691,7 +8691,7 @@
             <a:r>
               <a:rPr lang="en-US" sz="1700" b="1" dirty="0">
                 <a:solidFill>
-                  <a:srgbClr val="60A5FA"/>
+                  <a:srgbClr val="B7C2CD"/>
                 </a:solidFill>
                 <a:latin typeface="Cambria" pitchFamily="34" charset="0"/>
                 <a:ea typeface="Cambria" pitchFamily="34" charset="-122"/>
@@ -8733,7 +8733,7 @@
             <a:r>
               <a:rPr lang="en-US" sz="1350" dirty="0">
                 <a:solidFill>
-                  <a:srgbClr val="CBD5E1"/>
+                  <a:srgbClr val="AEB7BF"/>
                 </a:solidFill>
                 <a:latin typeface="Calibri" pitchFamily="34" charset="0"/>
                 <a:ea typeface="Calibri" pitchFamily="34" charset="-122"/>
@@ -8762,11 +8762,11 @@
             </a:avLst>
           </a:prstGeom>
           <a:solidFill>
-            <a:srgbClr val="16233B"/>
+            <a:srgbClr val="26303B"/>
           </a:solidFill>
           <a:ln w="12700">
             <a:solidFill>
-              <a:srgbClr val="2563EB"/>
+              <a:srgbClr val="2C3B4D"/>
             </a:solidFill>
             <a:prstDash val="solid"/>
           </a:ln>
@@ -8799,7 +8799,7 @@
             <a:r>
               <a:rPr lang="en-US" sz="1700" b="1" dirty="0">
                 <a:solidFill>
-                  <a:srgbClr val="60A5FA"/>
+                  <a:srgbClr val="B7C2CD"/>
                 </a:solidFill>
                 <a:latin typeface="Cambria" pitchFamily="34" charset="0"/>
                 <a:ea typeface="Cambria" pitchFamily="34" charset="-122"/>
@@ -8841,7 +8841,7 @@
             <a:r>
               <a:rPr lang="en-US" sz="1350" dirty="0">
                 <a:solidFill>
-                  <a:srgbClr val="CBD5E1"/>
+                  <a:srgbClr val="AEB7BF"/>
                 </a:solidFill>
                 <a:latin typeface="Calibri" pitchFamily="34" charset="0"/>
                 <a:ea typeface="Calibri" pitchFamily="34" charset="-122"/>
@@ -8870,11 +8870,11 @@
             </a:avLst>
           </a:prstGeom>
           <a:solidFill>
-            <a:srgbClr val="16233B"/>
+            <a:srgbClr val="26303B"/>
           </a:solidFill>
           <a:ln w="12700">
             <a:solidFill>
-              <a:srgbClr val="059669"/>
+              <a:srgbClr val="A35139"/>
             </a:solidFill>
             <a:prstDash val="solid"/>
           </a:ln>
@@ -8907,7 +8907,7 @@
             <a:r>
               <a:rPr lang="en-US" sz="1700" b="1" dirty="0">
                 <a:solidFill>
-                  <a:srgbClr val="34D399"/>
+                  <a:srgbClr val="D98E74"/>
                 </a:solidFill>
                 <a:latin typeface="Cambria" pitchFamily="34" charset="0"/>
                 <a:ea typeface="Cambria" pitchFamily="34" charset="-122"/>
@@ -8949,7 +8949,7 @@
             <a:r>
               <a:rPr lang="en-US" sz="1350" dirty="0">
                 <a:solidFill>
-                  <a:srgbClr val="CBD5E1"/>
+                  <a:srgbClr val="AEB7BF"/>
                 </a:solidFill>
                 <a:latin typeface="Calibri" pitchFamily="34" charset="0"/>
                 <a:ea typeface="Calibri" pitchFamily="34" charset="-122"/>
@@ -9020,7 +9020,7 @@
             <a:r>
               <a:rPr lang="en-US" sz="1300" b="1" spc="200" kern="0" dirty="0">
                 <a:solidFill>
-                  <a:srgbClr val="059669"/>
+                  <a:srgbClr val="A35139"/>
                 </a:solidFill>
                 <a:latin typeface="Calibri" pitchFamily="34" charset="0"/>
                 <a:ea typeface="Calibri" pitchFamily="34" charset="-122"/>
@@ -9059,7 +9059,7 @@
             <a:r>
               <a:rPr lang="en-US" sz="3400" b="1" dirty="0">
                 <a:solidFill>
-                  <a:srgbClr val="0F172A"/>
+                  <a:srgbClr val="26303B"/>
                 </a:solidFill>
                 <a:latin typeface="Cambria" pitchFamily="34" charset="0"/>
                 <a:ea typeface="Cambria" pitchFamily="34" charset="-122"/>
@@ -9088,17 +9088,17 @@
             </a:avLst>
           </a:prstGeom>
           <a:solidFill>
-            <a:srgbClr val="ECFDF5"/>
+            <a:srgbClr val="FBF0EC"/>
           </a:solidFill>
           <a:ln w="12700">
             <a:solidFill>
-              <a:srgbClr val="ECFDF5"/>
+              <a:srgbClr val="FBF0EC"/>
             </a:solidFill>
             <a:prstDash val="solid"/>
           </a:ln>
           <a:effectLst>
             <a:outerShdw sx="100000" sy="100000" kx="0" ky="0" algn="bl" rotWithShape="0" blurRad="76200" dist="25400" dir="5400000">
-              <a:srgbClr val="0F172A">
+              <a:srgbClr val="26303B">
                 <a:alpha val="16000"/>
               </a:srgbClr>
             </a:outerShdw>
@@ -9132,7 +9132,7 @@
             <a:r>
               <a:rPr lang="en-US" sz="1550" b="1" dirty="0">
                 <a:solidFill>
-                  <a:srgbClr val="059669"/>
+                  <a:srgbClr val="A35139"/>
                 </a:solidFill>
                 <a:latin typeface="Cambria" pitchFamily="34" charset="0"/>
                 <a:ea typeface="Cambria" pitchFamily="34" charset="-122"/>
@@ -9174,7 +9174,7 @@
             <a:r>
               <a:rPr lang="en-US" sz="1250" dirty="0">
                 <a:solidFill>
-                  <a:srgbClr val="64748B"/>
+                  <a:srgbClr val="6E685C"/>
                 </a:solidFill>
                 <a:latin typeface="Calibri" pitchFamily="34" charset="0"/>
                 <a:ea typeface="Calibri" pitchFamily="34" charset="-122"/>
@@ -9207,13 +9207,13 @@
           </a:solidFill>
           <a:ln w="12700">
             <a:solidFill>
-              <a:srgbClr val="E5E7EB"/>
+              <a:srgbClr val="DAD3C6"/>
             </a:solidFill>
             <a:prstDash val="solid"/>
           </a:ln>
           <a:effectLst>
             <a:outerShdw sx="100000" sy="100000" kx="0" ky="0" algn="bl" rotWithShape="0" blurRad="76200" dist="25400" dir="5400000">
-              <a:srgbClr val="0F172A">
+              <a:srgbClr val="26303B">
                 <a:alpha val="16000"/>
               </a:srgbClr>
             </a:outerShdw>
@@ -9247,7 +9247,7 @@
             <a:r>
               <a:rPr lang="en-US" sz="1550" b="1" dirty="0">
                 <a:solidFill>
-                  <a:srgbClr val="059669"/>
+                  <a:srgbClr val="A35139"/>
                 </a:solidFill>
                 <a:latin typeface="Cambria" pitchFamily="34" charset="0"/>
                 <a:ea typeface="Cambria" pitchFamily="34" charset="-122"/>
@@ -9289,7 +9289,7 @@
             <a:r>
               <a:rPr lang="en-US" sz="1250" dirty="0">
                 <a:solidFill>
-                  <a:srgbClr val="64748B"/>
+                  <a:srgbClr val="6E685C"/>
                 </a:solidFill>
                 <a:latin typeface="Calibri" pitchFamily="34" charset="0"/>
                 <a:ea typeface="Calibri" pitchFamily="34" charset="-122"/>
@@ -9318,17 +9318,17 @@
             </a:avLst>
           </a:prstGeom>
           <a:solidFill>
-            <a:srgbClr val="ECFDF5"/>
+            <a:srgbClr val="FBF0EC"/>
           </a:solidFill>
           <a:ln w="12700">
             <a:solidFill>
-              <a:srgbClr val="ECFDF5"/>
+              <a:srgbClr val="FBF0EC"/>
             </a:solidFill>
             <a:prstDash val="solid"/>
           </a:ln>
           <a:effectLst>
             <a:outerShdw sx="100000" sy="100000" kx="0" ky="0" algn="bl" rotWithShape="0" blurRad="76200" dist="25400" dir="5400000">
-              <a:srgbClr val="0F172A">
+              <a:srgbClr val="26303B">
                 <a:alpha val="16000"/>
               </a:srgbClr>
             </a:outerShdw>
@@ -9362,7 +9362,7 @@
             <a:r>
               <a:rPr lang="en-US" sz="1550" b="1" dirty="0">
                 <a:solidFill>
-                  <a:srgbClr val="059669"/>
+                  <a:srgbClr val="A35139"/>
                 </a:solidFill>
                 <a:latin typeface="Cambria" pitchFamily="34" charset="0"/>
                 <a:ea typeface="Cambria" pitchFamily="34" charset="-122"/>
@@ -9404,7 +9404,7 @@
             <a:r>
               <a:rPr lang="en-US" sz="1250" dirty="0">
                 <a:solidFill>
-                  <a:srgbClr val="64748B"/>
+                  <a:srgbClr val="6E685C"/>
                 </a:solidFill>
                 <a:latin typeface="Calibri" pitchFamily="34" charset="0"/>
                 <a:ea typeface="Calibri" pitchFamily="34" charset="-122"/>
@@ -9437,13 +9437,13 @@
           </a:solidFill>
           <a:ln w="12700">
             <a:solidFill>
-              <a:srgbClr val="E5E7EB"/>
+              <a:srgbClr val="DAD3C6"/>
             </a:solidFill>
             <a:prstDash val="solid"/>
           </a:ln>
           <a:effectLst>
             <a:outerShdw sx="100000" sy="100000" kx="0" ky="0" algn="bl" rotWithShape="0" blurRad="76200" dist="25400" dir="5400000">
-              <a:srgbClr val="0F172A">
+              <a:srgbClr val="26303B">
                 <a:alpha val="16000"/>
               </a:srgbClr>
             </a:outerShdw>
@@ -9477,7 +9477,7 @@
             <a:r>
               <a:rPr lang="en-US" sz="1550" b="1" dirty="0">
                 <a:solidFill>
-                  <a:srgbClr val="059669"/>
+                  <a:srgbClr val="A35139"/>
                 </a:solidFill>
                 <a:latin typeface="Cambria" pitchFamily="34" charset="0"/>
                 <a:ea typeface="Cambria" pitchFamily="34" charset="-122"/>
@@ -9519,7 +9519,7 @@
             <a:r>
               <a:rPr lang="en-US" sz="1250" dirty="0">
                 <a:solidFill>
-                  <a:srgbClr val="64748B"/>
+                  <a:srgbClr val="6E685C"/>
                 </a:solidFill>
                 <a:latin typeface="Calibri" pitchFamily="34" charset="0"/>
                 <a:ea typeface="Calibri" pitchFamily="34" charset="-122"/>
@@ -9548,17 +9548,17 @@
             </a:avLst>
           </a:prstGeom>
           <a:solidFill>
-            <a:srgbClr val="ECFDF5"/>
+            <a:srgbClr val="FBF0EC"/>
           </a:solidFill>
           <a:ln w="12700">
             <a:solidFill>
-              <a:srgbClr val="ECFDF5"/>
+              <a:srgbClr val="FBF0EC"/>
             </a:solidFill>
             <a:prstDash val="solid"/>
           </a:ln>
           <a:effectLst>
             <a:outerShdw sx="100000" sy="100000" kx="0" ky="0" algn="bl" rotWithShape="0" blurRad="76200" dist="25400" dir="5400000">
-              <a:srgbClr val="0F172A">
+              <a:srgbClr val="26303B">
                 <a:alpha val="16000"/>
               </a:srgbClr>
             </a:outerShdw>
@@ -9592,7 +9592,7 @@
             <a:r>
               <a:rPr lang="en-US" sz="1550" b="1" dirty="0">
                 <a:solidFill>
-                  <a:srgbClr val="059669"/>
+                  <a:srgbClr val="A35139"/>
                 </a:solidFill>
                 <a:latin typeface="Cambria" pitchFamily="34" charset="0"/>
                 <a:ea typeface="Cambria" pitchFamily="34" charset="-122"/>
@@ -9634,7 +9634,7 @@
             <a:r>
               <a:rPr lang="en-US" sz="1250" dirty="0">
                 <a:solidFill>
-                  <a:srgbClr val="64748B"/>
+                  <a:srgbClr val="6E685C"/>
                 </a:solidFill>
                 <a:latin typeface="Calibri" pitchFamily="34" charset="0"/>
                 <a:ea typeface="Calibri" pitchFamily="34" charset="-122"/>
@@ -9667,13 +9667,13 @@
           </a:solidFill>
           <a:ln w="12700">
             <a:solidFill>
-              <a:srgbClr val="E5E7EB"/>
+              <a:srgbClr val="DAD3C6"/>
             </a:solidFill>
             <a:prstDash val="solid"/>
           </a:ln>
           <a:effectLst>
             <a:outerShdw sx="100000" sy="100000" kx="0" ky="0" algn="bl" rotWithShape="0" blurRad="76200" dist="25400" dir="5400000">
-              <a:srgbClr val="0F172A">
+              <a:srgbClr val="26303B">
                 <a:alpha val="16000"/>
               </a:srgbClr>
             </a:outerShdw>
@@ -9707,7 +9707,7 @@
             <a:r>
               <a:rPr lang="en-US" sz="1550" b="1" dirty="0">
                 <a:solidFill>
-                  <a:srgbClr val="059669"/>
+                  <a:srgbClr val="A35139"/>
                 </a:solidFill>
                 <a:latin typeface="Cambria" pitchFamily="34" charset="0"/>
                 <a:ea typeface="Cambria" pitchFamily="34" charset="-122"/>
@@ -9749,7 +9749,7 @@
             <a:r>
               <a:rPr lang="en-US" sz="1250" dirty="0">
                 <a:solidFill>
-                  <a:srgbClr val="64748B"/>
+                  <a:srgbClr val="6E685C"/>
                 </a:solidFill>
                 <a:latin typeface="Calibri" pitchFamily="34" charset="0"/>
                 <a:ea typeface="Calibri" pitchFamily="34" charset="-122"/>
@@ -9820,7 +9820,7 @@
             <a:r>
               <a:rPr lang="en-US" sz="1300" b="1" spc="200" kern="0" dirty="0">
                 <a:solidFill>
-                  <a:srgbClr val="2563EB"/>
+                  <a:srgbClr val="2C3B4D"/>
                 </a:solidFill>
                 <a:latin typeface="Calibri" pitchFamily="34" charset="0"/>
                 <a:ea typeface="Calibri" pitchFamily="34" charset="-122"/>
@@ -9859,7 +9859,7 @@
             <a:r>
               <a:rPr lang="en-US" sz="3400" b="1" dirty="0">
                 <a:solidFill>
-                  <a:srgbClr val="0F172A"/>
+                  <a:srgbClr val="26303B"/>
                 </a:solidFill>
                 <a:latin typeface="Cambria" pitchFamily="34" charset="0"/>
                 <a:ea typeface="Cambria" pitchFamily="34" charset="-122"/>
@@ -9901,7 +9901,7 @@
             <a:r>
               <a:rPr lang="en-US" sz="1700" dirty="0">
                 <a:solidFill>
-                  <a:srgbClr val="64748B"/>
+                  <a:srgbClr val="6E685C"/>
                 </a:solidFill>
                 <a:latin typeface="Calibri" pitchFamily="34" charset="0"/>
                 <a:ea typeface="Calibri" pitchFamily="34" charset="-122"/>
@@ -9930,17 +9930,17 @@
             </a:avLst>
           </a:prstGeom>
           <a:solidFill>
-            <a:srgbClr val="EFF6FF"/>
+            <a:srgbClr val="EEF1F4"/>
           </a:solidFill>
           <a:ln w="12700">
             <a:solidFill>
-              <a:srgbClr val="EFF6FF"/>
+              <a:srgbClr val="EEF1F4"/>
             </a:solidFill>
             <a:prstDash val="solid"/>
           </a:ln>
           <a:effectLst>
             <a:outerShdw sx="100000" sy="100000" kx="0" ky="0" algn="bl" rotWithShape="0" blurRad="76200" dist="25400" dir="5400000">
-              <a:srgbClr val="0F172A">
+              <a:srgbClr val="26303B">
                 <a:alpha val="16000"/>
               </a:srgbClr>
             </a:outerShdw>
@@ -9974,7 +9974,7 @@
             <a:r>
               <a:rPr lang="en-US" sz="1300" b="1" dirty="0">
                 <a:solidFill>
-                  <a:srgbClr val="2563EB"/>
+                  <a:srgbClr val="2C3B4D"/>
                 </a:solidFill>
                 <a:latin typeface="Calibri" pitchFamily="34" charset="0"/>
                 <a:ea typeface="Calibri" pitchFamily="34" charset="-122"/>
@@ -10013,7 +10013,7 @@
             <a:r>
               <a:rPr lang="en-US" sz="4000" b="1" dirty="0">
                 <a:solidFill>
-                  <a:srgbClr val="2563EB"/>
+                  <a:srgbClr val="2C3B4D"/>
                 </a:solidFill>
                 <a:latin typeface="Cambria" pitchFamily="34" charset="0"/>
                 <a:ea typeface="Cambria" pitchFamily="34" charset="-122"/>
@@ -10052,7 +10052,7 @@
             <a:r>
               <a:rPr lang="en-US" sz="1100" dirty="0">
                 <a:solidFill>
-                  <a:srgbClr val="64748B"/>
+                  <a:srgbClr val="6E685C"/>
                 </a:solidFill>
                 <a:latin typeface="Calibri" pitchFamily="34" charset="0"/>
                 <a:ea typeface="Calibri" pitchFamily="34" charset="-122"/>
@@ -10081,17 +10081,17 @@
             </a:avLst>
           </a:prstGeom>
           <a:solidFill>
-            <a:srgbClr val="ECFDF5"/>
+            <a:srgbClr val="FBF0EC"/>
           </a:solidFill>
           <a:ln w="12700">
             <a:solidFill>
-              <a:srgbClr val="ECFDF5"/>
+              <a:srgbClr val="FBF0EC"/>
             </a:solidFill>
             <a:prstDash val="solid"/>
           </a:ln>
           <a:effectLst>
             <a:outerShdw sx="100000" sy="100000" kx="0" ky="0" algn="bl" rotWithShape="0" blurRad="76200" dist="25400" dir="5400000">
-              <a:srgbClr val="0F172A">
+              <a:srgbClr val="26303B">
                 <a:alpha val="16000"/>
               </a:srgbClr>
             </a:outerShdw>
@@ -10125,7 +10125,7 @@
             <a:r>
               <a:rPr lang="en-US" sz="1300" b="1" dirty="0">
                 <a:solidFill>
-                  <a:srgbClr val="059669"/>
+                  <a:srgbClr val="A35139"/>
                 </a:solidFill>
                 <a:latin typeface="Calibri" pitchFamily="34" charset="0"/>
                 <a:ea typeface="Calibri" pitchFamily="34" charset="-122"/>
@@ -10164,7 +10164,7 @@
             <a:r>
               <a:rPr lang="en-US" sz="4000" b="1" dirty="0">
                 <a:solidFill>
-                  <a:srgbClr val="059669"/>
+                  <a:srgbClr val="A35139"/>
                 </a:solidFill>
                 <a:latin typeface="Cambria" pitchFamily="34" charset="0"/>
                 <a:ea typeface="Cambria" pitchFamily="34" charset="-122"/>
@@ -10203,7 +10203,7 @@
             <a:r>
               <a:rPr lang="en-US" sz="1100" dirty="0">
                 <a:solidFill>
-                  <a:srgbClr val="64748B"/>
+                  <a:srgbClr val="6E685C"/>
                 </a:solidFill>
                 <a:latin typeface="Calibri" pitchFamily="34" charset="0"/>
                 <a:ea typeface="Calibri" pitchFamily="34" charset="-122"/>
@@ -10232,17 +10232,17 @@
             </a:avLst>
           </a:prstGeom>
           <a:solidFill>
-            <a:srgbClr val="0B1220"/>
+            <a:srgbClr val="1B2632"/>
           </a:solidFill>
           <a:ln w="12700">
             <a:solidFill>
-              <a:srgbClr val="0B1220"/>
+              <a:srgbClr val="1B2632"/>
             </a:solidFill>
             <a:prstDash val="solid"/>
           </a:ln>
           <a:effectLst>
             <a:outerShdw sx="100000" sy="100000" kx="0" ky="0" algn="bl" rotWithShape="0" blurRad="76200" dist="25400" dir="5400000">
-              <a:srgbClr val="0F172A">
+              <a:srgbClr val="26303B">
                 <a:alpha val="16000"/>
               </a:srgbClr>
             </a:outerShdw>
@@ -10315,7 +10315,7 @@
             <a:r>
               <a:rPr lang="en-US" sz="1350" dirty="0">
                 <a:solidFill>
-                  <a:srgbClr val="CBD5E1"/>
+                  <a:srgbClr val="AEB7BF"/>
                 </a:solidFill>
                 <a:latin typeface="Calibri" pitchFamily="34" charset="0"/>
                 <a:ea typeface="Calibri" pitchFamily="34" charset="-122"/>

</xml_diff>

<commit_message>
demo-kit: reconcile industry framing with the seed's solution profiles
Sweep the leftover generic-vertical framing (construction / manufacturing /
SaaS 'industries') to match the app's actual four solution profiles —
Workload Automation, Mainframe Optimization, Service & Operations, Software
Reseller — and the Industry->Solution rename. Also fixes a stale 'defaults
to ZAR' (now USD) in the User Guide.

Touched: User Guide (.md/.docx/.pdf), Design Document (.md + hardcoded
build-design-docx.js, regenerated .docx), Solution-Overview deck
(build-deck.js, regenerated .pptx/.pdf), and the industry-config diagram
(make-diagrams.js, regenerated PNG/SVG). Wording kept vendor-neutral.

Co-Authored-By: Claude Opus 4.8 <noreply@anthropic.com>
</commit_message>
<xml_diff>
--- a/demo-kit/ValueLifecycle-Solution-Overview.pptx
+++ b/demo-kit/ValueLifecycle-Solution-Overview.pptx
@@ -3085,7 +3085,7 @@
                 <a:ea typeface="Cambria" pitchFamily="34" charset="-122"/>
                 <a:cs typeface="Cambria" pitchFamily="34" charset="-120"/>
               </a:rPr>
-              <a:t>Three industries out of the box — configuration, not code.</a:t>
+              <a:t>Solution profiles out of the box — configuration, not code.</a:t>
             </a:r>
             <a:endParaRPr lang="en-US" sz="3400" dirty="0"/>
           </a:p>
@@ -3158,7 +3158,7 @@
                 <a:ea typeface="Cambria" pitchFamily="34" charset="-122"/>
                 <a:cs typeface="Cambria" pitchFamily="34" charset="-120"/>
               </a:rPr>
-              <a:t>Construction &amp; Infrastructure</a:t>
+              <a:t>Workload Automation</a:t>
             </a:r>
             <a:endParaRPr lang="en-US" sz="1700" dirty="0"/>
           </a:p>
@@ -3200,7 +3200,7 @@
                 <a:ea typeface="Calibri" pitchFamily="34" charset="-122"/>
                 <a:cs typeface="Calibri" pitchFamily="34" charset="-120"/>
               </a:rPr>
-              <a:t>Capital projects, life-cycle cost, buildability — value engineering's home turf.</a:t>
+              <a:t>Job orchestration, SLA management and scheduler consolidation — reliability and licence take-out.</a:t>
             </a:r>
             <a:endParaRPr lang="en-US" sz="1450" dirty="0"/>
           </a:p>
@@ -3273,7 +3273,7 @@
                 <a:ea typeface="Cambria" pitchFamily="34" charset="-122"/>
                 <a:cs typeface="Cambria" pitchFamily="34" charset="-120"/>
               </a:rPr>
-              <a:t>Manufacturing &amp; Product Dev</a:t>
+              <a:t>Service &amp; Operations</a:t>
             </a:r>
             <a:endParaRPr lang="en-US" sz="1700" dirty="0"/>
           </a:p>
@@ -3315,7 +3315,7 @@
                 <a:ea typeface="Calibri" pitchFamily="34" charset="-122"/>
                 <a:cs typeface="Calibri" pitchFamily="34" charset="-120"/>
               </a:rPr>
-              <a:t>Should-cost, DFMA, tooling and unit-cost levers across a product line.</a:t>
+              <a:t>ITSM, AIOps and self-service — MTTR, deflection and tool consolidation.</a:t>
             </a:r>
             <a:endParaRPr lang="en-US" sz="1450" dirty="0"/>
           </a:p>
@@ -3388,7 +3388,7 @@
                 <a:ea typeface="Cambria" pitchFamily="34" charset="-122"/>
                 <a:cs typeface="Cambria" pitchFamily="34" charset="-120"/>
               </a:rPr>
-              <a:t>Enterprise Software / SaaS</a:t>
+              <a:t>Mainframe Optimization</a:t>
             </a:r>
             <a:endParaRPr lang="en-US" sz="1700" dirty="0"/>
           </a:p>
@@ -3430,7 +3430,7 @@
                 <a:ea typeface="Calibri" pitchFamily="34" charset="-122"/>
                 <a:cs typeface="Calibri" pitchFamily="34" charset="-120"/>
               </a:rPr>
-              <a:t>Adoption, cost-to-serve and efficiency benefits for digital initiatives.</a:t>
+              <a:t>Cost-per-workload, throughput and resilience across the mainframe estate.</a:t>
             </a:r>
             <a:endParaRPr lang="en-US" sz="1450" dirty="0"/>
           </a:p>

</xml_diff>